<commit_message>
Frame commission slider table per 10 scoped leads
Slide 3 of the pay plan now shows the batch view: at each close-rate
tier, how many of 10 scoped leads actually close and collect (the only
ones the fee is paid on), the $0 fee on the rest, net per closed job,
and a new T^Rock total-net row ($9,900 at the floor to $37,500 at the
ceiling) - making clear the top fee tier only exists when all 10 fund.

Co-Authored-By: Claude Fable 5 <noreply@anthropic.com>
Claude-Session: https://claude.ai/code/session_01Qj1b2D7LVH4xves4mfA9FY
</commit_message>
<xml_diff>
--- a/pitch/Commission-Plan.pptx
+++ b/pitch/Commission-Plan.pptx
@@ -2797,7 +2797,7 @@
           </p:nvPr>
         </p:nvGraphicFramePr>
         <p:xfrm>
-          <a:off x="548640" y="1828800"/>
+          <a:off x="548640" y="1783080"/>
           <a:ext cx="11064240" cy="914400"/>
         </p:xfrm>
         <a:graphic>
@@ -2812,7 +2812,7 @@
                 <a:gridCol w="1463040"/>
                 <a:gridCol w="1737360"/>
               </a:tblGrid>
-              <a:tr h="411480">
+              <a:tr h="365760">
                 <a:tc>
                   <a:txBody>
                     <a:bodyPr/>
@@ -2821,6 +2821,17 @@
                       <a:pPr algn="ctr" indent="0" marL="0">
                         <a:buNone/>
                       </a:pPr>
+                      <a:r>
+                        <a:rPr lang="en-US" sz="1300" b="1" dirty="0">
+                          <a:solidFill>
+                            <a:srgbClr val="FFFFFF"/>
+                          </a:solidFill>
+                          <a:latin typeface="Arial" pitchFamily="34" charset="0"/>
+                          <a:ea typeface="Arial" pitchFamily="34" charset="-122"/>
+                          <a:cs typeface="Arial" pitchFamily="34" charset="-120"/>
+                        </a:rPr>
+                        <a:t>Per 10 scoped leads</a:t>
+                      </a:r>
                       <a:endParaRPr lang="en-US" sz="1300" dirty="0">
                         <a:latin typeface="Arial" charset="0"/>
                         <a:ea typeface="Arial" charset="0"/>
@@ -2828,7 +2839,7 @@
                       </a:endParaRPr>
                     </a:p>
                   </a:txBody>
-                  <a:tcPr marL="73152" marR="73152" marT="73152" marB="73152" anchor="ctr">
+                  <a:tcPr marL="64008" marR="64008" marT="64008" marB="64008" anchor="ctr">
                     <a:lnL w="9525" cap="flat" cmpd="sng" algn="ctr">
                       <a:solidFill>
                         <a:srgbClr val="DDDDDD"/>
@@ -2896,7 +2907,7 @@
                       </a:endParaRPr>
                     </a:p>
                   </a:txBody>
-                  <a:tcPr marL="73152" marR="73152" marT="73152" marB="73152" anchor="ctr">
+                  <a:tcPr marL="64008" marR="64008" marT="64008" marB="64008" anchor="ctr">
                     <a:lnL w="9525" cap="flat" cmpd="sng" algn="ctr">
                       <a:solidFill>
                         <a:srgbClr val="DDDDDD"/>
@@ -2964,7 +2975,7 @@
                       </a:endParaRPr>
                     </a:p>
                   </a:txBody>
-                  <a:tcPr marL="73152" marR="73152" marT="73152" marB="73152" anchor="ctr">
+                  <a:tcPr marL="64008" marR="64008" marT="64008" marB="64008" anchor="ctr">
                     <a:lnL w="9525" cap="flat" cmpd="sng" algn="ctr">
                       <a:solidFill>
                         <a:srgbClr val="DDDDDD"/>
@@ -3032,7 +3043,7 @@
                       </a:endParaRPr>
                     </a:p>
                   </a:txBody>
-                  <a:tcPr marL="73152" marR="73152" marT="73152" marB="73152" anchor="ctr">
+                  <a:tcPr marL="64008" marR="64008" marT="64008" marB="64008" anchor="ctr">
                     <a:lnL w="9525" cap="flat" cmpd="sng" algn="ctr">
                       <a:solidFill>
                         <a:srgbClr val="DDDDDD"/>
@@ -3100,7 +3111,7 @@
                       </a:endParaRPr>
                     </a:p>
                   </a:txBody>
-                  <a:tcPr marL="73152" marR="73152" marT="73152" marB="73152" anchor="ctr">
+                  <a:tcPr marL="64008" marR="64008" marT="64008" marB="64008" anchor="ctr">
                     <a:lnL w="9525" cap="flat" cmpd="sng" algn="ctr">
                       <a:solidFill>
                         <a:srgbClr val="DDDDDD"/>
@@ -3168,7 +3179,7 @@
                       </a:endParaRPr>
                     </a:p>
                   </a:txBody>
-                  <a:tcPr marL="73152" marR="73152" marT="73152" marB="73152" anchor="ctr">
+                  <a:tcPr marL="64008" marR="64008" marT="64008" marB="64008" anchor="ctr">
                     <a:lnL w="9525" cap="flat" cmpd="sng" algn="ctr">
                       <a:solidFill>
                         <a:srgbClr val="DDDDDD"/>
@@ -3211,7 +3222,7 @@
                   </a:tcPr>
                 </a:tc>
               </a:tr>
-              <a:tr h="502920">
+              <a:tr h="384048">
                 <a:tc>
                   <a:txBody>
                     <a:bodyPr/>
@@ -3238,7 +3249,7 @@
                       </a:endParaRPr>
                     </a:p>
                   </a:txBody>
-                  <a:tcPr marL="73152" marR="73152" marT="73152" marB="73152" anchor="ctr">
+                  <a:tcPr marL="64008" marR="64008" marT="64008" marB="64008" anchor="ctr">
                     <a:lnL w="9525" cap="flat" cmpd="sng" algn="ctr">
                       <a:solidFill>
                         <a:srgbClr val="DDDDDD"/>
@@ -3303,7 +3314,7 @@
                       </a:endParaRPr>
                     </a:p>
                   </a:txBody>
-                  <a:tcPr marL="73152" marR="73152" marT="73152" marB="73152" anchor="ctr">
+                  <a:tcPr marL="64008" marR="64008" marT="64008" marB="64008" anchor="ctr">
                     <a:lnL w="9525" cap="flat" cmpd="sng" algn="ctr">
                       <a:solidFill>
                         <a:srgbClr val="DDDDDD"/>
@@ -3368,7 +3379,7 @@
                       </a:endParaRPr>
                     </a:p>
                   </a:txBody>
-                  <a:tcPr marL="73152" marR="73152" marT="73152" marB="73152" anchor="ctr">
+                  <a:tcPr marL="64008" marR="64008" marT="64008" marB="64008" anchor="ctr">
                     <a:lnL w="9525" cap="flat" cmpd="sng" algn="ctr">
                       <a:solidFill>
                         <a:srgbClr val="DDDDDD"/>
@@ -3433,7 +3444,7 @@
                       </a:endParaRPr>
                     </a:p>
                   </a:txBody>
-                  <a:tcPr marL="73152" marR="73152" marT="73152" marB="73152" anchor="ctr">
+                  <a:tcPr marL="64008" marR="64008" marT="64008" marB="64008" anchor="ctr">
                     <a:lnL w="9525" cap="flat" cmpd="sng" algn="ctr">
                       <a:solidFill>
                         <a:srgbClr val="DDDDDD"/>
@@ -3498,7 +3509,7 @@
                       </a:endParaRPr>
                     </a:p>
                   </a:txBody>
-                  <a:tcPr marL="73152" marR="73152" marT="73152" marB="73152" anchor="ctr">
+                  <a:tcPr marL="64008" marR="64008" marT="64008" marB="64008" anchor="ctr">
                     <a:lnL w="9525" cap="flat" cmpd="sng" algn="ctr">
                       <a:solidFill>
                         <a:srgbClr val="DDDDDD"/>
@@ -3563,7 +3574,7 @@
                       </a:endParaRPr>
                     </a:p>
                   </a:txBody>
-                  <a:tcPr marL="73152" marR="73152" marT="73152" marB="73152" anchor="ctr">
+                  <a:tcPr marL="64008" marR="64008" marT="64008" marB="64008" anchor="ctr">
                     <a:lnL w="9525" cap="flat" cmpd="sng" algn="ctr">
                       <a:solidFill>
                         <a:srgbClr val="DDDDDD"/>
@@ -3603,7 +3614,7 @@
                   </a:tcPr>
                 </a:tc>
               </a:tr>
-              <a:tr h="502920">
+              <a:tr h="384048">
                 <a:tc>
                   <a:txBody>
                     <a:bodyPr/>
@@ -3621,7 +3632,7 @@
                           <a:ea typeface="Arial" pitchFamily="34" charset="-122"/>
                           <a:cs typeface="Arial" pitchFamily="34" charset="-120"/>
                         </a:rPr>
-                        <a:t>Fee on a $30,000 job</a:t>
+                        <a:t>Jobs closed &amp; collected (fee paid on these only)</a:t>
                       </a:r>
                       <a:endParaRPr lang="en-US" sz="1200" dirty="0">
                         <a:latin typeface="Arial" charset="0"/>
@@ -3630,7 +3641,399 @@
                       </a:endParaRPr>
                     </a:p>
                   </a:txBody>
-                  <a:tcPr marL="73152" marR="73152" marT="73152" marB="73152" anchor="ctr">
+                  <a:tcPr marL="64008" marR="64008" marT="64008" marB="64008" anchor="ctr">
+                    <a:lnL w="9525" cap="flat" cmpd="sng" algn="ctr">
+                      <a:solidFill>
+                        <a:srgbClr val="DDDDDD"/>
+                      </a:solidFill>
+                      <a:prstDash val="solid"/>
+                      <a:round/>
+                      <a:headEnd type="none" w="med" len="med"/>
+                      <a:tailEnd type="none" w="med" len="med"/>
+                    </a:lnL>
+                    <a:lnR w="9525" cap="flat" cmpd="sng" algn="ctr">
+                      <a:solidFill>
+                        <a:srgbClr val="DDDDDD"/>
+                      </a:solidFill>
+                      <a:prstDash val="solid"/>
+                      <a:round/>
+                      <a:headEnd type="none" w="med" len="med"/>
+                      <a:tailEnd type="none" w="med" len="med"/>
+                    </a:lnR>
+                    <a:lnT w="9525" cap="flat" cmpd="sng" algn="ctr">
+                      <a:solidFill>
+                        <a:srgbClr val="DDDDDD"/>
+                      </a:solidFill>
+                      <a:prstDash val="solid"/>
+                      <a:round/>
+                      <a:headEnd type="none" w="med" len="med"/>
+                      <a:tailEnd type="none" w="med" len="med"/>
+                    </a:lnT>
+                    <a:lnB w="9525" cap="flat" cmpd="sng" algn="ctr">
+                      <a:solidFill>
+                        <a:srgbClr val="DDDDDD"/>
+                      </a:solidFill>
+                      <a:prstDash val="solid"/>
+                      <a:round/>
+                      <a:headEnd type="none" w="med" len="med"/>
+                      <a:tailEnd type="none" w="med" len="med"/>
+                    </a:lnB>
+                  </a:tcPr>
+                </a:tc>
+                <a:tc>
+                  <a:txBody>
+                    <a:bodyPr/>
+                    <a:lstStyle/>
+                    <a:p>
+                      <a:pPr algn="ctr" indent="0" marL="0">
+                        <a:buNone/>
+                      </a:pPr>
+                      <a:r>
+                        <a:rPr lang="en-US" sz="1250" dirty="0">
+                          <a:solidFill>
+                            <a:srgbClr val="2A2A2A"/>
+                          </a:solidFill>
+                          <a:latin typeface="Arial" pitchFamily="34" charset="0"/>
+                          <a:ea typeface="Arial" pitchFamily="34" charset="-122"/>
+                          <a:cs typeface="Arial" pitchFamily="34" charset="-120"/>
+                        </a:rPr>
+                        <a:t>2 of 10</a:t>
+                      </a:r>
+                      <a:endParaRPr lang="en-US" sz="1250" dirty="0">
+                        <a:latin typeface="Arial" charset="0"/>
+                        <a:ea typeface="Arial" charset="0"/>
+                        <a:cs typeface="Arial" charset="0"/>
+                      </a:endParaRPr>
+                    </a:p>
+                  </a:txBody>
+                  <a:tcPr marL="64008" marR="64008" marT="64008" marB="64008" anchor="ctr">
+                    <a:lnL w="9525" cap="flat" cmpd="sng" algn="ctr">
+                      <a:solidFill>
+                        <a:srgbClr val="DDDDDD"/>
+                      </a:solidFill>
+                      <a:prstDash val="solid"/>
+                      <a:round/>
+                      <a:headEnd type="none" w="med" len="med"/>
+                      <a:tailEnd type="none" w="med" len="med"/>
+                    </a:lnL>
+                    <a:lnR w="9525" cap="flat" cmpd="sng" algn="ctr">
+                      <a:solidFill>
+                        <a:srgbClr val="DDDDDD"/>
+                      </a:solidFill>
+                      <a:prstDash val="solid"/>
+                      <a:round/>
+                      <a:headEnd type="none" w="med" len="med"/>
+                      <a:tailEnd type="none" w="med" len="med"/>
+                    </a:lnR>
+                    <a:lnT w="9525" cap="flat" cmpd="sng" algn="ctr">
+                      <a:solidFill>
+                        <a:srgbClr val="DDDDDD"/>
+                      </a:solidFill>
+                      <a:prstDash val="solid"/>
+                      <a:round/>
+                      <a:headEnd type="none" w="med" len="med"/>
+                      <a:tailEnd type="none" w="med" len="med"/>
+                    </a:lnT>
+                    <a:lnB w="9525" cap="flat" cmpd="sng" algn="ctr">
+                      <a:solidFill>
+                        <a:srgbClr val="DDDDDD"/>
+                      </a:solidFill>
+                      <a:prstDash val="solid"/>
+                      <a:round/>
+                      <a:headEnd type="none" w="med" len="med"/>
+                      <a:tailEnd type="none" w="med" len="med"/>
+                    </a:lnB>
+                  </a:tcPr>
+                </a:tc>
+                <a:tc>
+                  <a:txBody>
+                    <a:bodyPr/>
+                    <a:lstStyle/>
+                    <a:p>
+                      <a:pPr algn="ctr" indent="0" marL="0">
+                        <a:buNone/>
+                      </a:pPr>
+                      <a:r>
+                        <a:rPr lang="en-US" sz="1250" dirty="0">
+                          <a:solidFill>
+                            <a:srgbClr val="2A2A2A"/>
+                          </a:solidFill>
+                          <a:latin typeface="Arial" pitchFamily="34" charset="0"/>
+                          <a:ea typeface="Arial" pitchFamily="34" charset="-122"/>
+                          <a:cs typeface="Arial" pitchFamily="34" charset="-120"/>
+                        </a:rPr>
+                        <a:t>4 of 10</a:t>
+                      </a:r>
+                      <a:endParaRPr lang="en-US" sz="1250" dirty="0">
+                        <a:latin typeface="Arial" charset="0"/>
+                        <a:ea typeface="Arial" charset="0"/>
+                        <a:cs typeface="Arial" charset="0"/>
+                      </a:endParaRPr>
+                    </a:p>
+                  </a:txBody>
+                  <a:tcPr marL="64008" marR="64008" marT="64008" marB="64008" anchor="ctr">
+                    <a:lnL w="9525" cap="flat" cmpd="sng" algn="ctr">
+                      <a:solidFill>
+                        <a:srgbClr val="DDDDDD"/>
+                      </a:solidFill>
+                      <a:prstDash val="solid"/>
+                      <a:round/>
+                      <a:headEnd type="none" w="med" len="med"/>
+                      <a:tailEnd type="none" w="med" len="med"/>
+                    </a:lnL>
+                    <a:lnR w="9525" cap="flat" cmpd="sng" algn="ctr">
+                      <a:solidFill>
+                        <a:srgbClr val="DDDDDD"/>
+                      </a:solidFill>
+                      <a:prstDash val="solid"/>
+                      <a:round/>
+                      <a:headEnd type="none" w="med" len="med"/>
+                      <a:tailEnd type="none" w="med" len="med"/>
+                    </a:lnR>
+                    <a:lnT w="9525" cap="flat" cmpd="sng" algn="ctr">
+                      <a:solidFill>
+                        <a:srgbClr val="DDDDDD"/>
+                      </a:solidFill>
+                      <a:prstDash val="solid"/>
+                      <a:round/>
+                      <a:headEnd type="none" w="med" len="med"/>
+                      <a:tailEnd type="none" w="med" len="med"/>
+                    </a:lnT>
+                    <a:lnB w="9525" cap="flat" cmpd="sng" algn="ctr">
+                      <a:solidFill>
+                        <a:srgbClr val="DDDDDD"/>
+                      </a:solidFill>
+                      <a:prstDash val="solid"/>
+                      <a:round/>
+                      <a:headEnd type="none" w="med" len="med"/>
+                      <a:tailEnd type="none" w="med" len="med"/>
+                    </a:lnB>
+                  </a:tcPr>
+                </a:tc>
+                <a:tc>
+                  <a:txBody>
+                    <a:bodyPr/>
+                    <a:lstStyle/>
+                    <a:p>
+                      <a:pPr algn="ctr" indent="0" marL="0">
+                        <a:buNone/>
+                      </a:pPr>
+                      <a:r>
+                        <a:rPr lang="en-US" sz="1250" dirty="0">
+                          <a:solidFill>
+                            <a:srgbClr val="2A2A2A"/>
+                          </a:solidFill>
+                          <a:latin typeface="Arial" pitchFamily="34" charset="0"/>
+                          <a:ea typeface="Arial" pitchFamily="34" charset="-122"/>
+                          <a:cs typeface="Arial" pitchFamily="34" charset="-120"/>
+                        </a:rPr>
+                        <a:t>6 of 10</a:t>
+                      </a:r>
+                      <a:endParaRPr lang="en-US" sz="1250" dirty="0">
+                        <a:latin typeface="Arial" charset="0"/>
+                        <a:ea typeface="Arial" charset="0"/>
+                        <a:cs typeface="Arial" charset="0"/>
+                      </a:endParaRPr>
+                    </a:p>
+                  </a:txBody>
+                  <a:tcPr marL="64008" marR="64008" marT="64008" marB="64008" anchor="ctr">
+                    <a:lnL w="9525" cap="flat" cmpd="sng" algn="ctr">
+                      <a:solidFill>
+                        <a:srgbClr val="DDDDDD"/>
+                      </a:solidFill>
+                      <a:prstDash val="solid"/>
+                      <a:round/>
+                      <a:headEnd type="none" w="med" len="med"/>
+                      <a:tailEnd type="none" w="med" len="med"/>
+                    </a:lnL>
+                    <a:lnR w="9525" cap="flat" cmpd="sng" algn="ctr">
+                      <a:solidFill>
+                        <a:srgbClr val="DDDDDD"/>
+                      </a:solidFill>
+                      <a:prstDash val="solid"/>
+                      <a:round/>
+                      <a:headEnd type="none" w="med" len="med"/>
+                      <a:tailEnd type="none" w="med" len="med"/>
+                    </a:lnR>
+                    <a:lnT w="9525" cap="flat" cmpd="sng" algn="ctr">
+                      <a:solidFill>
+                        <a:srgbClr val="DDDDDD"/>
+                      </a:solidFill>
+                      <a:prstDash val="solid"/>
+                      <a:round/>
+                      <a:headEnd type="none" w="med" len="med"/>
+                      <a:tailEnd type="none" w="med" len="med"/>
+                    </a:lnT>
+                    <a:lnB w="9525" cap="flat" cmpd="sng" algn="ctr">
+                      <a:solidFill>
+                        <a:srgbClr val="DDDDDD"/>
+                      </a:solidFill>
+                      <a:prstDash val="solid"/>
+                      <a:round/>
+                      <a:headEnd type="none" w="med" len="med"/>
+                      <a:tailEnd type="none" w="med" len="med"/>
+                    </a:lnB>
+                  </a:tcPr>
+                </a:tc>
+                <a:tc>
+                  <a:txBody>
+                    <a:bodyPr/>
+                    <a:lstStyle/>
+                    <a:p>
+                      <a:pPr algn="ctr" indent="0" marL="0">
+                        <a:buNone/>
+                      </a:pPr>
+                      <a:r>
+                        <a:rPr lang="en-US" sz="1250" dirty="0">
+                          <a:solidFill>
+                            <a:srgbClr val="2A2A2A"/>
+                          </a:solidFill>
+                          <a:latin typeface="Arial" pitchFamily="34" charset="0"/>
+                          <a:ea typeface="Arial" pitchFamily="34" charset="-122"/>
+                          <a:cs typeface="Arial" pitchFamily="34" charset="-120"/>
+                        </a:rPr>
+                        <a:t>8 of 10</a:t>
+                      </a:r>
+                      <a:endParaRPr lang="en-US" sz="1250" dirty="0">
+                        <a:latin typeface="Arial" charset="0"/>
+                        <a:ea typeface="Arial" charset="0"/>
+                        <a:cs typeface="Arial" charset="0"/>
+                      </a:endParaRPr>
+                    </a:p>
+                  </a:txBody>
+                  <a:tcPr marL="64008" marR="64008" marT="64008" marB="64008" anchor="ctr">
+                    <a:lnL w="9525" cap="flat" cmpd="sng" algn="ctr">
+                      <a:solidFill>
+                        <a:srgbClr val="DDDDDD"/>
+                      </a:solidFill>
+                      <a:prstDash val="solid"/>
+                      <a:round/>
+                      <a:headEnd type="none" w="med" len="med"/>
+                      <a:tailEnd type="none" w="med" len="med"/>
+                    </a:lnL>
+                    <a:lnR w="9525" cap="flat" cmpd="sng" algn="ctr">
+                      <a:solidFill>
+                        <a:srgbClr val="DDDDDD"/>
+                      </a:solidFill>
+                      <a:prstDash val="solid"/>
+                      <a:round/>
+                      <a:headEnd type="none" w="med" len="med"/>
+                      <a:tailEnd type="none" w="med" len="med"/>
+                    </a:lnR>
+                    <a:lnT w="9525" cap="flat" cmpd="sng" algn="ctr">
+                      <a:solidFill>
+                        <a:srgbClr val="DDDDDD"/>
+                      </a:solidFill>
+                      <a:prstDash val="solid"/>
+                      <a:round/>
+                      <a:headEnd type="none" w="med" len="med"/>
+                      <a:tailEnd type="none" w="med" len="med"/>
+                    </a:lnT>
+                    <a:lnB w="9525" cap="flat" cmpd="sng" algn="ctr">
+                      <a:solidFill>
+                        <a:srgbClr val="DDDDDD"/>
+                      </a:solidFill>
+                      <a:prstDash val="solid"/>
+                      <a:round/>
+                      <a:headEnd type="none" w="med" len="med"/>
+                      <a:tailEnd type="none" w="med" len="med"/>
+                    </a:lnB>
+                  </a:tcPr>
+                </a:tc>
+                <a:tc>
+                  <a:txBody>
+                    <a:bodyPr/>
+                    <a:lstStyle/>
+                    <a:p>
+                      <a:pPr algn="ctr" indent="0" marL="0">
+                        <a:buNone/>
+                      </a:pPr>
+                      <a:r>
+                        <a:rPr lang="en-US" sz="1250" dirty="0">
+                          <a:solidFill>
+                            <a:srgbClr val="2A2A2A"/>
+                          </a:solidFill>
+                          <a:latin typeface="Arial" pitchFamily="34" charset="0"/>
+                          <a:ea typeface="Arial" pitchFamily="34" charset="-122"/>
+                          <a:cs typeface="Arial" pitchFamily="34" charset="-120"/>
+                        </a:rPr>
+                        <a:t>10 of 10</a:t>
+                      </a:r>
+                      <a:endParaRPr lang="en-US" sz="1250" dirty="0">
+                        <a:latin typeface="Arial" charset="0"/>
+                        <a:ea typeface="Arial" charset="0"/>
+                        <a:cs typeface="Arial" charset="0"/>
+                      </a:endParaRPr>
+                    </a:p>
+                  </a:txBody>
+                  <a:tcPr marL="64008" marR="64008" marT="64008" marB="64008" anchor="ctr">
+                    <a:lnL w="9525" cap="flat" cmpd="sng" algn="ctr">
+                      <a:solidFill>
+                        <a:srgbClr val="DDDDDD"/>
+                      </a:solidFill>
+                      <a:prstDash val="solid"/>
+                      <a:round/>
+                      <a:headEnd type="none" w="med" len="med"/>
+                      <a:tailEnd type="none" w="med" len="med"/>
+                    </a:lnL>
+                    <a:lnR w="9525" cap="flat" cmpd="sng" algn="ctr">
+                      <a:solidFill>
+                        <a:srgbClr val="DDDDDD"/>
+                      </a:solidFill>
+                      <a:prstDash val="solid"/>
+                      <a:round/>
+                      <a:headEnd type="none" w="med" len="med"/>
+                      <a:tailEnd type="none" w="med" len="med"/>
+                    </a:lnR>
+                    <a:lnT w="9525" cap="flat" cmpd="sng" algn="ctr">
+                      <a:solidFill>
+                        <a:srgbClr val="DDDDDD"/>
+                      </a:solidFill>
+                      <a:prstDash val="solid"/>
+                      <a:round/>
+                      <a:headEnd type="none" w="med" len="med"/>
+                      <a:tailEnd type="none" w="med" len="med"/>
+                    </a:lnT>
+                    <a:lnB w="9525" cap="flat" cmpd="sng" algn="ctr">
+                      <a:solidFill>
+                        <a:srgbClr val="DDDDDD"/>
+                      </a:solidFill>
+                      <a:prstDash val="solid"/>
+                      <a:round/>
+                      <a:headEnd type="none" w="med" len="med"/>
+                      <a:tailEnd type="none" w="med" len="med"/>
+                    </a:lnB>
+                  </a:tcPr>
+                </a:tc>
+              </a:tr>
+              <a:tr h="384048">
+                <a:tc>
+                  <a:txBody>
+                    <a:bodyPr/>
+                    <a:lstStyle/>
+                    <a:p>
+                      <a:pPr indent="0" marL="0">
+                        <a:buNone/>
+                      </a:pPr>
+                      <a:r>
+                        <a:rPr lang="en-US" sz="1200" b="1" dirty="0">
+                          <a:solidFill>
+                            <a:srgbClr val="111111"/>
+                          </a:solidFill>
+                          <a:latin typeface="Arial" pitchFamily="34" charset="0"/>
+                          <a:ea typeface="Arial" pitchFamily="34" charset="-122"/>
+                          <a:cs typeface="Arial" pitchFamily="34" charset="-120"/>
+                        </a:rPr>
+                        <a:t>Fee per closed $30,000 job</a:t>
+                      </a:r>
+                      <a:endParaRPr lang="en-US" sz="1200" dirty="0">
+                        <a:latin typeface="Arial" charset="0"/>
+                        <a:ea typeface="Arial" charset="0"/>
+                        <a:cs typeface="Arial" charset="0"/>
+                      </a:endParaRPr>
+                    </a:p>
+                  </a:txBody>
+                  <a:tcPr marL="64008" marR="64008" marT="64008" marB="64008" anchor="ctr">
                     <a:lnL w="9525" cap="flat" cmpd="sng" algn="ctr">
                       <a:solidFill>
                         <a:srgbClr val="DDDDDD"/>
@@ -3695,7 +4098,7 @@
                       </a:endParaRPr>
                     </a:p>
                   </a:txBody>
-                  <a:tcPr marL="73152" marR="73152" marT="73152" marB="73152" anchor="ctr">
+                  <a:tcPr marL="64008" marR="64008" marT="64008" marB="64008" anchor="ctr">
                     <a:lnL w="9525" cap="flat" cmpd="sng" algn="ctr">
                       <a:solidFill>
                         <a:srgbClr val="DDDDDD"/>
@@ -3760,7 +4163,7 @@
                       </a:endParaRPr>
                     </a:p>
                   </a:txBody>
-                  <a:tcPr marL="73152" marR="73152" marT="73152" marB="73152" anchor="ctr">
+                  <a:tcPr marL="64008" marR="64008" marT="64008" marB="64008" anchor="ctr">
                     <a:lnL w="9525" cap="flat" cmpd="sng" algn="ctr">
                       <a:solidFill>
                         <a:srgbClr val="DDDDDD"/>
@@ -3825,7 +4228,7 @@
                       </a:endParaRPr>
                     </a:p>
                   </a:txBody>
-                  <a:tcPr marL="73152" marR="73152" marT="73152" marB="73152" anchor="ctr">
+                  <a:tcPr marL="64008" marR="64008" marT="64008" marB="64008" anchor="ctr">
                     <a:lnL w="9525" cap="flat" cmpd="sng" algn="ctr">
                       <a:solidFill>
                         <a:srgbClr val="DDDDDD"/>
@@ -3890,7 +4293,7 @@
                       </a:endParaRPr>
                     </a:p>
                   </a:txBody>
-                  <a:tcPr marL="73152" marR="73152" marT="73152" marB="73152" anchor="ctr">
+                  <a:tcPr marL="64008" marR="64008" marT="64008" marB="64008" anchor="ctr">
                     <a:lnL w="9525" cap="flat" cmpd="sng" algn="ctr">
                       <a:solidFill>
                         <a:srgbClr val="DDDDDD"/>
@@ -3955,7 +4358,7 @@
                       </a:endParaRPr>
                     </a:p>
                   </a:txBody>
-                  <a:tcPr marL="73152" marR="73152" marT="73152" marB="73152" anchor="ctr">
+                  <a:tcPr marL="64008" marR="64008" marT="64008" marB="64008" anchor="ctr">
                     <a:lnL w="9525" cap="flat" cmpd="sng" algn="ctr">
                       <a:solidFill>
                         <a:srgbClr val="DDDDDD"/>
@@ -3995,7 +4398,7 @@
                   </a:tcPr>
                 </a:tc>
               </a:tr>
-              <a:tr h="502920">
+              <a:tr h="384048">
                 <a:tc>
                   <a:txBody>
                     <a:bodyPr/>
@@ -4013,7 +4416,7 @@
                           <a:ea typeface="Arial" pitchFamily="34" charset="-122"/>
                           <a:cs typeface="Arial" pitchFamily="34" charset="-120"/>
                         </a:rPr>
-                        <a:t>Job profit after fee (35% margin)</a:t>
+                        <a:t>Fee on the other 8 / 6 / 4 / 2 / 0 leads</a:t>
                       </a:r>
                       <a:endParaRPr lang="en-US" sz="1200" dirty="0">
                         <a:latin typeface="Arial" charset="0"/>
@@ -4022,7 +4425,399 @@
                       </a:endParaRPr>
                     </a:p>
                   </a:txBody>
-                  <a:tcPr marL="73152" marR="73152" marT="73152" marB="73152" anchor="ctr">
+                  <a:tcPr marL="64008" marR="64008" marT="64008" marB="64008" anchor="ctr">
+                    <a:lnL w="9525" cap="flat" cmpd="sng" algn="ctr">
+                      <a:solidFill>
+                        <a:srgbClr val="DDDDDD"/>
+                      </a:solidFill>
+                      <a:prstDash val="solid"/>
+                      <a:round/>
+                      <a:headEnd type="none" w="med" len="med"/>
+                      <a:tailEnd type="none" w="med" len="med"/>
+                    </a:lnL>
+                    <a:lnR w="9525" cap="flat" cmpd="sng" algn="ctr">
+                      <a:solidFill>
+                        <a:srgbClr val="DDDDDD"/>
+                      </a:solidFill>
+                      <a:prstDash val="solid"/>
+                      <a:round/>
+                      <a:headEnd type="none" w="med" len="med"/>
+                      <a:tailEnd type="none" w="med" len="med"/>
+                    </a:lnR>
+                    <a:lnT w="9525" cap="flat" cmpd="sng" algn="ctr">
+                      <a:solidFill>
+                        <a:srgbClr val="DDDDDD"/>
+                      </a:solidFill>
+                      <a:prstDash val="solid"/>
+                      <a:round/>
+                      <a:headEnd type="none" w="med" len="med"/>
+                      <a:tailEnd type="none" w="med" len="med"/>
+                    </a:lnT>
+                    <a:lnB w="9525" cap="flat" cmpd="sng" algn="ctr">
+                      <a:solidFill>
+                        <a:srgbClr val="DDDDDD"/>
+                      </a:solidFill>
+                      <a:prstDash val="solid"/>
+                      <a:round/>
+                      <a:headEnd type="none" w="med" len="med"/>
+                      <a:tailEnd type="none" w="med" len="med"/>
+                    </a:lnB>
+                  </a:tcPr>
+                </a:tc>
+                <a:tc>
+                  <a:txBody>
+                    <a:bodyPr/>
+                    <a:lstStyle/>
+                    <a:p>
+                      <a:pPr algn="ctr" indent="0" marL="0">
+                        <a:buNone/>
+                      </a:pPr>
+                      <a:r>
+                        <a:rPr lang="en-US" sz="1200" dirty="0">
+                          <a:solidFill>
+                            <a:srgbClr val="6E6E6E"/>
+                          </a:solidFill>
+                          <a:latin typeface="Arial" pitchFamily="34" charset="0"/>
+                          <a:ea typeface="Arial" pitchFamily="34" charset="-122"/>
+                          <a:cs typeface="Arial" pitchFamily="34" charset="-120"/>
+                        </a:rPr>
+                        <a:t>$0</a:t>
+                      </a:r>
+                      <a:endParaRPr lang="en-US" sz="1200" dirty="0">
+                        <a:latin typeface="Arial" charset="0"/>
+                        <a:ea typeface="Arial" charset="0"/>
+                        <a:cs typeface="Arial" charset="0"/>
+                      </a:endParaRPr>
+                    </a:p>
+                  </a:txBody>
+                  <a:tcPr marL="64008" marR="64008" marT="64008" marB="64008" anchor="ctr">
+                    <a:lnL w="9525" cap="flat" cmpd="sng" algn="ctr">
+                      <a:solidFill>
+                        <a:srgbClr val="DDDDDD"/>
+                      </a:solidFill>
+                      <a:prstDash val="solid"/>
+                      <a:round/>
+                      <a:headEnd type="none" w="med" len="med"/>
+                      <a:tailEnd type="none" w="med" len="med"/>
+                    </a:lnL>
+                    <a:lnR w="9525" cap="flat" cmpd="sng" algn="ctr">
+                      <a:solidFill>
+                        <a:srgbClr val="DDDDDD"/>
+                      </a:solidFill>
+                      <a:prstDash val="solid"/>
+                      <a:round/>
+                      <a:headEnd type="none" w="med" len="med"/>
+                      <a:tailEnd type="none" w="med" len="med"/>
+                    </a:lnR>
+                    <a:lnT w="9525" cap="flat" cmpd="sng" algn="ctr">
+                      <a:solidFill>
+                        <a:srgbClr val="DDDDDD"/>
+                      </a:solidFill>
+                      <a:prstDash val="solid"/>
+                      <a:round/>
+                      <a:headEnd type="none" w="med" len="med"/>
+                      <a:tailEnd type="none" w="med" len="med"/>
+                    </a:lnT>
+                    <a:lnB w="9525" cap="flat" cmpd="sng" algn="ctr">
+                      <a:solidFill>
+                        <a:srgbClr val="DDDDDD"/>
+                      </a:solidFill>
+                      <a:prstDash val="solid"/>
+                      <a:round/>
+                      <a:headEnd type="none" w="med" len="med"/>
+                      <a:tailEnd type="none" w="med" len="med"/>
+                    </a:lnB>
+                  </a:tcPr>
+                </a:tc>
+                <a:tc>
+                  <a:txBody>
+                    <a:bodyPr/>
+                    <a:lstStyle/>
+                    <a:p>
+                      <a:pPr algn="ctr" indent="0" marL="0">
+                        <a:buNone/>
+                      </a:pPr>
+                      <a:r>
+                        <a:rPr lang="en-US" sz="1200" dirty="0">
+                          <a:solidFill>
+                            <a:srgbClr val="6E6E6E"/>
+                          </a:solidFill>
+                          <a:latin typeface="Arial" pitchFamily="34" charset="0"/>
+                          <a:ea typeface="Arial" pitchFamily="34" charset="-122"/>
+                          <a:cs typeface="Arial" pitchFamily="34" charset="-120"/>
+                        </a:rPr>
+                        <a:t>$0</a:t>
+                      </a:r>
+                      <a:endParaRPr lang="en-US" sz="1200" dirty="0">
+                        <a:latin typeface="Arial" charset="0"/>
+                        <a:ea typeface="Arial" charset="0"/>
+                        <a:cs typeface="Arial" charset="0"/>
+                      </a:endParaRPr>
+                    </a:p>
+                  </a:txBody>
+                  <a:tcPr marL="64008" marR="64008" marT="64008" marB="64008" anchor="ctr">
+                    <a:lnL w="9525" cap="flat" cmpd="sng" algn="ctr">
+                      <a:solidFill>
+                        <a:srgbClr val="DDDDDD"/>
+                      </a:solidFill>
+                      <a:prstDash val="solid"/>
+                      <a:round/>
+                      <a:headEnd type="none" w="med" len="med"/>
+                      <a:tailEnd type="none" w="med" len="med"/>
+                    </a:lnL>
+                    <a:lnR w="9525" cap="flat" cmpd="sng" algn="ctr">
+                      <a:solidFill>
+                        <a:srgbClr val="DDDDDD"/>
+                      </a:solidFill>
+                      <a:prstDash val="solid"/>
+                      <a:round/>
+                      <a:headEnd type="none" w="med" len="med"/>
+                      <a:tailEnd type="none" w="med" len="med"/>
+                    </a:lnR>
+                    <a:lnT w="9525" cap="flat" cmpd="sng" algn="ctr">
+                      <a:solidFill>
+                        <a:srgbClr val="DDDDDD"/>
+                      </a:solidFill>
+                      <a:prstDash val="solid"/>
+                      <a:round/>
+                      <a:headEnd type="none" w="med" len="med"/>
+                      <a:tailEnd type="none" w="med" len="med"/>
+                    </a:lnT>
+                    <a:lnB w="9525" cap="flat" cmpd="sng" algn="ctr">
+                      <a:solidFill>
+                        <a:srgbClr val="DDDDDD"/>
+                      </a:solidFill>
+                      <a:prstDash val="solid"/>
+                      <a:round/>
+                      <a:headEnd type="none" w="med" len="med"/>
+                      <a:tailEnd type="none" w="med" len="med"/>
+                    </a:lnB>
+                  </a:tcPr>
+                </a:tc>
+                <a:tc>
+                  <a:txBody>
+                    <a:bodyPr/>
+                    <a:lstStyle/>
+                    <a:p>
+                      <a:pPr algn="ctr" indent="0" marL="0">
+                        <a:buNone/>
+                      </a:pPr>
+                      <a:r>
+                        <a:rPr lang="en-US" sz="1200" dirty="0">
+                          <a:solidFill>
+                            <a:srgbClr val="6E6E6E"/>
+                          </a:solidFill>
+                          <a:latin typeface="Arial" pitchFamily="34" charset="0"/>
+                          <a:ea typeface="Arial" pitchFamily="34" charset="-122"/>
+                          <a:cs typeface="Arial" pitchFamily="34" charset="-120"/>
+                        </a:rPr>
+                        <a:t>$0</a:t>
+                      </a:r>
+                      <a:endParaRPr lang="en-US" sz="1200" dirty="0">
+                        <a:latin typeface="Arial" charset="0"/>
+                        <a:ea typeface="Arial" charset="0"/>
+                        <a:cs typeface="Arial" charset="0"/>
+                      </a:endParaRPr>
+                    </a:p>
+                  </a:txBody>
+                  <a:tcPr marL="64008" marR="64008" marT="64008" marB="64008" anchor="ctr">
+                    <a:lnL w="9525" cap="flat" cmpd="sng" algn="ctr">
+                      <a:solidFill>
+                        <a:srgbClr val="DDDDDD"/>
+                      </a:solidFill>
+                      <a:prstDash val="solid"/>
+                      <a:round/>
+                      <a:headEnd type="none" w="med" len="med"/>
+                      <a:tailEnd type="none" w="med" len="med"/>
+                    </a:lnL>
+                    <a:lnR w="9525" cap="flat" cmpd="sng" algn="ctr">
+                      <a:solidFill>
+                        <a:srgbClr val="DDDDDD"/>
+                      </a:solidFill>
+                      <a:prstDash val="solid"/>
+                      <a:round/>
+                      <a:headEnd type="none" w="med" len="med"/>
+                      <a:tailEnd type="none" w="med" len="med"/>
+                    </a:lnR>
+                    <a:lnT w="9525" cap="flat" cmpd="sng" algn="ctr">
+                      <a:solidFill>
+                        <a:srgbClr val="DDDDDD"/>
+                      </a:solidFill>
+                      <a:prstDash val="solid"/>
+                      <a:round/>
+                      <a:headEnd type="none" w="med" len="med"/>
+                      <a:tailEnd type="none" w="med" len="med"/>
+                    </a:lnT>
+                    <a:lnB w="9525" cap="flat" cmpd="sng" algn="ctr">
+                      <a:solidFill>
+                        <a:srgbClr val="DDDDDD"/>
+                      </a:solidFill>
+                      <a:prstDash val="solid"/>
+                      <a:round/>
+                      <a:headEnd type="none" w="med" len="med"/>
+                      <a:tailEnd type="none" w="med" len="med"/>
+                    </a:lnB>
+                  </a:tcPr>
+                </a:tc>
+                <a:tc>
+                  <a:txBody>
+                    <a:bodyPr/>
+                    <a:lstStyle/>
+                    <a:p>
+                      <a:pPr algn="ctr" indent="0" marL="0">
+                        <a:buNone/>
+                      </a:pPr>
+                      <a:r>
+                        <a:rPr lang="en-US" sz="1200" dirty="0">
+                          <a:solidFill>
+                            <a:srgbClr val="6E6E6E"/>
+                          </a:solidFill>
+                          <a:latin typeface="Arial" pitchFamily="34" charset="0"/>
+                          <a:ea typeface="Arial" pitchFamily="34" charset="-122"/>
+                          <a:cs typeface="Arial" pitchFamily="34" charset="-120"/>
+                        </a:rPr>
+                        <a:t>$0</a:t>
+                      </a:r>
+                      <a:endParaRPr lang="en-US" sz="1200" dirty="0">
+                        <a:latin typeface="Arial" charset="0"/>
+                        <a:ea typeface="Arial" charset="0"/>
+                        <a:cs typeface="Arial" charset="0"/>
+                      </a:endParaRPr>
+                    </a:p>
+                  </a:txBody>
+                  <a:tcPr marL="64008" marR="64008" marT="64008" marB="64008" anchor="ctr">
+                    <a:lnL w="9525" cap="flat" cmpd="sng" algn="ctr">
+                      <a:solidFill>
+                        <a:srgbClr val="DDDDDD"/>
+                      </a:solidFill>
+                      <a:prstDash val="solid"/>
+                      <a:round/>
+                      <a:headEnd type="none" w="med" len="med"/>
+                      <a:tailEnd type="none" w="med" len="med"/>
+                    </a:lnL>
+                    <a:lnR w="9525" cap="flat" cmpd="sng" algn="ctr">
+                      <a:solidFill>
+                        <a:srgbClr val="DDDDDD"/>
+                      </a:solidFill>
+                      <a:prstDash val="solid"/>
+                      <a:round/>
+                      <a:headEnd type="none" w="med" len="med"/>
+                      <a:tailEnd type="none" w="med" len="med"/>
+                    </a:lnR>
+                    <a:lnT w="9525" cap="flat" cmpd="sng" algn="ctr">
+                      <a:solidFill>
+                        <a:srgbClr val="DDDDDD"/>
+                      </a:solidFill>
+                      <a:prstDash val="solid"/>
+                      <a:round/>
+                      <a:headEnd type="none" w="med" len="med"/>
+                      <a:tailEnd type="none" w="med" len="med"/>
+                    </a:lnT>
+                    <a:lnB w="9525" cap="flat" cmpd="sng" algn="ctr">
+                      <a:solidFill>
+                        <a:srgbClr val="DDDDDD"/>
+                      </a:solidFill>
+                      <a:prstDash val="solid"/>
+                      <a:round/>
+                      <a:headEnd type="none" w="med" len="med"/>
+                      <a:tailEnd type="none" w="med" len="med"/>
+                    </a:lnB>
+                  </a:tcPr>
+                </a:tc>
+                <a:tc>
+                  <a:txBody>
+                    <a:bodyPr/>
+                    <a:lstStyle/>
+                    <a:p>
+                      <a:pPr algn="ctr" indent="0" marL="0">
+                        <a:buNone/>
+                      </a:pPr>
+                      <a:r>
+                        <a:rPr lang="en-US" sz="1200" dirty="0">
+                          <a:solidFill>
+                            <a:srgbClr val="6E6E6E"/>
+                          </a:solidFill>
+                          <a:latin typeface="Arial" pitchFamily="34" charset="0"/>
+                          <a:ea typeface="Arial" pitchFamily="34" charset="-122"/>
+                          <a:cs typeface="Arial" pitchFamily="34" charset="-120"/>
+                        </a:rPr>
+                        <a:t>$0</a:t>
+                      </a:r>
+                      <a:endParaRPr lang="en-US" sz="1200" dirty="0">
+                        <a:latin typeface="Arial" charset="0"/>
+                        <a:ea typeface="Arial" charset="0"/>
+                        <a:cs typeface="Arial" charset="0"/>
+                      </a:endParaRPr>
+                    </a:p>
+                  </a:txBody>
+                  <a:tcPr marL="64008" marR="64008" marT="64008" marB="64008" anchor="ctr">
+                    <a:lnL w="9525" cap="flat" cmpd="sng" algn="ctr">
+                      <a:solidFill>
+                        <a:srgbClr val="DDDDDD"/>
+                      </a:solidFill>
+                      <a:prstDash val="solid"/>
+                      <a:round/>
+                      <a:headEnd type="none" w="med" len="med"/>
+                      <a:tailEnd type="none" w="med" len="med"/>
+                    </a:lnL>
+                    <a:lnR w="9525" cap="flat" cmpd="sng" algn="ctr">
+                      <a:solidFill>
+                        <a:srgbClr val="DDDDDD"/>
+                      </a:solidFill>
+                      <a:prstDash val="solid"/>
+                      <a:round/>
+                      <a:headEnd type="none" w="med" len="med"/>
+                      <a:tailEnd type="none" w="med" len="med"/>
+                    </a:lnR>
+                    <a:lnT w="9525" cap="flat" cmpd="sng" algn="ctr">
+                      <a:solidFill>
+                        <a:srgbClr val="DDDDDD"/>
+                      </a:solidFill>
+                      <a:prstDash val="solid"/>
+                      <a:round/>
+                      <a:headEnd type="none" w="med" len="med"/>
+                      <a:tailEnd type="none" w="med" len="med"/>
+                    </a:lnT>
+                    <a:lnB w="9525" cap="flat" cmpd="sng" algn="ctr">
+                      <a:solidFill>
+                        <a:srgbClr val="DDDDDD"/>
+                      </a:solidFill>
+                      <a:prstDash val="solid"/>
+                      <a:round/>
+                      <a:headEnd type="none" w="med" len="med"/>
+                      <a:tailEnd type="none" w="med" len="med"/>
+                    </a:lnB>
+                  </a:tcPr>
+                </a:tc>
+              </a:tr>
+              <a:tr h="384048">
+                <a:tc>
+                  <a:txBody>
+                    <a:bodyPr/>
+                    <a:lstStyle/>
+                    <a:p>
+                      <a:pPr indent="0" marL="0">
+                        <a:buNone/>
+                      </a:pPr>
+                      <a:r>
+                        <a:rPr lang="en-US" sz="1200" b="1" dirty="0">
+                          <a:solidFill>
+                            <a:srgbClr val="111111"/>
+                          </a:solidFill>
+                          <a:latin typeface="Arial" pitchFamily="34" charset="0"/>
+                          <a:ea typeface="Arial" pitchFamily="34" charset="-122"/>
+                          <a:cs typeface="Arial" pitchFamily="34" charset="-120"/>
+                        </a:rPr>
+                        <a:t>T^Rock net per closed job (after 50/50 PM split)</a:t>
+                      </a:r>
+                      <a:endParaRPr lang="en-US" sz="1200" dirty="0">
+                        <a:latin typeface="Arial" charset="0"/>
+                        <a:ea typeface="Arial" charset="0"/>
+                        <a:cs typeface="Arial" charset="0"/>
+                      </a:endParaRPr>
+                    </a:p>
+                  </a:txBody>
+                  <a:tcPr marL="64008" marR="64008" marT="64008" marB="64008" anchor="ctr">
                     <a:lnL w="9525" cap="flat" cmpd="sng" algn="ctr">
                       <a:solidFill>
                         <a:srgbClr val="DDDDDD"/>
@@ -4078,7 +4873,7 @@
                           <a:ea typeface="Arial" pitchFamily="34" charset="-122"/>
                           <a:cs typeface="Arial" pitchFamily="34" charset="-120"/>
                         </a:rPr>
-                        <a:t>$9,900</a:t>
+                        <a:t>$4,950</a:t>
                       </a:r>
                       <a:endParaRPr lang="en-US" sz="1250" dirty="0">
                         <a:latin typeface="Arial" charset="0"/>
@@ -4087,7 +4882,7 @@
                       </a:endParaRPr>
                     </a:p>
                   </a:txBody>
-                  <a:tcPr marL="73152" marR="73152" marT="73152" marB="73152" anchor="ctr">
+                  <a:tcPr marL="64008" marR="64008" marT="64008" marB="64008" anchor="ctr">
                     <a:lnL w="9525" cap="flat" cmpd="sng" algn="ctr">
                       <a:solidFill>
                         <a:srgbClr val="DDDDDD"/>
@@ -4143,7 +4938,7 @@
                           <a:ea typeface="Arial" pitchFamily="34" charset="-122"/>
                           <a:cs typeface="Arial" pitchFamily="34" charset="-120"/>
                         </a:rPr>
-                        <a:t>$9,300</a:t>
+                        <a:t>$4,650</a:t>
                       </a:r>
                       <a:endParaRPr lang="en-US" sz="1250" dirty="0">
                         <a:latin typeface="Arial" charset="0"/>
@@ -4152,7 +4947,7 @@
                       </a:endParaRPr>
                     </a:p>
                   </a:txBody>
-                  <a:tcPr marL="73152" marR="73152" marT="73152" marB="73152" anchor="ctr">
+                  <a:tcPr marL="64008" marR="64008" marT="64008" marB="64008" anchor="ctr">
                     <a:lnL w="9525" cap="flat" cmpd="sng" algn="ctr">
                       <a:solidFill>
                         <a:srgbClr val="DDDDDD"/>
@@ -4208,7 +5003,7 @@
                           <a:ea typeface="Arial" pitchFamily="34" charset="-122"/>
                           <a:cs typeface="Arial" pitchFamily="34" charset="-120"/>
                         </a:rPr>
-                        <a:t>$8,700</a:t>
+                        <a:t>$4,350</a:t>
                       </a:r>
                       <a:endParaRPr lang="en-US" sz="1250" dirty="0">
                         <a:latin typeface="Arial" charset="0"/>
@@ -4217,7 +5012,7 @@
                       </a:endParaRPr>
                     </a:p>
                   </a:txBody>
-                  <a:tcPr marL="73152" marR="73152" marT="73152" marB="73152" anchor="ctr">
+                  <a:tcPr marL="64008" marR="64008" marT="64008" marB="64008" anchor="ctr">
                     <a:lnL w="9525" cap="flat" cmpd="sng" algn="ctr">
                       <a:solidFill>
                         <a:srgbClr val="DDDDDD"/>
@@ -4273,7 +5068,7 @@
                           <a:ea typeface="Arial" pitchFamily="34" charset="-122"/>
                           <a:cs typeface="Arial" pitchFamily="34" charset="-120"/>
                         </a:rPr>
-                        <a:t>$8,100</a:t>
+                        <a:t>$4,050</a:t>
                       </a:r>
                       <a:endParaRPr lang="en-US" sz="1250" dirty="0">
                         <a:latin typeface="Arial" charset="0"/>
@@ -4282,7 +5077,7 @@
                       </a:endParaRPr>
                     </a:p>
                   </a:txBody>
-                  <a:tcPr marL="73152" marR="73152" marT="73152" marB="73152" anchor="ctr">
+                  <a:tcPr marL="64008" marR="64008" marT="64008" marB="64008" anchor="ctr">
                     <a:lnL w="9525" cap="flat" cmpd="sng" algn="ctr">
                       <a:solidFill>
                         <a:srgbClr val="DDDDDD"/>
@@ -4338,7 +5133,7 @@
                           <a:ea typeface="Arial" pitchFamily="34" charset="-122"/>
                           <a:cs typeface="Arial" pitchFamily="34" charset="-120"/>
                         </a:rPr>
-                        <a:t>$7,500</a:t>
+                        <a:t>$3,750</a:t>
                       </a:r>
                       <a:endParaRPr lang="en-US" sz="1250" dirty="0">
                         <a:latin typeface="Arial" charset="0"/>
@@ -4347,7 +5142,7 @@
                       </a:endParaRPr>
                     </a:p>
                   </a:txBody>
-                  <a:tcPr marL="73152" marR="73152" marT="73152" marB="73152" anchor="ctr">
+                  <a:tcPr marL="64008" marR="64008" marT="64008" marB="64008" anchor="ctr">
                     <a:lnL w="9525" cap="flat" cmpd="sng" algn="ctr">
                       <a:solidFill>
                         <a:srgbClr val="DDDDDD"/>
@@ -4387,7 +5182,7 @@
                   </a:tcPr>
                 </a:tc>
               </a:tr>
-              <a:tr h="548640">
+              <a:tr h="457200">
                 <a:tc>
                   <a:txBody>
                     <a:bodyPr/>
@@ -4405,7 +5200,7 @@
                           <a:ea typeface="Arial" pitchFamily="34" charset="-122"/>
                           <a:cs typeface="Arial" pitchFamily="34" charset="-120"/>
                         </a:rPr>
-                        <a:t>T^Rock net per job (after 50/50 PM split)</a:t>
+                        <a:t>T^Rock TOTAL net on the 10 leads</a:t>
                       </a:r>
                       <a:endParaRPr lang="en-US" sz="1200" dirty="0">
                         <a:latin typeface="Arial" charset="0"/>
@@ -4414,7 +5209,7 @@
                       </a:endParaRPr>
                     </a:p>
                   </a:txBody>
-                  <a:tcPr marL="73152" marR="73152" marT="73152" marB="73152" anchor="ctr">
+                  <a:tcPr marL="64008" marR="64008" marT="64008" marB="64008" anchor="ctr">
                     <a:lnL w="9525" cap="flat" cmpd="sng" algn="ctr">
                       <a:solidFill>
                         <a:srgbClr val="DDDDDD"/>
@@ -4470,7 +5265,7 @@
                           <a:ea typeface="Arial" pitchFamily="34" charset="-122"/>
                           <a:cs typeface="Arial" pitchFamily="34" charset="-120"/>
                         </a:rPr>
-                        <a:t>$4,950</a:t>
+                        <a:t>$9,900</a:t>
                       </a:r>
                       <a:endParaRPr lang="en-US" sz="1300" dirty="0">
                         <a:latin typeface="Arial" charset="0"/>
@@ -4479,7 +5274,7 @@
                       </a:endParaRPr>
                     </a:p>
                   </a:txBody>
-                  <a:tcPr marL="73152" marR="73152" marT="73152" marB="73152" anchor="ctr">
+                  <a:tcPr marL="64008" marR="64008" marT="64008" marB="64008" anchor="ctr">
                     <a:lnL w="9525" cap="flat" cmpd="sng" algn="ctr">
                       <a:solidFill>
                         <a:srgbClr val="DDDDDD"/>
@@ -4516,6 +5311,9 @@
                       <a:headEnd type="none" w="med" len="med"/>
                       <a:tailEnd type="none" w="med" len="med"/>
                     </a:lnB>
+                    <a:solidFill>
+                      <a:srgbClr val="FBEAEC"/>
+                    </a:solidFill>
                   </a:tcPr>
                 </a:tc>
                 <a:tc>
@@ -4535,7 +5333,7 @@
                           <a:ea typeface="Arial" pitchFamily="34" charset="-122"/>
                           <a:cs typeface="Arial" pitchFamily="34" charset="-120"/>
                         </a:rPr>
-                        <a:t>$4,650</a:t>
+                        <a:t>$18,600</a:t>
                       </a:r>
                       <a:endParaRPr lang="en-US" sz="1300" dirty="0">
                         <a:latin typeface="Arial" charset="0"/>
@@ -4544,7 +5342,7 @@
                       </a:endParaRPr>
                     </a:p>
                   </a:txBody>
-                  <a:tcPr marL="73152" marR="73152" marT="73152" marB="73152" anchor="ctr">
+                  <a:tcPr marL="64008" marR="64008" marT="64008" marB="64008" anchor="ctr">
                     <a:lnL w="9525" cap="flat" cmpd="sng" algn="ctr">
                       <a:solidFill>
                         <a:srgbClr val="DDDDDD"/>
@@ -4581,6 +5379,9 @@
                       <a:headEnd type="none" w="med" len="med"/>
                       <a:tailEnd type="none" w="med" len="med"/>
                     </a:lnB>
+                    <a:solidFill>
+                      <a:srgbClr val="FBEAEC"/>
+                    </a:solidFill>
                   </a:tcPr>
                 </a:tc>
                 <a:tc>
@@ -4600,7 +5401,7 @@
                           <a:ea typeface="Arial" pitchFamily="34" charset="-122"/>
                           <a:cs typeface="Arial" pitchFamily="34" charset="-120"/>
                         </a:rPr>
-                        <a:t>$4,350</a:t>
+                        <a:t>$26,100</a:t>
                       </a:r>
                       <a:endParaRPr lang="en-US" sz="1300" dirty="0">
                         <a:latin typeface="Arial" charset="0"/>
@@ -4609,7 +5410,7 @@
                       </a:endParaRPr>
                     </a:p>
                   </a:txBody>
-                  <a:tcPr marL="73152" marR="73152" marT="73152" marB="73152" anchor="ctr">
+                  <a:tcPr marL="64008" marR="64008" marT="64008" marB="64008" anchor="ctr">
                     <a:lnL w="9525" cap="flat" cmpd="sng" algn="ctr">
                       <a:solidFill>
                         <a:srgbClr val="DDDDDD"/>
@@ -4646,6 +5447,9 @@
                       <a:headEnd type="none" w="med" len="med"/>
                       <a:tailEnd type="none" w="med" len="med"/>
                     </a:lnB>
+                    <a:solidFill>
+                      <a:srgbClr val="FBEAEC"/>
+                    </a:solidFill>
                   </a:tcPr>
                 </a:tc>
                 <a:tc>
@@ -4665,7 +5469,7 @@
                           <a:ea typeface="Arial" pitchFamily="34" charset="-122"/>
                           <a:cs typeface="Arial" pitchFamily="34" charset="-120"/>
                         </a:rPr>
-                        <a:t>$4,050</a:t>
+                        <a:t>$32,400</a:t>
                       </a:r>
                       <a:endParaRPr lang="en-US" sz="1300" dirty="0">
                         <a:latin typeface="Arial" charset="0"/>
@@ -4674,7 +5478,7 @@
                       </a:endParaRPr>
                     </a:p>
                   </a:txBody>
-                  <a:tcPr marL="73152" marR="73152" marT="73152" marB="73152" anchor="ctr">
+                  <a:tcPr marL="64008" marR="64008" marT="64008" marB="64008" anchor="ctr">
                     <a:lnL w="9525" cap="flat" cmpd="sng" algn="ctr">
                       <a:solidFill>
                         <a:srgbClr val="DDDDDD"/>
@@ -4711,6 +5515,9 @@
                       <a:headEnd type="none" w="med" len="med"/>
                       <a:tailEnd type="none" w="med" len="med"/>
                     </a:lnB>
+                    <a:solidFill>
+                      <a:srgbClr val="FBEAEC"/>
+                    </a:solidFill>
                   </a:tcPr>
                 </a:tc>
                 <a:tc>
@@ -4730,7 +5537,7 @@
                           <a:ea typeface="Arial" pitchFamily="34" charset="-122"/>
                           <a:cs typeface="Arial" pitchFamily="34" charset="-120"/>
                         </a:rPr>
-                        <a:t>$3,750</a:t>
+                        <a:t>$37,500</a:t>
                       </a:r>
                       <a:endParaRPr lang="en-US" sz="1300" dirty="0">
                         <a:latin typeface="Arial" charset="0"/>
@@ -4739,7 +5546,7 @@
                       </a:endParaRPr>
                     </a:p>
                   </a:txBody>
-                  <a:tcPr marL="73152" marR="73152" marT="73152" marB="73152" anchor="ctr">
+                  <a:tcPr marL="64008" marR="64008" marT="64008" marB="64008" anchor="ctr">
                     <a:lnL w="9525" cap="flat" cmpd="sng" algn="ctr">
                       <a:solidFill>
                         <a:srgbClr val="DDDDDD"/>
@@ -4776,6 +5583,9 @@
                       <a:headEnd type="none" w="med" len="med"/>
                       <a:tailEnd type="none" w="med" len="med"/>
                     </a:lnB>
+                    <a:solidFill>
+                      <a:srgbClr val="FBEAEC"/>
+                    </a:solidFill>
                   </a:tcPr>
                 </a:tc>
               </a:tr>
@@ -4791,7 +5601,7 @@
         </p:nvSpPr>
         <p:spPr>
           <a:xfrm>
-            <a:off x="548640" y="4937760"/>
+            <a:off x="548640" y="4892040"/>
             <a:ext cx="11064240" cy="868680"/>
           </a:xfrm>
           <a:prstGeom prst="roundRect">
@@ -4813,8 +5623,8 @@
         </p:nvSpPr>
         <p:spPr>
           <a:xfrm>
-            <a:off x="868680" y="5074920"/>
-            <a:ext cx="10515600" cy="640080"/>
+            <a:off x="868680" y="5010912"/>
+            <a:ext cx="10515600" cy="658368"/>
           </a:xfrm>
           <a:prstGeom prst="rect">
             <a:avLst/>
@@ -4830,7 +5640,7 @@
               <a:buNone/>
             </a:pPr>
             <a:r>
-              <a:rPr lang="en-US" sz="1450" b="1" dirty="0">
+              <a:rPr lang="en-US" sz="1400" b="1" dirty="0">
                 <a:solidFill>
                   <a:srgbClr val="111111"/>
                 </a:solidFill>
@@ -4838,13 +5648,13 @@
                 <a:ea typeface="Arial" pitchFamily="34" charset="-122"/>
                 <a:cs typeface="Arial" pitchFamily="34" charset="-120"/>
               </a:rPr>
-              <a:t>Worst case for T^Rock is still $3,750 net per closed job </a:t>
+              <a:t>The “expensive” end of the slider is the one where T^Rock banks $37,500 on 10 leads instead of $9,900. </a:t>
             </a:r>
             <a:pPr indent="0" marL="0">
               <a:buNone/>
             </a:pPr>
             <a:r>
-              <a:rPr lang="en-US" sz="1450" dirty="0">
+              <a:rPr lang="en-US" sz="1400" dirty="0">
                 <a:solidFill>
                   <a:srgbClr val="2A2A2A"/>
                 </a:solidFill>
@@ -4852,9 +5662,9 @@
                 <a:ea typeface="Arial" pitchFamily="34" charset="-122"/>
                 <a:cs typeface="Arial" pitchFamily="34" charset="-120"/>
               </a:rPr>
-              <a:t>— and that case only exists in a quarter where every single scoped lead closed. The fee can never run ahead of collected cash.</a:t>
+              <a:t>The 10% fee only exists when all 10 closed and funded — it can never run ahead of collected cash.</a:t>
             </a:r>
-            <a:endParaRPr lang="en-US" sz="1450" dirty="0"/>
+            <a:endParaRPr lang="en-US" sz="1400" dirty="0"/>
           </a:p>
         </p:txBody>
       </p:sp>
@@ -4891,7 +5701,7 @@
                 <a:ea typeface="Arial" pitchFamily="34" charset="-122"/>
                 <a:cs typeface="Arial" pitchFamily="34" charset="-120"/>
               </a:rPr>
-              <a:t>Rates between tiers interpolate linearly. Close rate = closed &amp; collected jobs ÷ scoped leads, trailing quarter.</a:t>
+              <a:t>Total net = jobs closed (of 10) × net per closed job. Rates between tiers interpolate linearly. Close rate measured on a trailing quarter.</a:t>
             </a:r>
             <a:endParaRPr lang="en-US" sz="900" dirty="0"/>
           </a:p>

</xml_diff>

<commit_message>
Add slider-origin slide anchoring the fee curve to referral norms
New slide 4 in the pay plan explains where the 2%-10% curve comes from:
the floor prices raw scoped leads (most written for free), the ceiling
prices a guaranteed-to-close lead as what it is - a handed-off signed
contract, i.e. a referral at the customary ~10% fee. The close rate
interpolates between the two on quarterly actuals.

Co-Authored-By: Claude Fable 5 <noreply@anthropic.com>
Claude-Session: https://claude.ai/code/session_01Qj1b2D7LVH4xves4mfA9FY
</commit_message>
<xml_diff>
--- a/pitch/Commission-Plan.pptx
+++ b/pitch/Commission-Plan.pptx
@@ -12,9 +12,10 @@
     <p:sldId id="260" r:id="rId6"/>
     <p:sldId id="261" r:id="rId7"/>
     <p:sldId id="262" r:id="rId8"/>
+    <p:sldId id="263" r:id="rId9"/>
   </p:sldIdLst>
   <p:notesMasterIdLst>
-    <p:notesMasterId r:id="rId9"/>
+    <p:notesMasterId r:id="rId10"/>
   </p:notesMasterIdLst>
   <p:sldSz cx="12192000" cy="6858000"/>
   <p:notesSz cx="6858000" cy="12192000"/>
@@ -1342,6 +1343,94 @@
             <a:fld id="{F7021451-1387-4CA6-816F-3879F97B5CBC}" type="slidenum">
               <a:rPr lang="en-US"/>
               <a:t>7</a:t>
+            </a:fld>
+            <a:endParaRPr lang="en-US"/>
+          </a:p>
+        </p:txBody>
+      </p:sp>
+    </p:spTree>
+    <p:extLst>
+      <p:ext uri="{BB962C8B-B14F-4D97-AF65-F5344CB8AC3E}">
+        <p14:creationId xmlns:p14="http://schemas.microsoft.com/office/powerpoint/2010/main" val="1024086991"/>
+      </p:ext>
+    </p:extLst>
+  </p:cSld>
+  <p:clrMapOvr>
+    <a:masterClrMapping/>
+  </p:clrMapOvr>
+</p:notes>
+</file>
+
+<file path=ppt/notesSlides/notesSlide8.xml><?xml version="1.0" encoding="utf-8"?>
+<p:notes xmlns:a="http://schemas.openxmlformats.org/drawingml/2006/main" xmlns:r="http://schemas.openxmlformats.org/officeDocument/2006/relationships" xmlns:p="http://schemas.openxmlformats.org/presentationml/2006/main">
+  <p:cSld>
+    <p:spTree>
+      <p:nvGrpSpPr>
+        <p:cNvPr id="1" name=""/>
+        <p:cNvGrpSpPr/>
+        <p:nvPr/>
+      </p:nvGrpSpPr>
+      <p:grpSpPr>
+        <a:xfrm>
+          <a:off x="0" y="0"/>
+          <a:ext cx="0" cy="0"/>
+          <a:chOff x="0" y="0"/>
+          <a:chExt cx="0" cy="0"/>
+        </a:xfrm>
+      </p:grpSpPr>
+      <p:sp>
+        <p:nvSpPr>
+          <p:cNvPr id="2" name="Slide Image Placeholder 1"/>
+          <p:cNvSpPr>
+            <a:spLocks noGrp="1" noRot="1" noChangeAspect="1"/>
+          </p:cNvSpPr>
+          <p:nvPr>
+            <p:ph type="sldImg"/>
+          </p:nvPr>
+        </p:nvSpPr>
+        <p:spPr/>
+      </p:sp>
+      <p:sp>
+        <p:nvSpPr>
+          <p:cNvPr id="3" name="Notes Placeholder 2"/>
+          <p:cNvSpPr>
+            <a:spLocks noGrp="1"/>
+          </p:cNvSpPr>
+          <p:nvPr>
+            <p:ph type="body" idx="1"/>
+          </p:nvPr>
+        </p:nvSpPr>
+        <p:spPr/>
+        <p:txBody>
+          <a:bodyPr/>
+          <a:lstStyle/>
+          <a:p>
+            <a:r>
+              <a:rPr lang="en-US" dirty="0"/>
+              <a:t/>
+            </a:r>
+            <a:endParaRPr lang="en-US" dirty="0"/>
+          </a:p>
+        </p:txBody>
+      </p:sp>
+      <p:sp>
+        <p:nvSpPr>
+          <p:cNvPr id="4" name="Slide Number Placeholder 3"/>
+          <p:cNvSpPr>
+            <a:spLocks noGrp="1"/>
+          </p:cNvSpPr>
+          <p:nvPr>
+            <p:ph type="sldNum" sz="quarter" idx="10"/>
+          </p:nvPr>
+        </p:nvSpPr>
+        <p:spPr/>
+        <p:txBody>
+          <a:bodyPr/>
+          <a:lstStyle/>
+          <a:p>
+            <a:fld id="{F7021451-1387-4CA6-816F-3879F97B5CBC}" type="slidenum">
+              <a:rPr lang="en-US"/>
+              <a:t>8</a:t>
             </a:fld>
             <a:endParaRPr lang="en-US"/>
           </a:p>
@@ -5811,7 +5900,7 @@
                 <a:ea typeface="Arial" pitchFamily="34" charset="-122"/>
                 <a:cs typeface="Arial" pitchFamily="34" charset="-120"/>
               </a:rPr>
-              <a:t>Why the slider pays for itself</a:t>
+              <a:t>Where the slider comes from</a:t>
             </a:r>
             <a:endParaRPr lang="en-US" sz="3200" dirty="0"/>
           </a:p>
@@ -5825,7 +5914,7 @@
         </p:nvSpPr>
         <p:spPr>
           <a:xfrm>
-            <a:off x="548640" y="1078992"/>
+            <a:off x="548640" y="1097280"/>
             <a:ext cx="10881360" cy="365760"/>
           </a:xfrm>
           <a:prstGeom prst="rect">
@@ -5850,42 +5939,209 @@
                 <a:ea typeface="Arial" pitchFamily="34" charset="-122"/>
                 <a:cs typeface="Arial" pitchFamily="34" charset="-120"/>
               </a:rPr>
-              <a:t>Same 100 scoped leads, five close rates. The fee % rises — the pie rises much faster.</a:t>
+              <a:t>Both ends are anchored to prices the industry already pays. The slider just connects them.</a:t>
             </a:r>
             <a:endParaRPr lang="en-US" sz="1500" dirty="0"/>
           </a:p>
         </p:txBody>
       </p:sp>
-      <p:graphicFrame>
-        <p:nvGraphicFramePr>
-          <p:cNvPr id="4" name="Chart 0" descr=""/>
-          <p:cNvGraphicFramePr/>
-          <p:nvPr/>
-        </p:nvGraphicFramePr>
-        <p:xfrm>
-          <a:off x="548640" y="1600200"/>
-          <a:ext cx="11064240" cy="3749040"/>
-        </p:xfrm>
-        <a:graphic xmlns:a="http://schemas.openxmlformats.org/drawingml/2006/main">
-          <a:graphicData uri="http://schemas.openxmlformats.org/drawingml/2006/chart">
-            <c:chart xmlns:c="http://schemas.openxmlformats.org/drawingml/2006/chart" r:id="rId1"/>
-          </a:graphicData>
-        </a:graphic>
-      </p:graphicFrame>
-      <p:sp>
-        <p:nvSpPr>
-          <p:cNvPr id="5" name="Shape 2"/>
-          <p:cNvSpPr/>
-          <p:nvPr/>
-        </p:nvSpPr>
-        <p:spPr>
-          <a:xfrm>
-            <a:off x="548640" y="5532120"/>
-            <a:ext cx="11064240" cy="731520"/>
+      <p:sp>
+        <p:nvSpPr>
+          <p:cNvPr id="4" name="Shape 2"/>
+          <p:cNvSpPr/>
+          <p:nvPr/>
+        </p:nvSpPr>
+        <p:spPr>
+          <a:xfrm>
+            <a:off x="548640" y="1645920"/>
+            <a:ext cx="5394960" cy="3200400"/>
           </a:xfrm>
           <a:prstGeom prst="roundRect">
             <a:avLst>
-              <a:gd name="adj" fmla="val 7500"/>
+              <a:gd name="adj" fmla="val 2286"/>
+            </a:avLst>
+          </a:prstGeom>
+          <a:solidFill>
+            <a:srgbClr val="F5F5F5"/>
+          </a:solidFill>
+          <a:ln/>
+        </p:spPr>
+      </p:sp>
+      <p:sp>
+        <p:nvSpPr>
+          <p:cNvPr id="5" name="Shape 3"/>
+          <p:cNvSpPr/>
+          <p:nvPr/>
+        </p:nvSpPr>
+        <p:spPr>
+          <a:xfrm>
+            <a:off x="822960" y="1920240"/>
+            <a:ext cx="640080" cy="640080"/>
+          </a:xfrm>
+          <a:prstGeom prst="ellipse">
+            <a:avLst/>
+          </a:prstGeom>
+          <a:solidFill>
+            <a:srgbClr val="C8102E"/>
+          </a:solidFill>
+          <a:ln/>
+        </p:spPr>
+      </p:sp>
+      <p:pic>
+        <p:nvPicPr>
+          <p:cNvPr id="6" name="Image 0" descr="preencoded.png">    </p:cNvPr>
+          <p:cNvPicPr>
+            <a:picLocks noChangeAspect="1"/>
+          </p:cNvPicPr>
+          <p:nvPr/>
+        </p:nvPicPr>
+        <p:blipFill>
+          <a:blip r:embed="rId1"/>
+          <a:stretch>
+            <a:fillRect/>
+          </a:stretch>
+        </p:blipFill>
+        <p:spPr>
+          <a:xfrm>
+            <a:off x="989381" y="2086661"/>
+            <a:ext cx="307238" cy="307238"/>
+          </a:xfrm>
+          <a:prstGeom prst="rect">
+            <a:avLst/>
+          </a:prstGeom>
+        </p:spPr>
+      </p:pic>
+      <p:sp>
+        <p:nvSpPr>
+          <p:cNvPr id="7" name="Text 4"/>
+          <p:cNvSpPr/>
+          <p:nvPr/>
+        </p:nvSpPr>
+        <p:spPr>
+          <a:xfrm>
+            <a:off x="1645920" y="2057400"/>
+            <a:ext cx="4114800" cy="365760"/>
+          </a:xfrm>
+          <a:prstGeom prst="rect">
+            <a:avLst/>
+          </a:prstGeom>
+          <a:noFill/>
+          <a:ln/>
+        </p:spPr>
+        <p:txBody>
+          <a:bodyPr wrap="square" lIns="0" tIns="0" rIns="0" bIns="0" rtlCol="0" anchor="ctr"/>
+          <a:lstStyle/>
+          <a:p>
+            <a:pPr indent="0" marL="0">
+              <a:buNone/>
+            </a:pPr>
+            <a:r>
+              <a:rPr lang="en-US" sz="1700" b="1" dirty="0">
+                <a:solidFill>
+                  <a:srgbClr val="111111"/>
+                </a:solidFill>
+                <a:latin typeface="Arial" pitchFamily="34" charset="0"/>
+                <a:ea typeface="Arial" pitchFamily="34" charset="-122"/>
+                <a:cs typeface="Arial" pitchFamily="34" charset="-120"/>
+              </a:rPr>
+              <a:t>The floor — raw leads</a:t>
+            </a:r>
+            <a:endParaRPr lang="en-US" sz="1700" dirty="0"/>
+          </a:p>
+        </p:txBody>
+      </p:sp>
+      <p:sp>
+        <p:nvSpPr>
+          <p:cNvPr id="8" name="Text 5"/>
+          <p:cNvSpPr/>
+          <p:nvPr/>
+        </p:nvSpPr>
+        <p:spPr>
+          <a:xfrm>
+            <a:off x="822960" y="2697480"/>
+            <a:ext cx="1828800" cy="822960"/>
+          </a:xfrm>
+          <a:prstGeom prst="rect">
+            <a:avLst/>
+          </a:prstGeom>
+          <a:noFill/>
+          <a:ln/>
+        </p:spPr>
+        <p:txBody>
+          <a:bodyPr wrap="square" lIns="0" tIns="0" rIns="0" bIns="0" rtlCol="0" anchor="ctr"/>
+          <a:lstStyle/>
+          <a:p>
+            <a:pPr indent="0" marL="0">
+              <a:buNone/>
+            </a:pPr>
+            <a:r>
+              <a:rPr lang="en-US" sz="4800" b="1" dirty="0">
+                <a:solidFill>
+                  <a:srgbClr val="C8102E"/>
+                </a:solidFill>
+                <a:latin typeface="Arial" pitchFamily="34" charset="0"/>
+                <a:ea typeface="Arial" pitchFamily="34" charset="-122"/>
+                <a:cs typeface="Arial" pitchFamily="34" charset="-120"/>
+              </a:rPr>
+              <a:t>2%</a:t>
+            </a:r>
+            <a:endParaRPr lang="en-US" sz="4800" dirty="0"/>
+          </a:p>
+        </p:txBody>
+      </p:sp>
+      <p:sp>
+        <p:nvSpPr>
+          <p:cNvPr id="9" name="Text 6"/>
+          <p:cNvSpPr/>
+          <p:nvPr/>
+        </p:nvSpPr>
+        <p:spPr>
+          <a:xfrm>
+            <a:off x="822960" y="3611880"/>
+            <a:ext cx="4846320" cy="1097280"/>
+          </a:xfrm>
+          <a:prstGeom prst="rect">
+            <a:avLst/>
+          </a:prstGeom>
+          <a:noFill/>
+          <a:ln/>
+        </p:spPr>
+        <p:txBody>
+          <a:bodyPr wrap="square" lIns="0" tIns="0" rIns="0" bIns="0" rtlCol="0" anchor="ctr"/>
+          <a:lstStyle/>
+          <a:p>
+            <a:pPr indent="0" marL="0">
+              <a:buNone/>
+            </a:pPr>
+            <a:r>
+              <a:rPr lang="en-US" sz="1250" dirty="0">
+                <a:solidFill>
+                  <a:srgbClr val="2A2A2A"/>
+                </a:solidFill>
+                <a:latin typeface="Arial" pitchFamily="34" charset="0"/>
+                <a:ea typeface="Arial" pitchFamily="34" charset="-122"/>
+                <a:cs typeface="Arial" pitchFamily="34" charset="-120"/>
+              </a:rPr>
+              <a:t>Scoped leads where most won't close. The fee collects on the few that do — priced like professional scope work, paid only on results. At a 20% close rate, 8 of every 10 scopes were written for free.</a:t>
+            </a:r>
+            <a:endParaRPr lang="en-US" sz="1250" dirty="0"/>
+          </a:p>
+        </p:txBody>
+      </p:sp>
+      <p:sp>
+        <p:nvSpPr>
+          <p:cNvPr id="10" name="Shape 7"/>
+          <p:cNvSpPr/>
+          <p:nvPr/>
+        </p:nvSpPr>
+        <p:spPr>
+          <a:xfrm>
+            <a:off x="6217920" y="1645920"/>
+            <a:ext cx="5394960" cy="3200400"/>
+          </a:xfrm>
+          <a:prstGeom prst="roundRect">
+            <a:avLst>
+              <a:gd name="adj" fmla="val 2286"/>
             </a:avLst>
           </a:prstGeom>
           <a:solidFill>
@@ -5896,14 +6152,58 @@
       </p:sp>
       <p:sp>
         <p:nvSpPr>
-          <p:cNvPr id="6" name="Text 3"/>
-          <p:cNvSpPr/>
-          <p:nvPr/>
-        </p:nvSpPr>
-        <p:spPr>
-          <a:xfrm>
-            <a:off x="868680" y="5650992"/>
-            <a:ext cx="10515600" cy="502920"/>
+          <p:cNvPr id="11" name="Shape 8"/>
+          <p:cNvSpPr/>
+          <p:nvPr/>
+        </p:nvSpPr>
+        <p:spPr>
+          <a:xfrm>
+            <a:off x="6492240" y="1920240"/>
+            <a:ext cx="640080" cy="640080"/>
+          </a:xfrm>
+          <a:prstGeom prst="ellipse">
+            <a:avLst/>
+          </a:prstGeom>
+          <a:solidFill>
+            <a:srgbClr val="C8102E"/>
+          </a:solidFill>
+          <a:ln/>
+        </p:spPr>
+      </p:sp>
+      <p:pic>
+        <p:nvPicPr>
+          <p:cNvPr id="12" name="Image 1" descr="preencoded.png">    </p:cNvPr>
+          <p:cNvPicPr>
+            <a:picLocks noChangeAspect="1"/>
+          </p:cNvPicPr>
+          <p:nvPr/>
+        </p:nvPicPr>
+        <p:blipFill>
+          <a:blip r:embed="rId2"/>
+          <a:stretch>
+            <a:fillRect/>
+          </a:stretch>
+        </p:blipFill>
+        <p:spPr>
+          <a:xfrm>
+            <a:off x="6658661" y="2086661"/>
+            <a:ext cx="307238" cy="307238"/>
+          </a:xfrm>
+          <a:prstGeom prst="rect">
+            <a:avLst/>
+          </a:prstGeom>
+        </p:spPr>
+      </p:pic>
+      <p:sp>
+        <p:nvSpPr>
+          <p:cNvPr id="13" name="Text 9"/>
+          <p:cNvSpPr/>
+          <p:nvPr/>
+        </p:nvSpPr>
+        <p:spPr>
+          <a:xfrm>
+            <a:off x="7315200" y="2057400"/>
+            <a:ext cx="4114800" cy="365760"/>
           </a:xfrm>
           <a:prstGeom prst="rect">
             <a:avLst/>
@@ -5919,7 +6219,7 @@
               <a:buNone/>
             </a:pPr>
             <a:r>
-              <a:rPr lang="en-US" sz="1500" b="1" dirty="0">
+              <a:rPr lang="en-US" sz="1700" b="1" dirty="0">
                 <a:solidFill>
                   <a:srgbClr val="FFFFFF"/>
                 </a:solidFill>
@@ -5927,29 +6227,168 @@
                 <a:ea typeface="Arial" pitchFamily="34" charset="-122"/>
                 <a:cs typeface="Arial" pitchFamily="34" charset="-120"/>
               </a:rPr>
-              <a:t>Top of the slider = T^Rock's take is up nearly 4×. </a:t>
-            </a:r>
+              <a:t>The ceiling — a done deal</a:t>
+            </a:r>
+            <a:endParaRPr lang="en-US" sz="1700" dirty="0"/>
+          </a:p>
+        </p:txBody>
+      </p:sp>
+      <p:sp>
+        <p:nvSpPr>
+          <p:cNvPr id="14" name="Text 10"/>
+          <p:cNvSpPr/>
+          <p:nvPr/>
+        </p:nvSpPr>
+        <p:spPr>
+          <a:xfrm>
+            <a:off x="6492240" y="2697480"/>
+            <a:ext cx="2194560" cy="822960"/>
+          </a:xfrm>
+          <a:prstGeom prst="rect">
+            <a:avLst/>
+          </a:prstGeom>
+          <a:noFill/>
+          <a:ln/>
+        </p:spPr>
+        <p:txBody>
+          <a:bodyPr wrap="square" lIns="0" tIns="0" rIns="0" bIns="0" rtlCol="0" anchor="ctr"/>
+          <a:lstStyle/>
+          <a:p>
             <a:pPr indent="0" marL="0">
               <a:buNone/>
             </a:pPr>
             <a:r>
-              <a:rPr lang="en-US" sz="1500" dirty="0">
+              <a:rPr lang="en-US" sz="4800" b="1" dirty="0">
                 <a:solidFill>
-                  <a:srgbClr val="E6E6E6"/>
+                  <a:srgbClr val="C8102E"/>
                 </a:solidFill>
                 <a:latin typeface="Arial" pitchFamily="34" charset="0"/>
                 <a:ea typeface="Arial" pitchFamily="34" charset="-122"/>
                 <a:cs typeface="Arial" pitchFamily="34" charset="-120"/>
               </a:rPr>
-              <a:t>The higher fee is only ever paid out of jobs that already closed — the plan cannot cost money in a bad quarter.</a:t>
-            </a:r>
-            <a:endParaRPr lang="en-US" sz="1500" dirty="0"/>
-          </a:p>
-        </p:txBody>
-      </p:sp>
-      <p:sp>
-        <p:nvSpPr>
-          <p:cNvPr id="7" name="Text 4"/>
+              <a:t>10%</a:t>
+            </a:r>
+            <a:endParaRPr lang="en-US" sz="4800" dirty="0"/>
+          </a:p>
+        </p:txBody>
+      </p:sp>
+      <p:sp>
+        <p:nvSpPr>
+          <p:cNvPr id="15" name="Text 11"/>
+          <p:cNvSpPr/>
+          <p:nvPr/>
+        </p:nvSpPr>
+        <p:spPr>
+          <a:xfrm>
+            <a:off x="6492240" y="3611880"/>
+            <a:ext cx="4846320" cy="1097280"/>
+          </a:xfrm>
+          <a:prstGeom prst="rect">
+            <a:avLst/>
+          </a:prstGeom>
+          <a:noFill/>
+          <a:ln/>
+        </p:spPr>
+        <p:txBody>
+          <a:bodyPr wrap="square" lIns="0" tIns="0" rIns="0" bIns="0" rtlCol="0" anchor="ctr"/>
+          <a:lstStyle/>
+          <a:p>
+            <a:pPr indent="0" marL="0">
+              <a:buNone/>
+            </a:pPr>
+            <a:r>
+              <a:rPr lang="en-US" sz="1250" dirty="0">
+                <a:solidFill>
+                  <a:srgbClr val="E0E0E0"/>
+                </a:solidFill>
+                <a:latin typeface="Arial" pitchFamily="34" charset="0"/>
+                <a:ea typeface="Arial" pitchFamily="34" charset="-122"/>
+                <a:cs typeface="Arial" pitchFamily="34" charset="-120"/>
+              </a:rPr>
+              <a:t>A lead that closes 100% of the time is a signed contract changing hands. That's a referral — and 10% of contract value is the standard referral fee. Nobody blinks at 10% for a job that's already sold.</a:t>
+            </a:r>
+            <a:endParaRPr lang="en-US" sz="1250" dirty="0"/>
+          </a:p>
+        </p:txBody>
+      </p:sp>
+      <p:sp>
+        <p:nvSpPr>
+          <p:cNvPr id="16" name="Shape 12"/>
+          <p:cNvSpPr/>
+          <p:nvPr/>
+        </p:nvSpPr>
+        <p:spPr>
+          <a:xfrm>
+            <a:off x="548640" y="5120640"/>
+            <a:ext cx="11064240" cy="914400"/>
+          </a:xfrm>
+          <a:prstGeom prst="roundRect">
+            <a:avLst>
+              <a:gd name="adj" fmla="val 6000"/>
+            </a:avLst>
+          </a:prstGeom>
+          <a:solidFill>
+            <a:srgbClr val="FBEAEC"/>
+          </a:solidFill>
+          <a:ln/>
+        </p:spPr>
+      </p:sp>
+      <p:sp>
+        <p:nvSpPr>
+          <p:cNvPr id="17" name="Text 13"/>
+          <p:cNvSpPr/>
+          <p:nvPr/>
+        </p:nvSpPr>
+        <p:spPr>
+          <a:xfrm>
+            <a:off x="868680" y="5230368"/>
+            <a:ext cx="10515600" cy="713232"/>
+          </a:xfrm>
+          <a:prstGeom prst="rect">
+            <a:avLst/>
+          </a:prstGeom>
+          <a:noFill/>
+          <a:ln/>
+        </p:spPr>
+        <p:txBody>
+          <a:bodyPr wrap="square" lIns="0" tIns="0" rIns="0" bIns="0" rtlCol="0" anchor="ctr"/>
+          <a:lstStyle/>
+          <a:p>
+            <a:pPr indent="0" marL="0">
+              <a:buNone/>
+            </a:pPr>
+            <a:r>
+              <a:rPr lang="en-US" sz="1400" b="1" dirty="0">
+                <a:solidFill>
+                  <a:srgbClr val="111111"/>
+                </a:solidFill>
+                <a:latin typeface="Arial" pitchFamily="34" charset="0"/>
+                <a:ea typeface="Arial" pitchFamily="34" charset="-122"/>
+                <a:cs typeface="Arial" pitchFamily="34" charset="-120"/>
+              </a:rPr>
+              <a:t>Everything between is interpolation. </a:t>
+            </a:r>
+            <a:pPr indent="0" marL="0">
+              <a:buNone/>
+            </a:pPr>
+            <a:r>
+              <a:rPr lang="en-US" sz="1400" dirty="0">
+                <a:solidFill>
+                  <a:srgbClr val="2A2A2A"/>
+                </a:solidFill>
+                <a:latin typeface="Arial" pitchFamily="34" charset="0"/>
+                <a:ea typeface="Arial" pitchFamily="34" charset="-122"/>
+                <a:cs typeface="Arial" pitchFamily="34" charset="-120"/>
+              </a:rPr>
+              <a:t>The quarter's actual close rate measures how pre-sold the leads really were, and the fee settles to match — on results, not promises. The slider doesn't invent a price; it connects two prices the industry already accepts.</a:t>
+            </a:r>
+            <a:endParaRPr lang="en-US" sz="1400" dirty="0"/>
+          </a:p>
+        </p:txBody>
+      </p:sp>
+      <p:sp>
+        <p:nvSpPr>
+          <p:cNvPr id="18" name="Text 14"/>
           <p:cNvSpPr/>
           <p:nvPr/>
         </p:nvSpPr>
@@ -5980,7 +6419,7 @@
                 <a:ea typeface="Arial" pitchFamily="34" charset="-122"/>
                 <a:cs typeface="Arial" pitchFamily="34" charset="-120"/>
               </a:rPr>
-              <a:t>Per closed job: $30,000 × 35% margin, less slider fee, split 50/50 with the PM. 100 scoped leads held constant across scenarios.</a:t>
+              <a:t>Referral benchmark: ~10% of contract value is the customary fee for handed-off, ready-to-sign work in residential contracting.</a:t>
             </a:r>
             <a:endParaRPr lang="en-US" sz="900" dirty="0"/>
           </a:p>
@@ -5988,7 +6427,7 @@
       </p:sp>
       <p:sp>
         <p:nvSpPr>
-          <p:cNvPr id="8" name="Text 5"/>
+          <p:cNvPr id="19" name="Text 15"/>
           <p:cNvSpPr/>
           <p:nvPr/>
         </p:nvSpPr>
@@ -6090,7 +6529,7 @@
                 <a:ea typeface="Arial" pitchFamily="34" charset="-122"/>
                 <a:cs typeface="Arial" pitchFamily="34" charset="-120"/>
               </a:rPr>
-              <a:t>Two ways to base it — pick one, put it in writing</a:t>
+              <a:t>Why the slider pays for itself</a:t>
             </a:r>
             <a:endParaRPr lang="en-US" sz="3200" dirty="0"/>
           </a:p>
@@ -6098,80 +6537,14 @@
       </p:sp>
       <p:sp>
         <p:nvSpPr>
-          <p:cNvPr id="3" name="Shape 1"/>
-          <p:cNvSpPr/>
-          <p:nvPr/>
-        </p:nvSpPr>
-        <p:spPr>
-          <a:xfrm>
-            <a:off x="548640" y="1371600"/>
-            <a:ext cx="5394960" cy="3977640"/>
-          </a:xfrm>
-          <a:prstGeom prst="roundRect">
-            <a:avLst>
-              <a:gd name="adj" fmla="val 1839"/>
-            </a:avLst>
-          </a:prstGeom>
-          <a:solidFill>
-            <a:srgbClr val="F5F5F5"/>
-          </a:solidFill>
-          <a:ln/>
-        </p:spPr>
-      </p:sp>
-      <p:sp>
-        <p:nvSpPr>
-          <p:cNvPr id="4" name="Shape 2"/>
-          <p:cNvSpPr/>
-          <p:nvPr/>
-        </p:nvSpPr>
-        <p:spPr>
-          <a:xfrm>
-            <a:off x="822960" y="1645920"/>
-            <a:ext cx="640080" cy="640080"/>
-          </a:xfrm>
-          <a:prstGeom prst="ellipse">
-            <a:avLst/>
-          </a:prstGeom>
-          <a:solidFill>
-            <a:srgbClr val="C8102E"/>
-          </a:solidFill>
-          <a:ln/>
-        </p:spPr>
-      </p:sp>
-      <p:pic>
-        <p:nvPicPr>
-          <p:cNvPr id="5" name="Image 0" descr="preencoded.png">    </p:cNvPr>
-          <p:cNvPicPr>
-            <a:picLocks noChangeAspect="1"/>
-          </p:cNvPicPr>
-          <p:nvPr/>
-        </p:nvPicPr>
-        <p:blipFill>
-          <a:blip r:embed="rId1"/>
-          <a:stretch>
-            <a:fillRect/>
-          </a:stretch>
-        </p:blipFill>
-        <p:spPr>
-          <a:xfrm>
-            <a:off x="989381" y="1812341"/>
-            <a:ext cx="307238" cy="307238"/>
-          </a:xfrm>
-          <a:prstGeom prst="rect">
-            <a:avLst/>
-          </a:prstGeom>
-        </p:spPr>
-      </p:pic>
-      <p:sp>
-        <p:nvSpPr>
-          <p:cNvPr id="6" name="Text 3"/>
-          <p:cNvSpPr/>
-          <p:nvPr/>
-        </p:nvSpPr>
-        <p:spPr>
-          <a:xfrm>
-            <a:off x="1645920" y="1664208"/>
-            <a:ext cx="4114800" cy="365760"/>
+          <p:cNvPr id="3" name="Text 1"/>
+          <p:cNvSpPr/>
+          <p:nvPr/>
+        </p:nvSpPr>
+        <p:spPr>
+          <a:xfrm>
+            <a:off x="548640" y="1078992"/>
+            <a:ext cx="10881360" cy="365760"/>
           </a:xfrm>
           <a:prstGeom prst="rect">
             <a:avLst/>
@@ -6187,30 +6560,68 @@
               <a:buNone/>
             </a:pPr>
             <a:r>
-              <a:rPr lang="en-US" sz="1700" b="1" dirty="0">
+              <a:rPr lang="en-US" sz="1500" dirty="0">
                 <a:solidFill>
-                  <a:srgbClr val="111111"/>
+                  <a:srgbClr val="6E6E6E"/>
                 </a:solidFill>
                 <a:latin typeface="Arial" pitchFamily="34" charset="0"/>
                 <a:ea typeface="Arial" pitchFamily="34" charset="-122"/>
                 <a:cs typeface="Arial" pitchFamily="34" charset="-120"/>
               </a:rPr>
-              <a:t>Option A — % of RCV</a:t>
-            </a:r>
-            <a:endParaRPr lang="en-US" sz="1700" dirty="0"/>
-          </a:p>
-        </p:txBody>
-      </p:sp>
-      <p:sp>
-        <p:nvSpPr>
-          <p:cNvPr id="7" name="Text 4"/>
-          <p:cNvSpPr/>
-          <p:nvPr/>
-        </p:nvSpPr>
-        <p:spPr>
-          <a:xfrm>
-            <a:off x="1645920" y="2048256"/>
-            <a:ext cx="4114800" cy="274320"/>
+              <a:t>Same 100 scoped leads, five close rates. The fee % rises — the pie rises much faster.</a:t>
+            </a:r>
+            <a:endParaRPr lang="en-US" sz="1500" dirty="0"/>
+          </a:p>
+        </p:txBody>
+      </p:sp>
+      <p:graphicFrame>
+        <p:nvGraphicFramePr>
+          <p:cNvPr id="4" name="Chart 0" descr=""/>
+          <p:cNvGraphicFramePr/>
+          <p:nvPr/>
+        </p:nvGraphicFramePr>
+        <p:xfrm>
+          <a:off x="548640" y="1600200"/>
+          <a:ext cx="11064240" cy="3749040"/>
+        </p:xfrm>
+        <a:graphic xmlns:a="http://schemas.openxmlformats.org/drawingml/2006/main">
+          <a:graphicData uri="http://schemas.openxmlformats.org/drawingml/2006/chart">
+            <c:chart xmlns:c="http://schemas.openxmlformats.org/drawingml/2006/chart" r:id="rId1"/>
+          </a:graphicData>
+        </a:graphic>
+      </p:graphicFrame>
+      <p:sp>
+        <p:nvSpPr>
+          <p:cNvPr id="5" name="Shape 2"/>
+          <p:cNvSpPr/>
+          <p:nvPr/>
+        </p:nvSpPr>
+        <p:spPr>
+          <a:xfrm>
+            <a:off x="548640" y="5532120"/>
+            <a:ext cx="11064240" cy="731520"/>
+          </a:xfrm>
+          <a:prstGeom prst="roundRect">
+            <a:avLst>
+              <a:gd name="adj" fmla="val 7500"/>
+            </a:avLst>
+          </a:prstGeom>
+          <a:solidFill>
+            <a:srgbClr val="111111"/>
+          </a:solidFill>
+          <a:ln/>
+        </p:spPr>
+      </p:sp>
+      <p:sp>
+        <p:nvSpPr>
+          <p:cNvPr id="6" name="Text 3"/>
+          <p:cNvSpPr/>
+          <p:nvPr/>
+        </p:nvSpPr>
+        <p:spPr>
+          <a:xfrm>
+            <a:off x="868680" y="5650992"/>
+            <a:ext cx="10515600" cy="502920"/>
           </a:xfrm>
           <a:prstGeom prst="rect">
             <a:avLst/>
@@ -6226,476 +6637,76 @@
               <a:buNone/>
             </a:pPr>
             <a:r>
-              <a:rPr lang="en-US" sz="1150" i="1" dirty="0">
+              <a:rPr lang="en-US" sz="1500" b="1" dirty="0">
                 <a:solidFill>
-                  <a:srgbClr val="C8102E"/>
+                  <a:srgbClr val="FFFFFF"/>
                 </a:solidFill>
                 <a:latin typeface="Arial" pitchFamily="34" charset="0"/>
                 <a:ea typeface="Arial" pitchFamily="34" charset="-122"/>
                 <a:cs typeface="Arial" pitchFamily="34" charset="-120"/>
               </a:rPr>
-              <a:t>the numbers shown so far</a:t>
-            </a:r>
-            <a:endParaRPr lang="en-US" sz="1150" dirty="0"/>
-          </a:p>
-        </p:txBody>
-      </p:sp>
-      <p:sp>
-        <p:nvSpPr>
-          <p:cNvPr id="8" name="Text 5"/>
-          <p:cNvSpPr/>
-          <p:nvPr/>
-        </p:nvSpPr>
-        <p:spPr>
-          <a:xfrm>
-            <a:off x="868680" y="2514600"/>
-            <a:ext cx="4754880" cy="2651760"/>
-          </a:xfrm>
-          <a:prstGeom prst="rect">
-            <a:avLst/>
-          </a:prstGeom>
-          <a:noFill/>
-          <a:ln/>
-        </p:spPr>
-        <p:txBody>
-          <a:bodyPr wrap="square" lIns="0" tIns="0" rIns="0" bIns="0" rtlCol="0" anchor="ctr"/>
-          <a:lstStyle/>
-          <a:p>
-            <a:pPr marL="342900" indent="-342900">
-              <a:spcAft>
-                <a:spcPts val="800"/>
-              </a:spcAft>
-              <a:buSzPct val="100000"/>
-              <a:buChar char="•"/>
+              <a:t>Top of the slider = T^Rock's take is up nearly 4×. </a:t>
+            </a:r>
+            <a:pPr indent="0" marL="0">
+              <a:buNone/>
             </a:pPr>
             <a:r>
-              <a:rPr lang="en-US" sz="1250" dirty="0">
+              <a:rPr lang="en-US" sz="1500" dirty="0">
                 <a:solidFill>
-                  <a:srgbClr val="2A2A2A"/>
+                  <a:srgbClr val="E6E6E6"/>
                 </a:solidFill>
                 <a:latin typeface="Arial" pitchFamily="34" charset="0"/>
                 <a:ea typeface="Arial" pitchFamily="34" charset="-122"/>
                 <a:cs typeface="Arial" pitchFamily="34" charset="-120"/>
               </a:rPr>
-              <a:t>Verified straight off the carrier paperwork — no accounting disputes, ever</a:t>
-            </a:r>
-            <a:endParaRPr lang="en-US" sz="1250" dirty="0"/>
-          </a:p>
-          <a:p>
-            <a:pPr marL="342900" indent="-342900">
-              <a:spcAft>
-                <a:spcPts val="800"/>
-              </a:spcAft>
-              <a:buSzPct val="100000"/>
-              <a:buChar char="•"/>
+              <a:t>The higher fee is only ever paid out of jobs that already closed — the plan cannot cost money in a bad quarter.</a:t>
+            </a:r>
+            <a:endParaRPr lang="en-US" sz="1500" dirty="0"/>
+          </a:p>
+        </p:txBody>
+      </p:sp>
+      <p:sp>
+        <p:nvSpPr>
+          <p:cNvPr id="7" name="Text 4"/>
+          <p:cNvSpPr/>
+          <p:nvPr/>
+        </p:nvSpPr>
+        <p:spPr>
+          <a:xfrm>
+            <a:off x="548640" y="6473952"/>
+            <a:ext cx="9601200" cy="274320"/>
+          </a:xfrm>
+          <a:prstGeom prst="rect">
+            <a:avLst/>
+          </a:prstGeom>
+          <a:noFill/>
+          <a:ln/>
+        </p:spPr>
+        <p:txBody>
+          <a:bodyPr wrap="square" lIns="0" tIns="0" rIns="0" bIns="0" rtlCol="0" anchor="ctr"/>
+          <a:lstStyle/>
+          <a:p>
+            <a:pPr indent="0" marL="0">
+              <a:buNone/>
             </a:pPr>
             <a:r>
-              <a:rPr lang="en-US" sz="1250" dirty="0">
+              <a:rPr lang="en-US" sz="900" dirty="0">
                 <a:solidFill>
-                  <a:srgbClr val="2A2A2A"/>
+                  <a:srgbClr val="6E6E6E"/>
                 </a:solidFill>
                 <a:latin typeface="Arial" pitchFamily="34" charset="0"/>
                 <a:ea typeface="Arial" pitchFamily="34" charset="-122"/>
                 <a:cs typeface="Arial" pitchFamily="34" charset="-120"/>
               </a:rPr>
-              <a:t>Insulated from cost overruns neither side controls</a:t>
-            </a:r>
-            <a:endParaRPr lang="en-US" sz="1250" dirty="0"/>
-          </a:p>
-          <a:p>
-            <a:pPr marL="342900" indent="-342900">
-              <a:spcAft>
-                <a:spcPts val="800"/>
-              </a:spcAft>
-              <a:buSzPct val="100000"/>
-              <a:buChar char="•"/>
-            </a:pPr>
-            <a:r>
-              <a:rPr lang="en-US" sz="1250" dirty="0">
-                <a:solidFill>
-                  <a:srgbClr val="2A2A2A"/>
-                </a:solidFill>
-                <a:latin typeface="Arial" pitchFamily="34" charset="0"/>
-                <a:ea typeface="Arial" pitchFamily="34" charset="-122"/>
-                <a:cs typeface="Arial" pitchFamily="34" charset="-120"/>
-              </a:rPr>
-              <a:t>Slider band: 2% → 10% of RCV</a:t>
-            </a:r>
-            <a:endParaRPr lang="en-US" sz="1250" dirty="0"/>
-          </a:p>
-          <a:p>
-            <a:pPr marL="342900" indent="-342900">
-              <a:buSzPct val="100000"/>
-              <a:buChar char="•"/>
-            </a:pPr>
-            <a:r>
-              <a:rPr lang="en-US" sz="1250" dirty="0">
-                <a:solidFill>
-                  <a:srgbClr val="2A2A2A"/>
-                </a:solidFill>
-                <a:latin typeface="Arial" pitchFamily="34" charset="0"/>
-                <a:ea typeface="Arial" pitchFamily="34" charset="-122"/>
-                <a:cs typeface="Arial" pitchFamily="34" charset="-120"/>
-              </a:rPr>
-              <a:t>At 50% close: 5% × $30,000 = $1,500 per closed job</a:t>
-            </a:r>
-            <a:endParaRPr lang="en-US" sz="1250" dirty="0"/>
-          </a:p>
-        </p:txBody>
-      </p:sp>
-      <p:sp>
-        <p:nvSpPr>
-          <p:cNvPr id="9" name="Shape 6"/>
-          <p:cNvSpPr/>
-          <p:nvPr/>
-        </p:nvSpPr>
-        <p:spPr>
-          <a:xfrm>
-            <a:off x="6217920" y="1371600"/>
-            <a:ext cx="5394960" cy="3977640"/>
-          </a:xfrm>
-          <a:prstGeom prst="roundRect">
-            <a:avLst>
-              <a:gd name="adj" fmla="val 1839"/>
-            </a:avLst>
-          </a:prstGeom>
-          <a:solidFill>
-            <a:srgbClr val="F5F5F5"/>
-          </a:solidFill>
-          <a:ln/>
-        </p:spPr>
-      </p:sp>
-      <p:sp>
-        <p:nvSpPr>
-          <p:cNvPr id="10" name="Shape 7"/>
-          <p:cNvSpPr/>
-          <p:nvPr/>
-        </p:nvSpPr>
-        <p:spPr>
-          <a:xfrm>
-            <a:off x="6492240" y="1645920"/>
-            <a:ext cx="640080" cy="640080"/>
-          </a:xfrm>
-          <a:prstGeom prst="ellipse">
-            <a:avLst/>
-          </a:prstGeom>
-          <a:solidFill>
-            <a:srgbClr val="C8102E"/>
-          </a:solidFill>
-          <a:ln/>
-        </p:spPr>
-      </p:sp>
-      <p:pic>
-        <p:nvPicPr>
-          <p:cNvPr id="11" name="Image 1" descr="preencoded.png">    </p:cNvPr>
-          <p:cNvPicPr>
-            <a:picLocks noChangeAspect="1"/>
-          </p:cNvPicPr>
-          <p:nvPr/>
-        </p:nvPicPr>
-        <p:blipFill>
-          <a:blip r:embed="rId2"/>
-          <a:stretch>
-            <a:fillRect/>
-          </a:stretch>
-        </p:blipFill>
-        <p:spPr>
-          <a:xfrm>
-            <a:off x="6658661" y="1812341"/>
-            <a:ext cx="307238" cy="307238"/>
-          </a:xfrm>
-          <a:prstGeom prst="rect">
-            <a:avLst/>
-          </a:prstGeom>
-        </p:spPr>
-      </p:pic>
-      <p:sp>
-        <p:nvSpPr>
-          <p:cNvPr id="12" name="Text 8"/>
-          <p:cNvSpPr/>
-          <p:nvPr/>
-        </p:nvSpPr>
-        <p:spPr>
-          <a:xfrm>
-            <a:off x="7315200" y="1664208"/>
-            <a:ext cx="4114800" cy="365760"/>
-          </a:xfrm>
-          <a:prstGeom prst="rect">
-            <a:avLst/>
-          </a:prstGeom>
-          <a:noFill/>
-          <a:ln/>
-        </p:spPr>
-        <p:txBody>
-          <a:bodyPr wrap="square" lIns="0" tIns="0" rIns="0" bIns="0" rtlCol="0" anchor="ctr"/>
-          <a:lstStyle/>
-          <a:p>
-            <a:pPr indent="0" marL="0">
-              <a:buNone/>
-            </a:pPr>
-            <a:r>
-              <a:rPr lang="en-US" sz="1700" b="1" dirty="0">
-                <a:solidFill>
-                  <a:srgbClr val="111111"/>
-                </a:solidFill>
-                <a:latin typeface="Arial" pitchFamily="34" charset="0"/>
-                <a:ea typeface="Arial" pitchFamily="34" charset="-122"/>
-                <a:cs typeface="Arial" pitchFamily="34" charset="-120"/>
-              </a:rPr>
-              <a:t>Option B — % of job profit</a:t>
-            </a:r>
-            <a:endParaRPr lang="en-US" sz="1700" dirty="0"/>
-          </a:p>
-        </p:txBody>
-      </p:sp>
-      <p:sp>
-        <p:nvSpPr>
-          <p:cNvPr id="13" name="Text 9"/>
-          <p:cNvSpPr/>
-          <p:nvPr/>
-        </p:nvSpPr>
-        <p:spPr>
-          <a:xfrm>
-            <a:off x="7315200" y="2048256"/>
-            <a:ext cx="4114800" cy="274320"/>
-          </a:xfrm>
-          <a:prstGeom prst="rect">
-            <a:avLst/>
-          </a:prstGeom>
-          <a:noFill/>
-          <a:ln/>
-        </p:spPr>
-        <p:txBody>
-          <a:bodyPr wrap="square" lIns="0" tIns="0" rIns="0" bIns="0" rtlCol="0" anchor="ctr"/>
-          <a:lstStyle/>
-          <a:p>
-            <a:pPr indent="0" marL="0">
-              <a:buNone/>
-            </a:pPr>
-            <a:r>
-              <a:rPr lang="en-US" sz="1150" i="1" dirty="0">
-                <a:solidFill>
-                  <a:srgbClr val="C8102E"/>
-                </a:solidFill>
-                <a:latin typeface="Arial" pitchFamily="34" charset="0"/>
-                <a:ea typeface="Arial" pitchFamily="34" charset="-122"/>
-                <a:cs typeface="Arial" pitchFamily="34" charset="-120"/>
-              </a:rPr>
-              <a:t>equivalent dollars, different base</a:t>
-            </a:r>
-            <a:endParaRPr lang="en-US" sz="1150" dirty="0"/>
-          </a:p>
-        </p:txBody>
-      </p:sp>
-      <p:sp>
-        <p:nvSpPr>
-          <p:cNvPr id="14" name="Text 10"/>
-          <p:cNvSpPr/>
-          <p:nvPr/>
-        </p:nvSpPr>
-        <p:spPr>
-          <a:xfrm>
-            <a:off x="6537960" y="2514600"/>
-            <a:ext cx="4754880" cy="2651760"/>
-          </a:xfrm>
-          <a:prstGeom prst="rect">
-            <a:avLst/>
-          </a:prstGeom>
-          <a:noFill/>
-          <a:ln/>
-        </p:spPr>
-        <p:txBody>
-          <a:bodyPr wrap="square" lIns="0" tIns="0" rIns="0" bIns="0" rtlCol="0" anchor="ctr"/>
-          <a:lstStyle/>
-          <a:p>
-            <a:pPr marL="342900" indent="-342900">
-              <a:spcAft>
-                <a:spcPts val="800"/>
-              </a:spcAft>
-              <a:buSzPct val="100000"/>
-              <a:buChar char="•"/>
-            </a:pPr>
-            <a:r>
-              <a:rPr lang="en-US" sz="1250" dirty="0">
-                <a:solidFill>
-                  <a:srgbClr val="2A2A2A"/>
-                </a:solidFill>
-                <a:latin typeface="Arial" pitchFamily="34" charset="0"/>
-                <a:ea typeface="Arial" pitchFamily="34" charset="-122"/>
-                <a:cs typeface="Arial" pitchFamily="34" charset="-120"/>
-              </a:rPr>
-              <a:t>Scales with margin — the fee shrinks automatically on thin jobs</a:t>
-            </a:r>
-            <a:endParaRPr lang="en-US" sz="1250" dirty="0"/>
-          </a:p>
-          <a:p>
-            <a:pPr marL="342900" indent="-342900">
-              <a:spcAft>
-                <a:spcPts val="800"/>
-              </a:spcAft>
-              <a:buSzPct val="100000"/>
-              <a:buChar char="•"/>
-            </a:pPr>
-            <a:r>
-              <a:rPr lang="en-US" sz="1250" dirty="0">
-                <a:solidFill>
-                  <a:srgbClr val="2A2A2A"/>
-                </a:solidFill>
-                <a:latin typeface="Arial" pitchFamily="34" charset="0"/>
-                <a:ea typeface="Arial" pitchFamily="34" charset="-122"/>
-                <a:cs typeface="Arial" pitchFamily="34" charset="-120"/>
-              </a:rPr>
-              <a:t>Requires open-book job costing both sides trust</a:t>
-            </a:r>
-            <a:endParaRPr lang="en-US" sz="1250" dirty="0"/>
-          </a:p>
-          <a:p>
-            <a:pPr marL="342900" indent="-342900">
-              <a:spcAft>
-                <a:spcPts val="800"/>
-              </a:spcAft>
-              <a:buSzPct val="100000"/>
-              <a:buChar char="•"/>
-            </a:pPr>
-            <a:r>
-              <a:rPr lang="en-US" sz="1250" dirty="0">
-                <a:solidFill>
-                  <a:srgbClr val="2A2A2A"/>
-                </a:solidFill>
-                <a:latin typeface="Arial" pitchFamily="34" charset="0"/>
-                <a:ea typeface="Arial" pitchFamily="34" charset="-122"/>
-                <a:cs typeface="Arial" pitchFamily="34" charset="-120"/>
-              </a:rPr>
-              <a:t>Equivalent slider band: ~6% → 28% of job gross profit</a:t>
-            </a:r>
-            <a:endParaRPr lang="en-US" sz="1250" dirty="0"/>
-          </a:p>
-          <a:p>
-            <a:pPr marL="342900" indent="-342900">
-              <a:buSzPct val="100000"/>
-              <a:buChar char="•"/>
-            </a:pPr>
-            <a:r>
-              <a:rPr lang="en-US" sz="1250" dirty="0">
-                <a:solidFill>
-                  <a:srgbClr val="2A2A2A"/>
-                </a:solidFill>
-                <a:latin typeface="Arial" pitchFamily="34" charset="0"/>
-                <a:ea typeface="Arial" pitchFamily="34" charset="-122"/>
-                <a:cs typeface="Arial" pitchFamily="34" charset="-120"/>
-              </a:rPr>
-              <a:t>At 50% close: ~14% × $10,500 = ~$1,470 per closed job</a:t>
-            </a:r>
-            <a:endParaRPr lang="en-US" sz="1250" dirty="0"/>
-          </a:p>
-        </p:txBody>
-      </p:sp>
-      <p:sp>
-        <p:nvSpPr>
-          <p:cNvPr id="15" name="Shape 11"/>
-          <p:cNvSpPr/>
-          <p:nvPr/>
-        </p:nvSpPr>
-        <p:spPr>
-          <a:xfrm>
-            <a:off x="548640" y="5532120"/>
-            <a:ext cx="11064240" cy="731520"/>
-          </a:xfrm>
-          <a:prstGeom prst="roundRect">
-            <a:avLst>
-              <a:gd name="adj" fmla="val 7500"/>
-            </a:avLst>
-          </a:prstGeom>
-          <a:solidFill>
-            <a:srgbClr val="FBEAEC"/>
-          </a:solidFill>
-          <a:ln/>
-        </p:spPr>
-      </p:sp>
-      <p:sp>
-        <p:nvSpPr>
-          <p:cNvPr id="16" name="Text 12"/>
-          <p:cNvSpPr/>
-          <p:nvPr/>
-        </p:nvSpPr>
-        <p:spPr>
-          <a:xfrm>
-            <a:off x="868680" y="5669280"/>
-            <a:ext cx="10515600" cy="457200"/>
-          </a:xfrm>
-          <a:prstGeom prst="rect">
-            <a:avLst/>
-          </a:prstGeom>
-          <a:noFill/>
-          <a:ln/>
-        </p:spPr>
-        <p:txBody>
-          <a:bodyPr wrap="square" lIns="0" tIns="0" rIns="0" bIns="0" rtlCol="0" anchor="ctr"/>
-          <a:lstStyle/>
-          <a:p>
-            <a:pPr indent="0" marL="0">
-              <a:buNone/>
-            </a:pPr>
-            <a:r>
-              <a:rPr lang="en-US" sz="1450" b="1" dirty="0">
-                <a:solidFill>
-                  <a:srgbClr val="111111"/>
-                </a:solidFill>
-                <a:latin typeface="Arial" pitchFamily="34" charset="0"/>
-                <a:ea typeface="Arial" pitchFamily="34" charset="-122"/>
-                <a:cs typeface="Arial" pitchFamily="34" charset="-120"/>
-              </a:rPr>
-              <a:t>Same money either way at today's margins. </a:t>
-            </a:r>
-            <a:pPr indent="0" marL="0">
-              <a:buNone/>
-            </a:pPr>
-            <a:r>
-              <a:rPr lang="en-US" sz="1450" dirty="0">
-                <a:solidFill>
-                  <a:srgbClr val="2A2A2A"/>
-                </a:solidFill>
-                <a:latin typeface="Arial" pitchFamily="34" charset="0"/>
-                <a:ea typeface="Arial" pitchFamily="34" charset="-122"/>
-                <a:cs typeface="Arial" pitchFamily="34" charset="-120"/>
-              </a:rPr>
-              <a:t>A is simpler to verify; B is tighter to margin. The only wrong answer is leaving the definition verbal.</a:t>
-            </a:r>
-            <a:endParaRPr lang="en-US" sz="1450" dirty="0"/>
-          </a:p>
-        </p:txBody>
-      </p:sp>
-      <p:sp>
-        <p:nvSpPr>
-          <p:cNvPr id="17" name="Text 13"/>
-          <p:cNvSpPr/>
-          <p:nvPr/>
-        </p:nvSpPr>
-        <p:spPr>
-          <a:xfrm>
-            <a:off x="548640" y="6473952"/>
-            <a:ext cx="9601200" cy="274320"/>
-          </a:xfrm>
-          <a:prstGeom prst="rect">
-            <a:avLst/>
-          </a:prstGeom>
-          <a:noFill/>
-          <a:ln/>
-        </p:spPr>
-        <p:txBody>
-          <a:bodyPr wrap="square" lIns="0" tIns="0" rIns="0" bIns="0" rtlCol="0" anchor="ctr"/>
-          <a:lstStyle/>
-          <a:p>
-            <a:pPr indent="0" marL="0">
-              <a:buNone/>
-            </a:pPr>
+              <a:t>Per closed job: $30,000 × 35% margin, less slider fee, split 50/50 with the PM. 100 scoped leads held constant across scenarios.</a:t>
+            </a:r>
             <a:endParaRPr lang="en-US" sz="900" dirty="0"/>
           </a:p>
         </p:txBody>
       </p:sp>
       <p:sp>
         <p:nvSpPr>
-          <p:cNvPr id="18" name="Text 14"/>
+          <p:cNvPr id="8" name="Text 5"/>
           <p:cNvSpPr/>
           <p:nvPr/>
         </p:nvSpPr>
@@ -6797,7 +6808,7 @@
                 <a:ea typeface="Arial" pitchFamily="34" charset="-122"/>
                 <a:cs typeface="Arial" pitchFamily="34" charset="-120"/>
               </a:rPr>
-              <a:t>What this costs vs. the alternatives</a:t>
+              <a:t>Two ways to base it — pick one, put it in writing</a:t>
             </a:r>
             <a:endParaRPr lang="en-US" sz="3200" dirty="0"/>
           </a:p>
@@ -6805,57 +6816,18 @@
       </p:sp>
       <p:sp>
         <p:nvSpPr>
-          <p:cNvPr id="3" name="Text 1"/>
-          <p:cNvSpPr/>
-          <p:nvPr/>
-        </p:nvSpPr>
-        <p:spPr>
-          <a:xfrm>
-            <a:off x="548640" y="1097280"/>
-            <a:ext cx="10881360" cy="365760"/>
-          </a:xfrm>
-          <a:prstGeom prst="rect">
-            <a:avLst/>
-          </a:prstGeom>
-          <a:noFill/>
-          <a:ln/>
-        </p:spPr>
-        <p:txBody>
-          <a:bodyPr wrap="square" lIns="0" tIns="0" rIns="0" bIns="0" rtlCol="0" anchor="ctr"/>
-          <a:lstStyle/>
-          <a:p>
-            <a:pPr indent="0" marL="0">
-              <a:buNone/>
-            </a:pPr>
-            <a:r>
-              <a:rPr lang="en-US" sz="1500" dirty="0">
-                <a:solidFill>
-                  <a:srgbClr val="6E6E6E"/>
-                </a:solidFill>
-                <a:latin typeface="Arial" pitchFamily="34" charset="0"/>
-                <a:ea typeface="Arial" pitchFamily="34" charset="-122"/>
-                <a:cs typeface="Arial" pitchFamily="34" charset="-120"/>
-              </a:rPr>
-              <a:t>Every other way to buy scope writing carries fixed cost or scales with paperwork. This one scales only with collected revenue.</a:t>
-            </a:r>
-            <a:endParaRPr lang="en-US" sz="1500" dirty="0"/>
-          </a:p>
-        </p:txBody>
-      </p:sp>
-      <p:sp>
-        <p:nvSpPr>
-          <p:cNvPr id="4" name="Shape 2"/>
-          <p:cNvSpPr/>
-          <p:nvPr/>
-        </p:nvSpPr>
-        <p:spPr>
-          <a:xfrm>
-            <a:off x="548640" y="1737360"/>
-            <a:ext cx="3520440" cy="3566160"/>
+          <p:cNvPr id="3" name="Shape 1"/>
+          <p:cNvSpPr/>
+          <p:nvPr/>
+        </p:nvSpPr>
+        <p:spPr>
+          <a:xfrm>
+            <a:off x="548640" y="1371600"/>
+            <a:ext cx="5394960" cy="3977640"/>
           </a:xfrm>
           <a:prstGeom prst="roundRect">
             <a:avLst>
-              <a:gd name="adj" fmla="val 2078"/>
+              <a:gd name="adj" fmla="val 1839"/>
             </a:avLst>
           </a:prstGeom>
           <a:solidFill>
@@ -6866,14 +6838,14 @@
       </p:sp>
       <p:sp>
         <p:nvSpPr>
-          <p:cNvPr id="5" name="Shape 3"/>
-          <p:cNvSpPr/>
-          <p:nvPr/>
-        </p:nvSpPr>
-        <p:spPr>
-          <a:xfrm>
-            <a:off x="868680" y="2011680"/>
-            <a:ext cx="685800" cy="685800"/>
+          <p:cNvPr id="4" name="Shape 2"/>
+          <p:cNvSpPr/>
+          <p:nvPr/>
+        </p:nvSpPr>
+        <p:spPr>
+          <a:xfrm>
+            <a:off x="822960" y="1645920"/>
+            <a:ext cx="640080" cy="640080"/>
           </a:xfrm>
           <a:prstGeom prst="ellipse">
             <a:avLst/>
@@ -6886,7 +6858,7 @@
       </p:sp>
       <p:pic>
         <p:nvPicPr>
-          <p:cNvPr id="6" name="Image 0" descr="preencoded.png">    </p:cNvPr>
+          <p:cNvPr id="5" name="Image 0" descr="preencoded.png">    </p:cNvPr>
           <p:cNvPicPr>
             <a:picLocks noChangeAspect="1"/>
           </p:cNvPicPr>
@@ -6900,8 +6872,8 @@
         </p:blipFill>
         <p:spPr>
           <a:xfrm>
-            <a:off x="1046988" y="2189988"/>
-            <a:ext cx="329184" cy="329184"/>
+            <a:off x="989381" y="1812341"/>
+            <a:ext cx="307238" cy="307238"/>
           </a:xfrm>
           <a:prstGeom prst="rect">
             <a:avLst/>
@@ -6910,14 +6882,14 @@
       </p:pic>
       <p:sp>
         <p:nvSpPr>
-          <p:cNvPr id="7" name="Text 4"/>
-          <p:cNvSpPr/>
-          <p:nvPr/>
-        </p:nvSpPr>
-        <p:spPr>
-          <a:xfrm>
-            <a:off x="1691640" y="2194560"/>
-            <a:ext cx="2286000" cy="365760"/>
+          <p:cNvPr id="6" name="Text 3"/>
+          <p:cNvSpPr/>
+          <p:nvPr/>
+        </p:nvSpPr>
+        <p:spPr>
+          <a:xfrm>
+            <a:off x="1645920" y="1664208"/>
+            <a:ext cx="4114800" cy="365760"/>
           </a:xfrm>
           <a:prstGeom prst="rect">
             <a:avLst/>
@@ -6933,7 +6905,7 @@
               <a:buNone/>
             </a:pPr>
             <a:r>
-              <a:rPr lang="en-US" sz="1500" b="1" dirty="0">
+              <a:rPr lang="en-US" sz="1700" b="1" dirty="0">
                 <a:solidFill>
                   <a:srgbClr val="111111"/>
                 </a:solidFill>
@@ -6941,22 +6913,22 @@
                 <a:ea typeface="Arial" pitchFamily="34" charset="-122"/>
                 <a:cs typeface="Arial" pitchFamily="34" charset="-120"/>
               </a:rPr>
-              <a:t>Staff estimator</a:t>
-            </a:r>
-            <a:endParaRPr lang="en-US" sz="1500" dirty="0"/>
-          </a:p>
-        </p:txBody>
-      </p:sp>
-      <p:sp>
-        <p:nvSpPr>
-          <p:cNvPr id="8" name="Text 5"/>
-          <p:cNvSpPr/>
-          <p:nvPr/>
-        </p:nvSpPr>
-        <p:spPr>
-          <a:xfrm>
-            <a:off x="868680" y="2880360"/>
-            <a:ext cx="2926080" cy="777240"/>
+              <a:t>Option A — % of RCV</a:t>
+            </a:r>
+            <a:endParaRPr lang="en-US" sz="1700" dirty="0"/>
+          </a:p>
+        </p:txBody>
+      </p:sp>
+      <p:sp>
+        <p:nvSpPr>
+          <p:cNvPr id="7" name="Text 4"/>
+          <p:cNvSpPr/>
+          <p:nvPr/>
+        </p:nvSpPr>
+        <p:spPr>
+          <a:xfrm>
+            <a:off x="1645920" y="2048256"/>
+            <a:ext cx="4114800" cy="274320"/>
           </a:xfrm>
           <a:prstGeom prst="rect">
             <a:avLst/>
@@ -6972,7 +6944,7 @@
               <a:buNone/>
             </a:pPr>
             <a:r>
-              <a:rPr lang="en-US" sz="4000" b="1" dirty="0">
+              <a:rPr lang="en-US" sz="1150" i="1" dirty="0">
                 <a:solidFill>
                   <a:srgbClr val="C8102E"/>
                 </a:solidFill>
@@ -6980,22 +6952,22 @@
                 <a:ea typeface="Arial" pitchFamily="34" charset="-122"/>
                 <a:cs typeface="Arial" pitchFamily="34" charset="-120"/>
               </a:rPr>
-              <a:t>$70–90k/yr</a:t>
-            </a:r>
-            <a:endParaRPr lang="en-US" sz="4000" dirty="0"/>
-          </a:p>
-        </p:txBody>
-      </p:sp>
-      <p:sp>
-        <p:nvSpPr>
-          <p:cNvPr id="9" name="Text 6"/>
-          <p:cNvSpPr/>
-          <p:nvPr/>
-        </p:nvSpPr>
-        <p:spPr>
-          <a:xfrm>
-            <a:off x="868680" y="3749040"/>
-            <a:ext cx="2926080" cy="1417320"/>
+              <a:t>the numbers shown so far</a:t>
+            </a:r>
+            <a:endParaRPr lang="en-US" sz="1150" dirty="0"/>
+          </a:p>
+        </p:txBody>
+      </p:sp>
+      <p:sp>
+        <p:nvSpPr>
+          <p:cNvPr id="8" name="Text 5"/>
+          <p:cNvSpPr/>
+          <p:nvPr/>
+        </p:nvSpPr>
+        <p:spPr>
+          <a:xfrm>
+            <a:off x="868680" y="2514600"/>
+            <a:ext cx="4754880" cy="2651760"/>
           </a:xfrm>
           <a:prstGeom prst="rect">
             <a:avLst/>
@@ -7007,11 +6979,15 @@
           <a:bodyPr wrap="square" lIns="0" tIns="0" rIns="0" bIns="0" rtlCol="0" anchor="ctr"/>
           <a:lstStyle/>
           <a:p>
-            <a:pPr indent="0" marL="0">
-              <a:buNone/>
+            <a:pPr marL="342900" indent="-342900">
+              <a:spcAft>
+                <a:spcPts val="800"/>
+              </a:spcAft>
+              <a:buSzPct val="100000"/>
+              <a:buChar char="•"/>
             </a:pPr>
             <a:r>
-              <a:rPr lang="en-US" sz="1200" dirty="0">
+              <a:rPr lang="en-US" sz="1250" dirty="0">
                 <a:solidFill>
                   <a:srgbClr val="2A2A2A"/>
                 </a:solidFill>
@@ -7019,26 +6995,86 @@
                 <a:ea typeface="Arial" pitchFamily="34" charset="-122"/>
                 <a:cs typeface="Arial" pitchFamily="34" charset="-120"/>
               </a:rPr>
-              <a:t>Salary paid whether jobs close or not. Pure fixed overhead, plus payroll burden — and someone still has to run lead targeting.</a:t>
-            </a:r>
-            <a:endParaRPr lang="en-US" sz="1200" dirty="0"/>
-          </a:p>
-        </p:txBody>
-      </p:sp>
-      <p:sp>
-        <p:nvSpPr>
-          <p:cNvPr id="10" name="Shape 7"/>
-          <p:cNvSpPr/>
-          <p:nvPr/>
-        </p:nvSpPr>
-        <p:spPr>
-          <a:xfrm>
-            <a:off x="4343400" y="1737360"/>
-            <a:ext cx="3520440" cy="3566160"/>
+              <a:t>Verified straight off the carrier paperwork — no accounting disputes, ever</a:t>
+            </a:r>
+            <a:endParaRPr lang="en-US" sz="1250" dirty="0"/>
+          </a:p>
+          <a:p>
+            <a:pPr marL="342900" indent="-342900">
+              <a:spcAft>
+                <a:spcPts val="800"/>
+              </a:spcAft>
+              <a:buSzPct val="100000"/>
+              <a:buChar char="•"/>
+            </a:pPr>
+            <a:r>
+              <a:rPr lang="en-US" sz="1250" dirty="0">
+                <a:solidFill>
+                  <a:srgbClr val="2A2A2A"/>
+                </a:solidFill>
+                <a:latin typeface="Arial" pitchFamily="34" charset="0"/>
+                <a:ea typeface="Arial" pitchFamily="34" charset="-122"/>
+                <a:cs typeface="Arial" pitchFamily="34" charset="-120"/>
+              </a:rPr>
+              <a:t>Insulated from cost overruns neither side controls</a:t>
+            </a:r>
+            <a:endParaRPr lang="en-US" sz="1250" dirty="0"/>
+          </a:p>
+          <a:p>
+            <a:pPr marL="342900" indent="-342900">
+              <a:spcAft>
+                <a:spcPts val="800"/>
+              </a:spcAft>
+              <a:buSzPct val="100000"/>
+              <a:buChar char="•"/>
+            </a:pPr>
+            <a:r>
+              <a:rPr lang="en-US" sz="1250" dirty="0">
+                <a:solidFill>
+                  <a:srgbClr val="2A2A2A"/>
+                </a:solidFill>
+                <a:latin typeface="Arial" pitchFamily="34" charset="0"/>
+                <a:ea typeface="Arial" pitchFamily="34" charset="-122"/>
+                <a:cs typeface="Arial" pitchFamily="34" charset="-120"/>
+              </a:rPr>
+              <a:t>Slider band: 2% → 10% of RCV</a:t>
+            </a:r>
+            <a:endParaRPr lang="en-US" sz="1250" dirty="0"/>
+          </a:p>
+          <a:p>
+            <a:pPr marL="342900" indent="-342900">
+              <a:buSzPct val="100000"/>
+              <a:buChar char="•"/>
+            </a:pPr>
+            <a:r>
+              <a:rPr lang="en-US" sz="1250" dirty="0">
+                <a:solidFill>
+                  <a:srgbClr val="2A2A2A"/>
+                </a:solidFill>
+                <a:latin typeface="Arial" pitchFamily="34" charset="0"/>
+                <a:ea typeface="Arial" pitchFamily="34" charset="-122"/>
+                <a:cs typeface="Arial" pitchFamily="34" charset="-120"/>
+              </a:rPr>
+              <a:t>At 50% close: 5% × $30,000 = $1,500 per closed job</a:t>
+            </a:r>
+            <a:endParaRPr lang="en-US" sz="1250" dirty="0"/>
+          </a:p>
+        </p:txBody>
+      </p:sp>
+      <p:sp>
+        <p:nvSpPr>
+          <p:cNvPr id="9" name="Shape 6"/>
+          <p:cNvSpPr/>
+          <p:nvPr/>
+        </p:nvSpPr>
+        <p:spPr>
+          <a:xfrm>
+            <a:off x="6217920" y="1371600"/>
+            <a:ext cx="5394960" cy="3977640"/>
           </a:xfrm>
           <a:prstGeom prst="roundRect">
             <a:avLst>
-              <a:gd name="adj" fmla="val 2078"/>
+              <a:gd name="adj" fmla="val 1839"/>
             </a:avLst>
           </a:prstGeom>
           <a:solidFill>
@@ -7049,14 +7085,14 @@
       </p:sp>
       <p:sp>
         <p:nvSpPr>
-          <p:cNvPr id="11" name="Shape 8"/>
-          <p:cNvSpPr/>
-          <p:nvPr/>
-        </p:nvSpPr>
-        <p:spPr>
-          <a:xfrm>
-            <a:off x="4663440" y="2011680"/>
-            <a:ext cx="685800" cy="685800"/>
+          <p:cNvPr id="10" name="Shape 7"/>
+          <p:cNvSpPr/>
+          <p:nvPr/>
+        </p:nvSpPr>
+        <p:spPr>
+          <a:xfrm>
+            <a:off x="6492240" y="1645920"/>
+            <a:ext cx="640080" cy="640080"/>
           </a:xfrm>
           <a:prstGeom prst="ellipse">
             <a:avLst/>
@@ -7069,7 +7105,7 @@
       </p:sp>
       <p:pic>
         <p:nvPicPr>
-          <p:cNvPr id="12" name="Image 1" descr="preencoded.png">    </p:cNvPr>
+          <p:cNvPr id="11" name="Image 1" descr="preencoded.png">    </p:cNvPr>
           <p:cNvPicPr>
             <a:picLocks noChangeAspect="1"/>
           </p:cNvPicPr>
@@ -7083,8 +7119,8 @@
         </p:blipFill>
         <p:spPr>
           <a:xfrm>
-            <a:off x="4841748" y="2189988"/>
-            <a:ext cx="329184" cy="329184"/>
+            <a:off x="6658661" y="1812341"/>
+            <a:ext cx="307238" cy="307238"/>
           </a:xfrm>
           <a:prstGeom prst="rect">
             <a:avLst/>
@@ -7093,14 +7129,14 @@
       </p:pic>
       <p:sp>
         <p:nvSpPr>
-          <p:cNvPr id="13" name="Text 9"/>
-          <p:cNvSpPr/>
-          <p:nvPr/>
-        </p:nvSpPr>
-        <p:spPr>
-          <a:xfrm>
-            <a:off x="5486400" y="2194560"/>
-            <a:ext cx="2286000" cy="365760"/>
+          <p:cNvPr id="12" name="Text 8"/>
+          <p:cNvSpPr/>
+          <p:nvPr/>
+        </p:nvSpPr>
+        <p:spPr>
+          <a:xfrm>
+            <a:off x="7315200" y="1664208"/>
+            <a:ext cx="4114800" cy="365760"/>
           </a:xfrm>
           <a:prstGeom prst="rect">
             <a:avLst/>
@@ -7116,7 +7152,7 @@
               <a:buNone/>
             </a:pPr>
             <a:r>
-              <a:rPr lang="en-US" sz="1500" b="1" dirty="0">
+              <a:rPr lang="en-US" sz="1700" b="1" dirty="0">
                 <a:solidFill>
                   <a:srgbClr val="111111"/>
                 </a:solidFill>
@@ -7124,22 +7160,22 @@
                 <a:ea typeface="Arial" pitchFamily="34" charset="-122"/>
                 <a:cs typeface="Arial" pitchFamily="34" charset="-120"/>
               </a:rPr>
-              <a:t>Supplement service</a:t>
-            </a:r>
-            <a:endParaRPr lang="en-US" sz="1500" dirty="0"/>
-          </a:p>
-        </p:txBody>
-      </p:sp>
-      <p:sp>
-        <p:nvSpPr>
-          <p:cNvPr id="14" name="Text 10"/>
-          <p:cNvSpPr/>
-          <p:nvPr/>
-        </p:nvSpPr>
-        <p:spPr>
-          <a:xfrm>
-            <a:off x="4663440" y="2880360"/>
-            <a:ext cx="2926080" cy="777240"/>
+              <a:t>Option B — % of job profit</a:t>
+            </a:r>
+            <a:endParaRPr lang="en-US" sz="1700" dirty="0"/>
+          </a:p>
+        </p:txBody>
+      </p:sp>
+      <p:sp>
+        <p:nvSpPr>
+          <p:cNvPr id="13" name="Text 9"/>
+          <p:cNvSpPr/>
+          <p:nvPr/>
+        </p:nvSpPr>
+        <p:spPr>
+          <a:xfrm>
+            <a:off x="7315200" y="2048256"/>
+            <a:ext cx="4114800" cy="274320"/>
           </a:xfrm>
           <a:prstGeom prst="rect">
             <a:avLst/>
@@ -7155,7 +7191,7 @@
               <a:buNone/>
             </a:pPr>
             <a:r>
-              <a:rPr lang="en-US" sz="4000" b="1" dirty="0">
+              <a:rPr lang="en-US" sz="1150" i="1" dirty="0">
                 <a:solidFill>
                   <a:srgbClr val="C8102E"/>
                 </a:solidFill>
@@ -7163,22 +7199,22 @@
                 <a:ea typeface="Arial" pitchFamily="34" charset="-122"/>
                 <a:cs typeface="Arial" pitchFamily="34" charset="-120"/>
               </a:rPr>
-              <a:t>25–33%</a:t>
-            </a:r>
-            <a:endParaRPr lang="en-US" sz="4000" dirty="0"/>
-          </a:p>
-        </p:txBody>
-      </p:sp>
-      <p:sp>
-        <p:nvSpPr>
-          <p:cNvPr id="15" name="Text 11"/>
-          <p:cNvSpPr/>
-          <p:nvPr/>
-        </p:nvSpPr>
-        <p:spPr>
-          <a:xfrm>
-            <a:off x="4663440" y="3749040"/>
-            <a:ext cx="2926080" cy="1417320"/>
+              <a:t>equivalent dollars, different base</a:t>
+            </a:r>
+            <a:endParaRPr lang="en-US" sz="1150" dirty="0"/>
+          </a:p>
+        </p:txBody>
+      </p:sp>
+      <p:sp>
+        <p:nvSpPr>
+          <p:cNvPr id="14" name="Text 10"/>
+          <p:cNvSpPr/>
+          <p:nvPr/>
+        </p:nvSpPr>
+        <p:spPr>
+          <a:xfrm>
+            <a:off x="6537960" y="2514600"/>
+            <a:ext cx="4754880" cy="2651760"/>
           </a:xfrm>
           <a:prstGeom prst="rect">
             <a:avLst/>
@@ -7190,11 +7226,15 @@
           <a:bodyPr wrap="square" lIns="0" tIns="0" rIns="0" bIns="0" rtlCol="0" anchor="ctr"/>
           <a:lstStyle/>
           <a:p>
-            <a:pPr indent="0" marL="0">
-              <a:buNone/>
+            <a:pPr marL="342900" indent="-342900">
+              <a:spcAft>
+                <a:spcPts val="800"/>
+              </a:spcAft>
+              <a:buSzPct val="100000"/>
+              <a:buChar char="•"/>
             </a:pPr>
             <a:r>
-              <a:rPr lang="en-US" sz="1200" dirty="0">
+              <a:rPr lang="en-US" sz="1250" dirty="0">
                 <a:solidFill>
                   <a:srgbClr val="2A2A2A"/>
                 </a:solidFill>
@@ -7202,205 +7242,104 @@
                 <a:ea typeface="Arial" pitchFamily="34" charset="-122"/>
                 <a:cs typeface="Arial" pitchFamily="34" charset="-120"/>
               </a:rPr>
-              <a:t>of every supplement dollar they add — cost scales with paperwork volume, not with closed jobs, and they touch nothing else.</a:t>
-            </a:r>
-            <a:endParaRPr lang="en-US" sz="1200" dirty="0"/>
-          </a:p>
-        </p:txBody>
-      </p:sp>
-      <p:sp>
-        <p:nvSpPr>
-          <p:cNvPr id="16" name="Shape 12"/>
-          <p:cNvSpPr/>
-          <p:nvPr/>
-        </p:nvSpPr>
-        <p:spPr>
-          <a:xfrm>
-            <a:off x="8138160" y="1737360"/>
-            <a:ext cx="3520440" cy="3566160"/>
-          </a:xfrm>
-          <a:prstGeom prst="roundRect">
-            <a:avLst>
-              <a:gd name="adj" fmla="val 2078"/>
-            </a:avLst>
-          </a:prstGeom>
-          <a:solidFill>
-            <a:srgbClr val="111111"/>
-          </a:solidFill>
-          <a:ln/>
-        </p:spPr>
-      </p:sp>
-      <p:sp>
-        <p:nvSpPr>
-          <p:cNvPr id="17" name="Shape 13"/>
-          <p:cNvSpPr/>
-          <p:nvPr/>
-        </p:nvSpPr>
-        <p:spPr>
-          <a:xfrm>
-            <a:off x="8458200" y="2011680"/>
-            <a:ext cx="685800" cy="685800"/>
-          </a:xfrm>
-          <a:prstGeom prst="ellipse">
-            <a:avLst/>
-          </a:prstGeom>
-          <a:solidFill>
-            <a:srgbClr val="C8102E"/>
-          </a:solidFill>
-          <a:ln/>
-        </p:spPr>
-      </p:sp>
-      <p:pic>
-        <p:nvPicPr>
-          <p:cNvPr id="18" name="Image 2" descr="preencoded.png">    </p:cNvPr>
-          <p:cNvPicPr>
-            <a:picLocks noChangeAspect="1"/>
-          </p:cNvPicPr>
-          <p:nvPr/>
-        </p:nvPicPr>
-        <p:blipFill>
-          <a:blip r:embed="rId3"/>
-          <a:stretch>
-            <a:fillRect/>
-          </a:stretch>
-        </p:blipFill>
-        <p:spPr>
-          <a:xfrm>
-            <a:off x="8636508" y="2189988"/>
-            <a:ext cx="329184" cy="329184"/>
-          </a:xfrm>
-          <a:prstGeom prst="rect">
-            <a:avLst/>
-          </a:prstGeom>
-        </p:spPr>
-      </p:pic>
-      <p:sp>
-        <p:nvSpPr>
-          <p:cNvPr id="19" name="Text 14"/>
-          <p:cNvSpPr/>
-          <p:nvPr/>
-        </p:nvSpPr>
-        <p:spPr>
-          <a:xfrm>
-            <a:off x="9281160" y="2194560"/>
-            <a:ext cx="2286000" cy="365760"/>
-          </a:xfrm>
-          <a:prstGeom prst="rect">
-            <a:avLst/>
-          </a:prstGeom>
-          <a:noFill/>
-          <a:ln/>
-        </p:spPr>
-        <p:txBody>
-          <a:bodyPr wrap="square" lIns="0" tIns="0" rIns="0" bIns="0" rtlCol="0" anchor="ctr"/>
-          <a:lstStyle/>
-          <a:p>
-            <a:pPr indent="0" marL="0">
-              <a:buNone/>
+              <a:t>Scales with margin — the fee shrinks automatically on thin jobs</a:t>
+            </a:r>
+            <a:endParaRPr lang="en-US" sz="1250" dirty="0"/>
+          </a:p>
+          <a:p>
+            <a:pPr marL="342900" indent="-342900">
+              <a:spcAft>
+                <a:spcPts val="800"/>
+              </a:spcAft>
+              <a:buSzPct val="100000"/>
+              <a:buChar char="•"/>
             </a:pPr>
             <a:r>
-              <a:rPr lang="en-US" sz="1500" b="1" dirty="0">
+              <a:rPr lang="en-US" sz="1250" dirty="0">
                 <a:solidFill>
-                  <a:srgbClr val="FFFFFF"/>
+                  <a:srgbClr val="2A2A2A"/>
                 </a:solidFill>
                 <a:latin typeface="Arial" pitchFamily="34" charset="0"/>
                 <a:ea typeface="Arial" pitchFamily="34" charset="-122"/>
                 <a:cs typeface="Arial" pitchFamily="34" charset="-120"/>
               </a:rPr>
-              <a:t>This plan</a:t>
-            </a:r>
-            <a:endParaRPr lang="en-US" sz="1500" dirty="0"/>
-          </a:p>
-        </p:txBody>
-      </p:sp>
-      <p:sp>
-        <p:nvSpPr>
-          <p:cNvPr id="20" name="Text 15"/>
-          <p:cNvSpPr/>
-          <p:nvPr/>
-        </p:nvSpPr>
-        <p:spPr>
-          <a:xfrm>
-            <a:off x="8458200" y="2880360"/>
-            <a:ext cx="2926080" cy="777240"/>
-          </a:xfrm>
-          <a:prstGeom prst="rect">
-            <a:avLst/>
-          </a:prstGeom>
-          <a:noFill/>
-          <a:ln/>
-        </p:spPr>
-        <p:txBody>
-          <a:bodyPr wrap="square" lIns="0" tIns="0" rIns="0" bIns="0" rtlCol="0" anchor="ctr"/>
-          <a:lstStyle/>
-          <a:p>
-            <a:pPr indent="0" marL="0">
-              <a:buNone/>
+              <a:t>Requires open-book job costing both sides trust</a:t>
+            </a:r>
+            <a:endParaRPr lang="en-US" sz="1250" dirty="0"/>
+          </a:p>
+          <a:p>
+            <a:pPr marL="342900" indent="-342900">
+              <a:spcAft>
+                <a:spcPts val="800"/>
+              </a:spcAft>
+              <a:buSzPct val="100000"/>
+              <a:buChar char="•"/>
             </a:pPr>
             <a:r>
-              <a:rPr lang="en-US" sz="4000" b="1" dirty="0">
+              <a:rPr lang="en-US" sz="1250" dirty="0">
                 <a:solidFill>
-                  <a:srgbClr val="C8102E"/>
+                  <a:srgbClr val="2A2A2A"/>
                 </a:solidFill>
                 <a:latin typeface="Arial" pitchFamily="34" charset="0"/>
                 <a:ea typeface="Arial" pitchFamily="34" charset="-122"/>
                 <a:cs typeface="Arial" pitchFamily="34" charset="-120"/>
               </a:rPr>
-              <a:t>$0</a:t>
-            </a:r>
-            <a:endParaRPr lang="en-US" sz="4000" dirty="0"/>
-          </a:p>
-        </p:txBody>
-      </p:sp>
-      <p:sp>
-        <p:nvSpPr>
-          <p:cNvPr id="21" name="Text 16"/>
-          <p:cNvSpPr/>
-          <p:nvPr/>
-        </p:nvSpPr>
-        <p:spPr>
-          <a:xfrm>
-            <a:off x="8458200" y="3749040"/>
-            <a:ext cx="2926080" cy="1417320"/>
-          </a:xfrm>
-          <a:prstGeom prst="rect">
-            <a:avLst/>
-          </a:prstGeom>
-          <a:noFill/>
-          <a:ln/>
-        </p:spPr>
-        <p:txBody>
-          <a:bodyPr wrap="square" lIns="0" tIns="0" rIns="0" bIns="0" rtlCol="0" anchor="ctr"/>
-          <a:lstStyle/>
-          <a:p>
-            <a:pPr indent="0" marL="0">
-              <a:buNone/>
+              <a:t>Equivalent slider band: ~6% → 28% of job gross profit</a:t>
+            </a:r>
+            <a:endParaRPr lang="en-US" sz="1250" dirty="0"/>
+          </a:p>
+          <a:p>
+            <a:pPr marL="342900" indent="-342900">
+              <a:buSzPct val="100000"/>
+              <a:buChar char="•"/>
             </a:pPr>
             <a:r>
-              <a:rPr lang="en-US" sz="1200" dirty="0">
+              <a:rPr lang="en-US" sz="1250" dirty="0">
                 <a:solidFill>
-                  <a:srgbClr val="E0E0E0"/>
+                  <a:srgbClr val="2A2A2A"/>
                 </a:solidFill>
                 <a:latin typeface="Arial" pitchFamily="34" charset="0"/>
                 <a:ea typeface="Arial" pitchFamily="34" charset="-122"/>
                 <a:cs typeface="Arial" pitchFamily="34" charset="-120"/>
               </a:rPr>
-              <a:t>until a job closes AND the check clears. Scope writing and lead operations in one seat, booked as a job cost on collected revenue.</a:t>
-            </a:r>
-            <a:endParaRPr lang="en-US" sz="1200" dirty="0"/>
-          </a:p>
-        </p:txBody>
-      </p:sp>
-      <p:sp>
-        <p:nvSpPr>
-          <p:cNvPr id="22" name="Text 17"/>
-          <p:cNvSpPr/>
-          <p:nvPr/>
-        </p:nvSpPr>
-        <p:spPr>
-          <a:xfrm>
-            <a:off x="548640" y="6473952"/>
-            <a:ext cx="9601200" cy="274320"/>
+              <a:t>At 50% close: ~14% × $10,500 = ~$1,470 per closed job</a:t>
+            </a:r>
+            <a:endParaRPr lang="en-US" sz="1250" dirty="0"/>
+          </a:p>
+        </p:txBody>
+      </p:sp>
+      <p:sp>
+        <p:nvSpPr>
+          <p:cNvPr id="15" name="Shape 11"/>
+          <p:cNvSpPr/>
+          <p:nvPr/>
+        </p:nvSpPr>
+        <p:spPr>
+          <a:xfrm>
+            <a:off x="548640" y="5532120"/>
+            <a:ext cx="11064240" cy="731520"/>
+          </a:xfrm>
+          <a:prstGeom prst="roundRect">
+            <a:avLst>
+              <a:gd name="adj" fmla="val 7500"/>
+            </a:avLst>
+          </a:prstGeom>
+          <a:solidFill>
+            <a:srgbClr val="FBEAEC"/>
+          </a:solidFill>
+          <a:ln/>
+        </p:spPr>
+      </p:sp>
+      <p:sp>
+        <p:nvSpPr>
+          <p:cNvPr id="16" name="Text 12"/>
+          <p:cNvSpPr/>
+          <p:nvPr/>
+        </p:nvSpPr>
+        <p:spPr>
+          <a:xfrm>
+            <a:off x="868680" y="5669280"/>
+            <a:ext cx="10515600" cy="457200"/>
           </a:xfrm>
           <a:prstGeom prst="rect">
             <a:avLst/>
@@ -7416,23 +7355,65 @@
               <a:buNone/>
             </a:pPr>
             <a:r>
-              <a:rPr lang="en-US" sz="900" dirty="0">
+              <a:rPr lang="en-US" sz="1450" b="1" dirty="0">
                 <a:solidFill>
-                  <a:srgbClr val="6E6E6E"/>
+                  <a:srgbClr val="111111"/>
                 </a:solidFill>
                 <a:latin typeface="Arial" pitchFamily="34" charset="0"/>
                 <a:ea typeface="Arial" pitchFamily="34" charset="-122"/>
                 <a:cs typeface="Arial" pitchFamily="34" charset="-120"/>
               </a:rPr>
-              <a:t>Estimator salary and supplement-fee ranges are industry-typical figures for the region, not quotes.</a:t>
-            </a:r>
+              <a:t>Same money either way at today's margins. </a:t>
+            </a:r>
+            <a:pPr indent="0" marL="0">
+              <a:buNone/>
+            </a:pPr>
+            <a:r>
+              <a:rPr lang="en-US" sz="1450" dirty="0">
+                <a:solidFill>
+                  <a:srgbClr val="2A2A2A"/>
+                </a:solidFill>
+                <a:latin typeface="Arial" pitchFamily="34" charset="0"/>
+                <a:ea typeface="Arial" pitchFamily="34" charset="-122"/>
+                <a:cs typeface="Arial" pitchFamily="34" charset="-120"/>
+              </a:rPr>
+              <a:t>A is simpler to verify; B is tighter to margin. The only wrong answer is leaving the definition verbal.</a:t>
+            </a:r>
+            <a:endParaRPr lang="en-US" sz="1450" dirty="0"/>
+          </a:p>
+        </p:txBody>
+      </p:sp>
+      <p:sp>
+        <p:nvSpPr>
+          <p:cNvPr id="17" name="Text 13"/>
+          <p:cNvSpPr/>
+          <p:nvPr/>
+        </p:nvSpPr>
+        <p:spPr>
+          <a:xfrm>
+            <a:off x="548640" y="6473952"/>
+            <a:ext cx="9601200" cy="274320"/>
+          </a:xfrm>
+          <a:prstGeom prst="rect">
+            <a:avLst/>
+          </a:prstGeom>
+          <a:noFill/>
+          <a:ln/>
+        </p:spPr>
+        <p:txBody>
+          <a:bodyPr wrap="square" lIns="0" tIns="0" rIns="0" bIns="0" rtlCol="0" anchor="ctr"/>
+          <a:lstStyle/>
+          <a:p>
+            <a:pPr indent="0" marL="0">
+              <a:buNone/>
+            </a:pPr>
             <a:endParaRPr lang="en-US" sz="900" dirty="0"/>
           </a:p>
         </p:txBody>
       </p:sp>
       <p:sp>
         <p:nvSpPr>
-          <p:cNvPr id="23" name="Text 18"/>
+          <p:cNvPr id="18" name="Text 14"/>
           <p:cNvSpPr/>
           <p:nvPr/>
         </p:nvSpPr>
@@ -7480,6 +7461,743 @@
 <file path=ppt/slides/slide7.xml><?xml version="1.0" encoding="utf-8"?>
 <p:sld xmlns:a="http://schemas.openxmlformats.org/drawingml/2006/main" xmlns:r="http://schemas.openxmlformats.org/officeDocument/2006/relationships" xmlns:p="http://schemas.openxmlformats.org/presentationml/2006/main">
   <p:cSld name="Slide 7">
+    <p:bg>
+      <p:bgPr>
+        <a:solidFill>
+          <a:srgbClr val="FFFFFF"/>
+        </a:solidFill>
+      </p:bgPr>
+    </p:bg>
+    <p:spTree>
+      <p:nvGrpSpPr>
+        <p:cNvPr id="1" name=""/>
+        <p:cNvGrpSpPr/>
+        <p:nvPr/>
+      </p:nvGrpSpPr>
+      <p:grpSpPr>
+        <a:xfrm>
+          <a:off x="0" y="0"/>
+          <a:ext cx="0" cy="0"/>
+          <a:chOff x="0" y="0"/>
+          <a:chExt cx="0" cy="0"/>
+        </a:xfrm>
+      </p:grpSpPr>
+      <p:sp>
+        <p:nvSpPr>
+          <p:cNvPr id="2" name="Text 0"/>
+          <p:cNvSpPr/>
+          <p:nvPr/>
+        </p:nvSpPr>
+        <p:spPr>
+          <a:xfrm>
+            <a:off x="548640" y="411480"/>
+            <a:ext cx="11064240" cy="640080"/>
+          </a:xfrm>
+          <a:prstGeom prst="rect">
+            <a:avLst/>
+          </a:prstGeom>
+          <a:noFill/>
+          <a:ln/>
+        </p:spPr>
+        <p:txBody>
+          <a:bodyPr wrap="square" lIns="0" tIns="0" rIns="0" bIns="0" rtlCol="0" anchor="ctr"/>
+          <a:lstStyle/>
+          <a:p>
+            <a:pPr indent="0" marL="0">
+              <a:buNone/>
+            </a:pPr>
+            <a:r>
+              <a:rPr lang="en-US" sz="3200" b="1" dirty="0">
+                <a:solidFill>
+                  <a:srgbClr val="111111"/>
+                </a:solidFill>
+                <a:latin typeface="Arial" pitchFamily="34" charset="0"/>
+                <a:ea typeface="Arial" pitchFamily="34" charset="-122"/>
+                <a:cs typeface="Arial" pitchFamily="34" charset="-120"/>
+              </a:rPr>
+              <a:t>What this costs vs. the alternatives</a:t>
+            </a:r>
+            <a:endParaRPr lang="en-US" sz="3200" dirty="0"/>
+          </a:p>
+        </p:txBody>
+      </p:sp>
+      <p:sp>
+        <p:nvSpPr>
+          <p:cNvPr id="3" name="Text 1"/>
+          <p:cNvSpPr/>
+          <p:nvPr/>
+        </p:nvSpPr>
+        <p:spPr>
+          <a:xfrm>
+            <a:off x="548640" y="1097280"/>
+            <a:ext cx="10881360" cy="365760"/>
+          </a:xfrm>
+          <a:prstGeom prst="rect">
+            <a:avLst/>
+          </a:prstGeom>
+          <a:noFill/>
+          <a:ln/>
+        </p:spPr>
+        <p:txBody>
+          <a:bodyPr wrap="square" lIns="0" tIns="0" rIns="0" bIns="0" rtlCol="0" anchor="ctr"/>
+          <a:lstStyle/>
+          <a:p>
+            <a:pPr indent="0" marL="0">
+              <a:buNone/>
+            </a:pPr>
+            <a:r>
+              <a:rPr lang="en-US" sz="1500" dirty="0">
+                <a:solidFill>
+                  <a:srgbClr val="6E6E6E"/>
+                </a:solidFill>
+                <a:latin typeface="Arial" pitchFamily="34" charset="0"/>
+                <a:ea typeface="Arial" pitchFamily="34" charset="-122"/>
+                <a:cs typeface="Arial" pitchFamily="34" charset="-120"/>
+              </a:rPr>
+              <a:t>Every other way to buy scope writing carries fixed cost or scales with paperwork. This one scales only with collected revenue.</a:t>
+            </a:r>
+            <a:endParaRPr lang="en-US" sz="1500" dirty="0"/>
+          </a:p>
+        </p:txBody>
+      </p:sp>
+      <p:sp>
+        <p:nvSpPr>
+          <p:cNvPr id="4" name="Shape 2"/>
+          <p:cNvSpPr/>
+          <p:nvPr/>
+        </p:nvSpPr>
+        <p:spPr>
+          <a:xfrm>
+            <a:off x="548640" y="1737360"/>
+            <a:ext cx="3520440" cy="3566160"/>
+          </a:xfrm>
+          <a:prstGeom prst="roundRect">
+            <a:avLst>
+              <a:gd name="adj" fmla="val 2078"/>
+            </a:avLst>
+          </a:prstGeom>
+          <a:solidFill>
+            <a:srgbClr val="F5F5F5"/>
+          </a:solidFill>
+          <a:ln/>
+        </p:spPr>
+      </p:sp>
+      <p:sp>
+        <p:nvSpPr>
+          <p:cNvPr id="5" name="Shape 3"/>
+          <p:cNvSpPr/>
+          <p:nvPr/>
+        </p:nvSpPr>
+        <p:spPr>
+          <a:xfrm>
+            <a:off x="868680" y="2011680"/>
+            <a:ext cx="685800" cy="685800"/>
+          </a:xfrm>
+          <a:prstGeom prst="ellipse">
+            <a:avLst/>
+          </a:prstGeom>
+          <a:solidFill>
+            <a:srgbClr val="C8102E"/>
+          </a:solidFill>
+          <a:ln/>
+        </p:spPr>
+      </p:sp>
+      <p:pic>
+        <p:nvPicPr>
+          <p:cNvPr id="6" name="Image 0" descr="preencoded.png">    </p:cNvPr>
+          <p:cNvPicPr>
+            <a:picLocks noChangeAspect="1"/>
+          </p:cNvPicPr>
+          <p:nvPr/>
+        </p:nvPicPr>
+        <p:blipFill>
+          <a:blip r:embed="rId1"/>
+          <a:stretch>
+            <a:fillRect/>
+          </a:stretch>
+        </p:blipFill>
+        <p:spPr>
+          <a:xfrm>
+            <a:off x="1046988" y="2189988"/>
+            <a:ext cx="329184" cy="329184"/>
+          </a:xfrm>
+          <a:prstGeom prst="rect">
+            <a:avLst/>
+          </a:prstGeom>
+        </p:spPr>
+      </p:pic>
+      <p:sp>
+        <p:nvSpPr>
+          <p:cNvPr id="7" name="Text 4"/>
+          <p:cNvSpPr/>
+          <p:nvPr/>
+        </p:nvSpPr>
+        <p:spPr>
+          <a:xfrm>
+            <a:off x="1691640" y="2194560"/>
+            <a:ext cx="2286000" cy="365760"/>
+          </a:xfrm>
+          <a:prstGeom prst="rect">
+            <a:avLst/>
+          </a:prstGeom>
+          <a:noFill/>
+          <a:ln/>
+        </p:spPr>
+        <p:txBody>
+          <a:bodyPr wrap="square" lIns="0" tIns="0" rIns="0" bIns="0" rtlCol="0" anchor="ctr"/>
+          <a:lstStyle/>
+          <a:p>
+            <a:pPr indent="0" marL="0">
+              <a:buNone/>
+            </a:pPr>
+            <a:r>
+              <a:rPr lang="en-US" sz="1500" b="1" dirty="0">
+                <a:solidFill>
+                  <a:srgbClr val="111111"/>
+                </a:solidFill>
+                <a:latin typeface="Arial" pitchFamily="34" charset="0"/>
+                <a:ea typeface="Arial" pitchFamily="34" charset="-122"/>
+                <a:cs typeface="Arial" pitchFamily="34" charset="-120"/>
+              </a:rPr>
+              <a:t>Staff estimator</a:t>
+            </a:r>
+            <a:endParaRPr lang="en-US" sz="1500" dirty="0"/>
+          </a:p>
+        </p:txBody>
+      </p:sp>
+      <p:sp>
+        <p:nvSpPr>
+          <p:cNvPr id="8" name="Text 5"/>
+          <p:cNvSpPr/>
+          <p:nvPr/>
+        </p:nvSpPr>
+        <p:spPr>
+          <a:xfrm>
+            <a:off x="868680" y="2880360"/>
+            <a:ext cx="2926080" cy="777240"/>
+          </a:xfrm>
+          <a:prstGeom prst="rect">
+            <a:avLst/>
+          </a:prstGeom>
+          <a:noFill/>
+          <a:ln/>
+        </p:spPr>
+        <p:txBody>
+          <a:bodyPr wrap="square" lIns="0" tIns="0" rIns="0" bIns="0" rtlCol="0" anchor="ctr"/>
+          <a:lstStyle/>
+          <a:p>
+            <a:pPr indent="0" marL="0">
+              <a:buNone/>
+            </a:pPr>
+            <a:r>
+              <a:rPr lang="en-US" sz="4000" b="1" dirty="0">
+                <a:solidFill>
+                  <a:srgbClr val="C8102E"/>
+                </a:solidFill>
+                <a:latin typeface="Arial" pitchFamily="34" charset="0"/>
+                <a:ea typeface="Arial" pitchFamily="34" charset="-122"/>
+                <a:cs typeface="Arial" pitchFamily="34" charset="-120"/>
+              </a:rPr>
+              <a:t>$70–90k/yr</a:t>
+            </a:r>
+            <a:endParaRPr lang="en-US" sz="4000" dirty="0"/>
+          </a:p>
+        </p:txBody>
+      </p:sp>
+      <p:sp>
+        <p:nvSpPr>
+          <p:cNvPr id="9" name="Text 6"/>
+          <p:cNvSpPr/>
+          <p:nvPr/>
+        </p:nvSpPr>
+        <p:spPr>
+          <a:xfrm>
+            <a:off x="868680" y="3749040"/>
+            <a:ext cx="2926080" cy="1417320"/>
+          </a:xfrm>
+          <a:prstGeom prst="rect">
+            <a:avLst/>
+          </a:prstGeom>
+          <a:noFill/>
+          <a:ln/>
+        </p:spPr>
+        <p:txBody>
+          <a:bodyPr wrap="square" lIns="0" tIns="0" rIns="0" bIns="0" rtlCol="0" anchor="ctr"/>
+          <a:lstStyle/>
+          <a:p>
+            <a:pPr indent="0" marL="0">
+              <a:buNone/>
+            </a:pPr>
+            <a:r>
+              <a:rPr lang="en-US" sz="1200" dirty="0">
+                <a:solidFill>
+                  <a:srgbClr val="2A2A2A"/>
+                </a:solidFill>
+                <a:latin typeface="Arial" pitchFamily="34" charset="0"/>
+                <a:ea typeface="Arial" pitchFamily="34" charset="-122"/>
+                <a:cs typeface="Arial" pitchFamily="34" charset="-120"/>
+              </a:rPr>
+              <a:t>Salary paid whether jobs close or not. Pure fixed overhead, plus payroll burden — and someone still has to run lead targeting.</a:t>
+            </a:r>
+            <a:endParaRPr lang="en-US" sz="1200" dirty="0"/>
+          </a:p>
+        </p:txBody>
+      </p:sp>
+      <p:sp>
+        <p:nvSpPr>
+          <p:cNvPr id="10" name="Shape 7"/>
+          <p:cNvSpPr/>
+          <p:nvPr/>
+        </p:nvSpPr>
+        <p:spPr>
+          <a:xfrm>
+            <a:off x="4343400" y="1737360"/>
+            <a:ext cx="3520440" cy="3566160"/>
+          </a:xfrm>
+          <a:prstGeom prst="roundRect">
+            <a:avLst>
+              <a:gd name="adj" fmla="val 2078"/>
+            </a:avLst>
+          </a:prstGeom>
+          <a:solidFill>
+            <a:srgbClr val="F5F5F5"/>
+          </a:solidFill>
+          <a:ln/>
+        </p:spPr>
+      </p:sp>
+      <p:sp>
+        <p:nvSpPr>
+          <p:cNvPr id="11" name="Shape 8"/>
+          <p:cNvSpPr/>
+          <p:nvPr/>
+        </p:nvSpPr>
+        <p:spPr>
+          <a:xfrm>
+            <a:off x="4663440" y="2011680"/>
+            <a:ext cx="685800" cy="685800"/>
+          </a:xfrm>
+          <a:prstGeom prst="ellipse">
+            <a:avLst/>
+          </a:prstGeom>
+          <a:solidFill>
+            <a:srgbClr val="C8102E"/>
+          </a:solidFill>
+          <a:ln/>
+        </p:spPr>
+      </p:sp>
+      <p:pic>
+        <p:nvPicPr>
+          <p:cNvPr id="12" name="Image 1" descr="preencoded.png">    </p:cNvPr>
+          <p:cNvPicPr>
+            <a:picLocks noChangeAspect="1"/>
+          </p:cNvPicPr>
+          <p:nvPr/>
+        </p:nvPicPr>
+        <p:blipFill>
+          <a:blip r:embed="rId2"/>
+          <a:stretch>
+            <a:fillRect/>
+          </a:stretch>
+        </p:blipFill>
+        <p:spPr>
+          <a:xfrm>
+            <a:off x="4841748" y="2189988"/>
+            <a:ext cx="329184" cy="329184"/>
+          </a:xfrm>
+          <a:prstGeom prst="rect">
+            <a:avLst/>
+          </a:prstGeom>
+        </p:spPr>
+      </p:pic>
+      <p:sp>
+        <p:nvSpPr>
+          <p:cNvPr id="13" name="Text 9"/>
+          <p:cNvSpPr/>
+          <p:nvPr/>
+        </p:nvSpPr>
+        <p:spPr>
+          <a:xfrm>
+            <a:off x="5486400" y="2194560"/>
+            <a:ext cx="2286000" cy="365760"/>
+          </a:xfrm>
+          <a:prstGeom prst="rect">
+            <a:avLst/>
+          </a:prstGeom>
+          <a:noFill/>
+          <a:ln/>
+        </p:spPr>
+        <p:txBody>
+          <a:bodyPr wrap="square" lIns="0" tIns="0" rIns="0" bIns="0" rtlCol="0" anchor="ctr"/>
+          <a:lstStyle/>
+          <a:p>
+            <a:pPr indent="0" marL="0">
+              <a:buNone/>
+            </a:pPr>
+            <a:r>
+              <a:rPr lang="en-US" sz="1500" b="1" dirty="0">
+                <a:solidFill>
+                  <a:srgbClr val="111111"/>
+                </a:solidFill>
+                <a:latin typeface="Arial" pitchFamily="34" charset="0"/>
+                <a:ea typeface="Arial" pitchFamily="34" charset="-122"/>
+                <a:cs typeface="Arial" pitchFamily="34" charset="-120"/>
+              </a:rPr>
+              <a:t>Supplement service</a:t>
+            </a:r>
+            <a:endParaRPr lang="en-US" sz="1500" dirty="0"/>
+          </a:p>
+        </p:txBody>
+      </p:sp>
+      <p:sp>
+        <p:nvSpPr>
+          <p:cNvPr id="14" name="Text 10"/>
+          <p:cNvSpPr/>
+          <p:nvPr/>
+        </p:nvSpPr>
+        <p:spPr>
+          <a:xfrm>
+            <a:off x="4663440" y="2880360"/>
+            <a:ext cx="2926080" cy="777240"/>
+          </a:xfrm>
+          <a:prstGeom prst="rect">
+            <a:avLst/>
+          </a:prstGeom>
+          <a:noFill/>
+          <a:ln/>
+        </p:spPr>
+        <p:txBody>
+          <a:bodyPr wrap="square" lIns="0" tIns="0" rIns="0" bIns="0" rtlCol="0" anchor="ctr"/>
+          <a:lstStyle/>
+          <a:p>
+            <a:pPr indent="0" marL="0">
+              <a:buNone/>
+            </a:pPr>
+            <a:r>
+              <a:rPr lang="en-US" sz="4000" b="1" dirty="0">
+                <a:solidFill>
+                  <a:srgbClr val="C8102E"/>
+                </a:solidFill>
+                <a:latin typeface="Arial" pitchFamily="34" charset="0"/>
+                <a:ea typeface="Arial" pitchFamily="34" charset="-122"/>
+                <a:cs typeface="Arial" pitchFamily="34" charset="-120"/>
+              </a:rPr>
+              <a:t>25–33%</a:t>
+            </a:r>
+            <a:endParaRPr lang="en-US" sz="4000" dirty="0"/>
+          </a:p>
+        </p:txBody>
+      </p:sp>
+      <p:sp>
+        <p:nvSpPr>
+          <p:cNvPr id="15" name="Text 11"/>
+          <p:cNvSpPr/>
+          <p:nvPr/>
+        </p:nvSpPr>
+        <p:spPr>
+          <a:xfrm>
+            <a:off x="4663440" y="3749040"/>
+            <a:ext cx="2926080" cy="1417320"/>
+          </a:xfrm>
+          <a:prstGeom prst="rect">
+            <a:avLst/>
+          </a:prstGeom>
+          <a:noFill/>
+          <a:ln/>
+        </p:spPr>
+        <p:txBody>
+          <a:bodyPr wrap="square" lIns="0" tIns="0" rIns="0" bIns="0" rtlCol="0" anchor="ctr"/>
+          <a:lstStyle/>
+          <a:p>
+            <a:pPr indent="0" marL="0">
+              <a:buNone/>
+            </a:pPr>
+            <a:r>
+              <a:rPr lang="en-US" sz="1200" dirty="0">
+                <a:solidFill>
+                  <a:srgbClr val="2A2A2A"/>
+                </a:solidFill>
+                <a:latin typeface="Arial" pitchFamily="34" charset="0"/>
+                <a:ea typeface="Arial" pitchFamily="34" charset="-122"/>
+                <a:cs typeface="Arial" pitchFamily="34" charset="-120"/>
+              </a:rPr>
+              <a:t>of every supplement dollar they add — cost scales with paperwork volume, not with closed jobs, and they touch nothing else.</a:t>
+            </a:r>
+            <a:endParaRPr lang="en-US" sz="1200" dirty="0"/>
+          </a:p>
+        </p:txBody>
+      </p:sp>
+      <p:sp>
+        <p:nvSpPr>
+          <p:cNvPr id="16" name="Shape 12"/>
+          <p:cNvSpPr/>
+          <p:nvPr/>
+        </p:nvSpPr>
+        <p:spPr>
+          <a:xfrm>
+            <a:off x="8138160" y="1737360"/>
+            <a:ext cx="3520440" cy="3566160"/>
+          </a:xfrm>
+          <a:prstGeom prst="roundRect">
+            <a:avLst>
+              <a:gd name="adj" fmla="val 2078"/>
+            </a:avLst>
+          </a:prstGeom>
+          <a:solidFill>
+            <a:srgbClr val="111111"/>
+          </a:solidFill>
+          <a:ln/>
+        </p:spPr>
+      </p:sp>
+      <p:sp>
+        <p:nvSpPr>
+          <p:cNvPr id="17" name="Shape 13"/>
+          <p:cNvSpPr/>
+          <p:nvPr/>
+        </p:nvSpPr>
+        <p:spPr>
+          <a:xfrm>
+            <a:off x="8458200" y="2011680"/>
+            <a:ext cx="685800" cy="685800"/>
+          </a:xfrm>
+          <a:prstGeom prst="ellipse">
+            <a:avLst/>
+          </a:prstGeom>
+          <a:solidFill>
+            <a:srgbClr val="C8102E"/>
+          </a:solidFill>
+          <a:ln/>
+        </p:spPr>
+      </p:sp>
+      <p:pic>
+        <p:nvPicPr>
+          <p:cNvPr id="18" name="Image 2" descr="preencoded.png">    </p:cNvPr>
+          <p:cNvPicPr>
+            <a:picLocks noChangeAspect="1"/>
+          </p:cNvPicPr>
+          <p:nvPr/>
+        </p:nvPicPr>
+        <p:blipFill>
+          <a:blip r:embed="rId3"/>
+          <a:stretch>
+            <a:fillRect/>
+          </a:stretch>
+        </p:blipFill>
+        <p:spPr>
+          <a:xfrm>
+            <a:off x="8636508" y="2189988"/>
+            <a:ext cx="329184" cy="329184"/>
+          </a:xfrm>
+          <a:prstGeom prst="rect">
+            <a:avLst/>
+          </a:prstGeom>
+        </p:spPr>
+      </p:pic>
+      <p:sp>
+        <p:nvSpPr>
+          <p:cNvPr id="19" name="Text 14"/>
+          <p:cNvSpPr/>
+          <p:nvPr/>
+        </p:nvSpPr>
+        <p:spPr>
+          <a:xfrm>
+            <a:off x="9281160" y="2194560"/>
+            <a:ext cx="2286000" cy="365760"/>
+          </a:xfrm>
+          <a:prstGeom prst="rect">
+            <a:avLst/>
+          </a:prstGeom>
+          <a:noFill/>
+          <a:ln/>
+        </p:spPr>
+        <p:txBody>
+          <a:bodyPr wrap="square" lIns="0" tIns="0" rIns="0" bIns="0" rtlCol="0" anchor="ctr"/>
+          <a:lstStyle/>
+          <a:p>
+            <a:pPr indent="0" marL="0">
+              <a:buNone/>
+            </a:pPr>
+            <a:r>
+              <a:rPr lang="en-US" sz="1500" b="1" dirty="0">
+                <a:solidFill>
+                  <a:srgbClr val="FFFFFF"/>
+                </a:solidFill>
+                <a:latin typeface="Arial" pitchFamily="34" charset="0"/>
+                <a:ea typeface="Arial" pitchFamily="34" charset="-122"/>
+                <a:cs typeface="Arial" pitchFamily="34" charset="-120"/>
+              </a:rPr>
+              <a:t>This plan</a:t>
+            </a:r>
+            <a:endParaRPr lang="en-US" sz="1500" dirty="0"/>
+          </a:p>
+        </p:txBody>
+      </p:sp>
+      <p:sp>
+        <p:nvSpPr>
+          <p:cNvPr id="20" name="Text 15"/>
+          <p:cNvSpPr/>
+          <p:nvPr/>
+        </p:nvSpPr>
+        <p:spPr>
+          <a:xfrm>
+            <a:off x="8458200" y="2880360"/>
+            <a:ext cx="2926080" cy="777240"/>
+          </a:xfrm>
+          <a:prstGeom prst="rect">
+            <a:avLst/>
+          </a:prstGeom>
+          <a:noFill/>
+          <a:ln/>
+        </p:spPr>
+        <p:txBody>
+          <a:bodyPr wrap="square" lIns="0" tIns="0" rIns="0" bIns="0" rtlCol="0" anchor="ctr"/>
+          <a:lstStyle/>
+          <a:p>
+            <a:pPr indent="0" marL="0">
+              <a:buNone/>
+            </a:pPr>
+            <a:r>
+              <a:rPr lang="en-US" sz="4000" b="1" dirty="0">
+                <a:solidFill>
+                  <a:srgbClr val="C8102E"/>
+                </a:solidFill>
+                <a:latin typeface="Arial" pitchFamily="34" charset="0"/>
+                <a:ea typeface="Arial" pitchFamily="34" charset="-122"/>
+                <a:cs typeface="Arial" pitchFamily="34" charset="-120"/>
+              </a:rPr>
+              <a:t>$0</a:t>
+            </a:r>
+            <a:endParaRPr lang="en-US" sz="4000" dirty="0"/>
+          </a:p>
+        </p:txBody>
+      </p:sp>
+      <p:sp>
+        <p:nvSpPr>
+          <p:cNvPr id="21" name="Text 16"/>
+          <p:cNvSpPr/>
+          <p:nvPr/>
+        </p:nvSpPr>
+        <p:spPr>
+          <a:xfrm>
+            <a:off x="8458200" y="3749040"/>
+            <a:ext cx="2926080" cy="1417320"/>
+          </a:xfrm>
+          <a:prstGeom prst="rect">
+            <a:avLst/>
+          </a:prstGeom>
+          <a:noFill/>
+          <a:ln/>
+        </p:spPr>
+        <p:txBody>
+          <a:bodyPr wrap="square" lIns="0" tIns="0" rIns="0" bIns="0" rtlCol="0" anchor="ctr"/>
+          <a:lstStyle/>
+          <a:p>
+            <a:pPr indent="0" marL="0">
+              <a:buNone/>
+            </a:pPr>
+            <a:r>
+              <a:rPr lang="en-US" sz="1200" dirty="0">
+                <a:solidFill>
+                  <a:srgbClr val="E0E0E0"/>
+                </a:solidFill>
+                <a:latin typeface="Arial" pitchFamily="34" charset="0"/>
+                <a:ea typeface="Arial" pitchFamily="34" charset="-122"/>
+                <a:cs typeface="Arial" pitchFamily="34" charset="-120"/>
+              </a:rPr>
+              <a:t>until a job closes AND the check clears. Scope writing and lead operations in one seat, booked as a job cost on collected revenue.</a:t>
+            </a:r>
+            <a:endParaRPr lang="en-US" sz="1200" dirty="0"/>
+          </a:p>
+        </p:txBody>
+      </p:sp>
+      <p:sp>
+        <p:nvSpPr>
+          <p:cNvPr id="22" name="Text 17"/>
+          <p:cNvSpPr/>
+          <p:nvPr/>
+        </p:nvSpPr>
+        <p:spPr>
+          <a:xfrm>
+            <a:off x="548640" y="6473952"/>
+            <a:ext cx="9601200" cy="274320"/>
+          </a:xfrm>
+          <a:prstGeom prst="rect">
+            <a:avLst/>
+          </a:prstGeom>
+          <a:noFill/>
+          <a:ln/>
+        </p:spPr>
+        <p:txBody>
+          <a:bodyPr wrap="square" lIns="0" tIns="0" rIns="0" bIns="0" rtlCol="0" anchor="ctr"/>
+          <a:lstStyle/>
+          <a:p>
+            <a:pPr indent="0" marL="0">
+              <a:buNone/>
+            </a:pPr>
+            <a:r>
+              <a:rPr lang="en-US" sz="900" dirty="0">
+                <a:solidFill>
+                  <a:srgbClr val="6E6E6E"/>
+                </a:solidFill>
+                <a:latin typeface="Arial" pitchFamily="34" charset="0"/>
+                <a:ea typeface="Arial" pitchFamily="34" charset="-122"/>
+                <a:cs typeface="Arial" pitchFamily="34" charset="-120"/>
+              </a:rPr>
+              <a:t>Estimator salary and supplement-fee ranges are industry-typical figures for the region, not quotes.</a:t>
+            </a:r>
+            <a:endParaRPr lang="en-US" sz="900" dirty="0"/>
+          </a:p>
+        </p:txBody>
+      </p:sp>
+      <p:sp>
+        <p:nvSpPr>
+          <p:cNvPr id="23" name="Text 18"/>
+          <p:cNvSpPr/>
+          <p:nvPr/>
+        </p:nvSpPr>
+        <p:spPr>
+          <a:xfrm>
+            <a:off x="11274552" y="6473952"/>
+            <a:ext cx="457200" cy="274320"/>
+          </a:xfrm>
+          <a:prstGeom prst="rect">
+            <a:avLst/>
+          </a:prstGeom>
+          <a:noFill/>
+          <a:ln/>
+        </p:spPr>
+        <p:txBody>
+          <a:bodyPr wrap="square" lIns="0" tIns="0" rIns="0" bIns="0" rtlCol="0" anchor="ctr"/>
+          <a:lstStyle/>
+          <a:p>
+            <a:pPr algn="r" indent="0" marL="0">
+              <a:buNone/>
+            </a:pPr>
+            <a:r>
+              <a:rPr lang="en-US" sz="1000" dirty="0">
+                <a:solidFill>
+                  <a:srgbClr val="6E6E6E"/>
+                </a:solidFill>
+                <a:latin typeface="Arial" pitchFamily="34" charset="0"/>
+                <a:ea typeface="Arial" pitchFamily="34" charset="-122"/>
+                <a:cs typeface="Arial" pitchFamily="34" charset="-120"/>
+              </a:rPr>
+              <a:t>7</a:t>
+            </a:r>
+            <a:endParaRPr lang="en-US" sz="1000" dirty="0"/>
+          </a:p>
+        </p:txBody>
+      </p:sp>
+    </p:spTree>
+  </p:cSld>
+  <p:clrMapOvr>
+    <a:masterClrMapping/>
+  </p:clrMapOvr>
+</p:sld>
+</file>
+
+<file path=ppt/slides/slide8.xml><?xml version="1.0" encoding="utf-8"?>
+<p:sld xmlns:a="http://schemas.openxmlformats.org/drawingml/2006/main" xmlns:r="http://schemas.openxmlformats.org/officeDocument/2006/relationships" xmlns:p="http://schemas.openxmlformats.org/presentationml/2006/main">
+  <p:cSld name="Slide 8">
     <p:bg>
       <p:bgPr>
         <a:solidFill>

</xml_diff>

<commit_message>
Add 2%-floor-plus-quarterly-true-up payment mechanics to pay plan
Slider slide now states the cash-flow mechanics: the 2% floor is paid
as each job funds, and quarter-end reconciliation trues up to the
earned average rate - no prepaid rates, no clawbacks. Next-steps
slide updated to match.

Co-Authored-By: Claude Fable 5 <noreply@anthropic.com>
Claude-Session: https://claude.ai/code/session_01Qj1b2D7LVH4xves4mfA9FY
</commit_message>
<xml_diff>
--- a/pitch/Commission-Plan.pptx
+++ b/pitch/Commission-Plan.pptx
@@ -2826,8 +2826,8 @@
         </p:nvSpPr>
         <p:spPr>
           <a:xfrm>
-            <a:off x="548640" y="1097280"/>
-            <a:ext cx="10881360" cy="502920"/>
+            <a:off x="548640" y="1051560"/>
+            <a:ext cx="10881360" cy="685800"/>
           </a:xfrm>
           <a:prstGeom prst="rect">
             <a:avLst/>
@@ -2843,7 +2843,7 @@
               <a:buNone/>
             </a:pPr>
             <a:r>
-              <a:rPr lang="en-US" sz="1450" b="1" dirty="0">
+              <a:rPr lang="en-US" sz="1400" b="1" dirty="0">
                 <a:solidFill>
                   <a:srgbClr val="2A2A2A"/>
                 </a:solidFill>
@@ -2857,7 +2857,7 @@
               <a:buNone/>
             </a:pPr>
             <a:r>
-              <a:rPr lang="en-US" sz="1450" dirty="0">
+              <a:rPr lang="en-US" sz="1400" dirty="0">
                 <a:solidFill>
                   <a:srgbClr val="6E6E6E"/>
                 </a:solidFill>
@@ -2865,9 +2865,23 @@
                 <a:ea typeface="Arial" pitchFamily="34" charset="-122"/>
                 <a:cs typeface="Arial" pitchFamily="34" charset="-120"/>
               </a:rPr>
-              <a:t>The % is set by the close rate on scoped leads, measured quarterly — better conversion, better rate, for both sides.</a:t>
-            </a:r>
-            <a:endParaRPr lang="en-US" sz="1450" dirty="0"/>
+              <a:t>The % is set by the close rate on scoped leads, measured quarterly. </a:t>
+            </a:r>
+            <a:pPr indent="0" marL="0">
+              <a:buNone/>
+            </a:pPr>
+            <a:r>
+              <a:rPr lang="en-US" sz="1400" b="1" dirty="0">
+                <a:solidFill>
+                  <a:srgbClr val="C8102E"/>
+                </a:solidFill>
+                <a:latin typeface="Arial" pitchFamily="34" charset="0"/>
+                <a:ea typeface="Arial" pitchFamily="34" charset="-122"/>
+                <a:cs typeface="Arial" pitchFamily="34" charset="-120"/>
+              </a:rPr>
+              <a:t>Cash flow: the 2% floor is paid as each job funds; quarter-end reconciliation trues up to the earned average rate — T^Rock never prepays a rate, and nothing is ever clawed back.</a:t>
+            </a:r>
+            <a:endParaRPr lang="en-US" sz="1400" dirty="0"/>
           </a:p>
         </p:txBody>
       </p:sp>
@@ -2886,7 +2900,7 @@
           </p:nvPr>
         </p:nvGraphicFramePr>
         <p:xfrm>
-          <a:off x="548640" y="1783080"/>
+          <a:off x="548640" y="1874520"/>
           <a:ext cx="11064240" cy="914400"/>
         </p:xfrm>
         <a:graphic>
@@ -8801,7 +8815,7 @@
                 <a:ea typeface="Arial" pitchFamily="34" charset="-122"/>
                 <a:cs typeface="Arial" pitchFamily="34" charset="-120"/>
               </a:rPr>
-              <a:t>Rate recalculates each quarter from actuals. Six-month check: if the numbers say adjust the curve, adjust the curve.</a:t>
+              <a:t>2% floor paid as jobs fund; quarter-end true-up to the earned average rate. Six-month check: if the numbers say adjust the curve, adjust the curve.</a:t>
             </a:r>
             <a:endParaRPr lang="en-US" sz="1250" dirty="0"/>
           </a:p>

</xml_diff>

<commit_message>
Replace native charts with drawn shapes; reframe break-even card
Native PowerPoint charts render as blank space in lightweight viewers
(iOS Quick Look), so the cost-per-lead bars, break-even columns, and
the pay plan's per-100-leads columns are now drawn with shapes and
text, which render everywhere. The break-even slide's left card no
longer walks a $30,000 to $4,950 deduction stack - it leads with the
$4,950 T^Rock keeps per closed roof, with the derivation kept to the
footnote.

Co-Authored-By: Claude Fable 5 <noreply@anthropic.com>
Claude-Session: https://claude.ai/code/session_01Qj1b2D7LVH4xves4mfA9FY
</commit_message>
<xml_diff>
--- a/pitch/Commission-Plan.pptx
+++ b/pitch/Commission-Plan.pptx
@@ -112,288 +112,6 @@
     </a:lvl9pPr>
   </p:defaultTextStyle>
 </p:presentation>
-</file>
-
-<file path=ppt/charts/chart1.xml><?xml version="1.0" encoding="utf-8"?>
-<c:chartSpace xmlns:c="http://schemas.openxmlformats.org/drawingml/2006/chart" xmlns:a="http://schemas.openxmlformats.org/drawingml/2006/main" xmlns:r="http://schemas.openxmlformats.org/officeDocument/2006/relationships">
-  <c:date1904 val="0"/>
-  <c:roundedCorners val="1"/>
-  <c:chart>
-    <c:title>
-      <c:tx>
-        <c:rich>
-          <a:bodyPr/>
-          <a:lstStyle/>
-          <a:p>
-            <a:pPr>
-              <a:defRPr sz="1400" b="0" i="0" u="none" strike="noStrike">
-                <a:solidFill>
-                  <a:srgbClr val="111111"/>
-                </a:solidFill>
-                <a:latin typeface="Arial"/>
-              </a:defRPr>
-            </a:pPr>
-            <a:r>
-              <a:rPr sz="1400" b="0" i="0" u="none" strike="noStrike">
-                <a:solidFill>
-                  <a:srgbClr val="111111"/>
-                </a:solidFill>
-                <a:latin typeface="Arial"/>
-              </a:rPr>
-              <a:t>T^Rock net profit per 100 scoped leads (after fee &amp; PM split)</a:t>
-            </a:r>
-          </a:p>
-        </c:rich>
-      </c:tx>
-      <c:layout/>
-      <c:overlay val="0"/>
-    </c:title>
-    <c:autoTitleDeleted val="0"/>
-    <c:plotArea>
-      <c:layout/>
-      <c:barChart>
-        <c:barDir val="col"/>
-        <c:grouping val="clustered"/>
-        <c:varyColors val="0"/>
-        <c:ser>
-          <c:idx val="0"/>
-          <c:order val="0"/>
-          <c:tx>
-            <c:strRef>
-              <c:f>Sheet1!$B$1</c:f>
-              <c:strCache>
-                <c:ptCount val="1"/>
-                <c:pt idx="0">
-                  <c:v>T^Rock net profit per 100 scoped leads</c:v>
-                </c:pt>
-              </c:strCache>
-            </c:strRef>
-          </c:tx>
-          <c:spPr>
-            <a:solidFill>
-              <a:srgbClr val="C8102E"/>
-            </a:solidFill>
-            <a:effectLst/>
-          </c:spPr>
-          <c:invertIfNegative val="0"/>
-          <c:dLbls>
-            <c:numFmt formatCode="$#,##0" sourceLinked="0"/>
-            <c:txPr>
-              <a:bodyPr/>
-              <a:lstStyle/>
-              <a:p>
-                <a:pPr>
-                  <a:defRPr b="0" i="0" strike="noStrike" sz="1200" u="none">
-                    <a:solidFill>
-                      <a:srgbClr val="111111"/>
-                    </a:solidFill>
-                    <a:latin typeface="Arial"/>
-                  </a:defRPr>
-                </a:pPr>
-              </a:p>
-            </c:txPr>
-            <c:showLegendKey val="0"/>
-            <c:showVal val="1"/>
-            <c:showCatName val="0"/>
-            <c:showSerName val="0"/>
-            <c:showPercent val="0"/>
-            <c:showBubbleSize val="0"/>
-            <c:showLeaderLines val="0"/>
-          </c:dLbls>
-          <c:cat>
-            <c:multiLvlStrRef>
-              <c:f>Sheet1!$A$2:$A$6</c:f>
-              <c:multiLvlStrCache>
-                <c:ptCount val="5"/>
-                <c:lvl>
-                  <c:pt idx="0">
-                    <c:v>20% close</c:v>
-                  </c:pt>
-                  <c:pt idx="1">
-                    <c:v>40% close</c:v>
-                  </c:pt>
-                  <c:pt idx="2">
-                    <c:v>60% close</c:v>
-                  </c:pt>
-                  <c:pt idx="3">
-                    <c:v>80% close</c:v>
-                  </c:pt>
-                  <c:pt idx="4">
-                    <c:v>100% close</c:v>
-                  </c:pt>
-                </c:lvl>
-              </c:multiLvlStrCache>
-            </c:multiLvlStrRef>
-          </c:cat>
-          <c:val>
-            <c:numRef>
-              <c:f>Sheet1!$B$2:$B$6</c:f>
-              <c:numCache>
-                <c:formatCode>General</c:formatCode>
-                <c:ptCount val="5"/>
-                <c:pt idx="0">
-                  <c:v>99000</c:v>
-                </c:pt>
-                <c:pt idx="1">
-                  <c:v>186000</c:v>
-                </c:pt>
-                <c:pt idx="2">
-                  <c:v>261000</c:v>
-                </c:pt>
-                <c:pt idx="3">
-                  <c:v>324000</c:v>
-                </c:pt>
-                <c:pt idx="4">
-                  <c:v>375000</c:v>
-                </c:pt>
-              </c:numCache>
-            </c:numRef>
-          </c:val>
-        </c:ser>
-        <c:dLbls>
-          <c:numFmt formatCode="$#,##0" sourceLinked="0"/>
-          <c:txPr>
-            <a:bodyPr/>
-            <a:lstStyle/>
-            <a:p>
-              <a:pPr>
-                <a:defRPr b="0" i="0" strike="noStrike" sz="1200" u="none">
-                  <a:solidFill>
-                    <a:srgbClr val="111111"/>
-                  </a:solidFill>
-                  <a:latin typeface="Arial"/>
-                </a:defRPr>
-              </a:pPr>
-            </a:p>
-          </c:txPr>
-          <c:showLegendKey val="0"/>
-          <c:showVal val="1"/>
-          <c:showCatName val="0"/>
-          <c:showSerName val="0"/>
-          <c:showPercent val="0"/>
-          <c:showBubbleSize val="0"/>
-          <c:showLeaderLines val="0"/>
-        </c:dLbls>
-        <c:gapWidth val="150"/>
-        <c:overlap val="0"/>
-        <c:axId val="2094734554"/>
-        <c:axId val="2094734552"/>
-        <c:axId val="2094734556"/>
-      </c:barChart>
-      <c:catAx>
-        <c:axId val="2094734554"/>
-        <c:scaling>
-          <c:orientation val="minMax"/>
-        </c:scaling>
-        <c:delete val="0"/>
-        <c:axPos val="b"/>
-        <c:numFmt formatCode="General" sourceLinked="1"/>
-        <c:majorTickMark val="out"/>
-        <c:minorTickMark val="none"/>
-        <c:tickLblPos val="low"/>
-        <c:spPr>
-          <a:ln w="12700" cap="flat">
-            <a:solidFill>
-              <a:srgbClr val="888888"/>
-            </a:solidFill>
-            <a:prstDash val="solid"/>
-            <a:round/>
-          </a:ln>
-        </c:spPr>
-        <c:txPr>
-          <a:bodyPr/>
-          <a:lstStyle/>
-          <a:p>
-            <a:pPr>
-              <a:defRPr sz="1200" b="0" i="0" u="none" strike="noStrike">
-                <a:solidFill>
-                  <a:srgbClr val="2A2A2A"/>
-                </a:solidFill>
-                <a:latin typeface="Arial"/>
-              </a:defRPr>
-            </a:pPr>
-            <a:endParaRPr lang="en-US"/>
-          </a:p>
-        </c:txPr>
-        <c:crossAx val="2094734552"/>
-        <c:crosses val="autoZero"/>
-        <c:auto val="1"/>
-        <c:lblAlgn val="ctr"/>
-        <c:noMultiLvlLbl val="1"/>
-      </c:catAx>
-      <c:valAx>
-        <c:axId val="2094734552"/>
-        <c:scaling>
-          <c:orientation val="minMax"/>
-          <c:max val="420000"/>
-        </c:scaling>
-        <c:delete val="0"/>
-        <c:axPos val="l"/>
-        <c:majorGridlines>
-          <c:spPr>
-            <a:ln w="6350" cap="flat">
-              <a:solidFill>
-                <a:srgbClr val="E8E8E8"/>
-              </a:solidFill>
-              <a:prstDash val="solid"/>
-              <a:round/>
-            </a:ln>
-          </c:spPr>
-        </c:majorGridlines>
-        <c:numFmt formatCode="$#,##0" sourceLinked="0"/>
-        <c:majorTickMark val="out"/>
-        <c:minorTickMark val="none"/>
-        <c:tickLblPos val="nextTo"/>
-        <c:spPr>
-          <a:ln w="12700" cap="flat">
-            <a:solidFill>
-              <a:srgbClr val="888888"/>
-            </a:solidFill>
-            <a:prstDash val="solid"/>
-            <a:round/>
-          </a:ln>
-        </c:spPr>
-        <c:txPr>
-          <a:bodyPr/>
-          <a:lstStyle/>
-          <a:p>
-            <a:pPr>
-              <a:defRPr sz="1000" b="0" i="0" u="none" strike="noStrike">
-                <a:solidFill>
-                  <a:srgbClr val="6E6E6E"/>
-                </a:solidFill>
-                <a:latin typeface="Arial"/>
-              </a:defRPr>
-            </a:pPr>
-            <a:endParaRPr lang="en-US"/>
-          </a:p>
-        </c:txPr>
-        <c:crossAx val="2094734554"/>
-        <c:crosses val="autoZero"/>
-        <c:crossBetween val="between"/>
-      </c:valAx>
-      <c:spPr>
-        <a:noFill/>
-        <a:ln>
-          <a:noFill/>
-        </a:ln>
-        <a:effectLst/>
-      </c:spPr>
-    </c:plotArea>
-    <c:plotVisOnly val="1"/>
-    <c:dispBlanksAs val="span"/>
-  </c:chart>
-  <c:spPr>
-    <a:noFill/>
-    <a:ln>
-      <a:noFill/>
-    </a:ln>
-    <a:effectLst/>
-  </c:spPr>
-  <c:externalData r:id="rId1">
-    <c:autoUpdate val="0"/>
-  </c:externalData>
-</c:chartSpace>
 </file>
 
 <file path=ppt/notesMasters/notesMaster1.xml><?xml version="1.0" encoding="utf-8"?>
@@ -6588,25 +6306,568 @@
           </a:p>
         </p:txBody>
       </p:sp>
-      <p:graphicFrame>
-        <p:nvGraphicFramePr>
-          <p:cNvPr id="4" name="Chart 0" descr=""/>
-          <p:cNvGraphicFramePr/>
-          <p:nvPr/>
-        </p:nvGraphicFramePr>
-        <p:xfrm>
-          <a:off x="548640" y="1600200"/>
-          <a:ext cx="11064240" cy="3749040"/>
-        </p:xfrm>
-        <a:graphic xmlns:a="http://schemas.openxmlformats.org/drawingml/2006/main">
-          <a:graphicData uri="http://schemas.openxmlformats.org/drawingml/2006/chart">
-            <c:chart xmlns:c="http://schemas.openxmlformats.org/drawingml/2006/chart" r:id="rId1"/>
-          </a:graphicData>
-        </a:graphic>
-      </p:graphicFrame>
-      <p:sp>
-        <p:nvSpPr>
-          <p:cNvPr id="5" name="Shape 2"/>
+      <p:sp>
+        <p:nvSpPr>
+          <p:cNvPr id="4" name="Text 2"/>
+          <p:cNvSpPr/>
+          <p:nvPr/>
+        </p:nvSpPr>
+        <p:spPr>
+          <a:xfrm>
+            <a:off x="548640" y="1600200"/>
+            <a:ext cx="11064240" cy="320040"/>
+          </a:xfrm>
+          <a:prstGeom prst="rect">
+            <a:avLst/>
+          </a:prstGeom>
+          <a:noFill/>
+          <a:ln/>
+        </p:spPr>
+        <p:txBody>
+          <a:bodyPr wrap="square" lIns="0" tIns="0" rIns="0" bIns="0" rtlCol="0" anchor="ctr"/>
+          <a:lstStyle/>
+          <a:p>
+            <a:pPr indent="0" marL="0">
+              <a:buNone/>
+            </a:pPr>
+            <a:r>
+              <a:rPr lang="en-US" sz="1400" b="1" dirty="0">
+                <a:solidFill>
+                  <a:srgbClr val="111111"/>
+                </a:solidFill>
+                <a:latin typeface="Arial" pitchFamily="34" charset="0"/>
+                <a:ea typeface="Arial" pitchFamily="34" charset="-122"/>
+                <a:cs typeface="Arial" pitchFamily="34" charset="-120"/>
+              </a:rPr>
+              <a:t>T^Rock net profit per 100 scoped leads  (after fee &amp; PM split)</a:t>
+            </a:r>
+            <a:endParaRPr lang="en-US" sz="1400" dirty="0"/>
+          </a:p>
+        </p:txBody>
+      </p:sp>
+      <p:sp>
+        <p:nvSpPr>
+          <p:cNvPr id="5" name="Shape 3"/>
+          <p:cNvSpPr/>
+          <p:nvPr/>
+        </p:nvSpPr>
+        <p:spPr>
+          <a:xfrm>
+            <a:off x="685800" y="4846320"/>
+            <a:ext cx="10789920" cy="13716"/>
+          </a:xfrm>
+          <a:prstGeom prst="rect">
+            <a:avLst/>
+          </a:prstGeom>
+          <a:solidFill>
+            <a:srgbClr val="CCCCCC"/>
+          </a:solidFill>
+          <a:ln/>
+        </p:spPr>
+      </p:sp>
+      <p:sp>
+        <p:nvSpPr>
+          <p:cNvPr id="6" name="Shape 4"/>
+          <p:cNvSpPr/>
+          <p:nvPr/>
+        </p:nvSpPr>
+        <p:spPr>
+          <a:xfrm>
+            <a:off x="1005840" y="4194536"/>
+            <a:ext cx="1371600" cy="651784"/>
+          </a:xfrm>
+          <a:prstGeom prst="roundRect">
+            <a:avLst>
+              <a:gd name="adj" fmla="val 4209"/>
+            </a:avLst>
+          </a:prstGeom>
+          <a:solidFill>
+            <a:srgbClr val="B9BDC2"/>
+          </a:solidFill>
+          <a:ln/>
+        </p:spPr>
+      </p:sp>
+      <p:sp>
+        <p:nvSpPr>
+          <p:cNvPr id="7" name="Text 5"/>
+          <p:cNvSpPr/>
+          <p:nvPr/>
+        </p:nvSpPr>
+        <p:spPr>
+          <a:xfrm>
+            <a:off x="685800" y="3847064"/>
+            <a:ext cx="2011680" cy="320040"/>
+          </a:xfrm>
+          <a:prstGeom prst="rect">
+            <a:avLst/>
+          </a:prstGeom>
+          <a:noFill/>
+          <a:ln/>
+        </p:spPr>
+        <p:txBody>
+          <a:bodyPr wrap="square" lIns="0" tIns="0" rIns="0" bIns="0" rtlCol="0" anchor="ctr"/>
+          <a:lstStyle/>
+          <a:p>
+            <a:pPr algn="ctr" indent="0" marL="0">
+              <a:buNone/>
+            </a:pPr>
+            <a:r>
+              <a:rPr lang="en-US" sz="1350" b="1" dirty="0">
+                <a:solidFill>
+                  <a:srgbClr val="2A2A2A"/>
+                </a:solidFill>
+                <a:latin typeface="Arial" pitchFamily="34" charset="0"/>
+                <a:ea typeface="Arial" pitchFamily="34" charset="-122"/>
+                <a:cs typeface="Arial" pitchFamily="34" charset="-120"/>
+              </a:rPr>
+              <a:t>$99,000</a:t>
+            </a:r>
+            <a:endParaRPr lang="en-US" sz="1350" dirty="0"/>
+          </a:p>
+        </p:txBody>
+      </p:sp>
+      <p:sp>
+        <p:nvSpPr>
+          <p:cNvPr id="8" name="Text 6"/>
+          <p:cNvSpPr/>
+          <p:nvPr/>
+        </p:nvSpPr>
+        <p:spPr>
+          <a:xfrm>
+            <a:off x="685800" y="4919472"/>
+            <a:ext cx="2011680" cy="274320"/>
+          </a:xfrm>
+          <a:prstGeom prst="rect">
+            <a:avLst/>
+          </a:prstGeom>
+          <a:noFill/>
+          <a:ln/>
+        </p:spPr>
+        <p:txBody>
+          <a:bodyPr wrap="square" lIns="0" tIns="0" rIns="0" bIns="0" rtlCol="0" anchor="ctr"/>
+          <a:lstStyle/>
+          <a:p>
+            <a:pPr algn="ctr" indent="0" marL="0">
+              <a:buNone/>
+            </a:pPr>
+            <a:r>
+              <a:rPr lang="en-US" sz="1200" dirty="0">
+                <a:solidFill>
+                  <a:srgbClr val="2A2A2A"/>
+                </a:solidFill>
+                <a:latin typeface="Arial" pitchFamily="34" charset="0"/>
+                <a:ea typeface="Arial" pitchFamily="34" charset="-122"/>
+                <a:cs typeface="Arial" pitchFamily="34" charset="-120"/>
+              </a:rPr>
+              <a:t>20% close</a:t>
+            </a:r>
+            <a:endParaRPr lang="en-US" sz="1200" dirty="0"/>
+          </a:p>
+        </p:txBody>
+      </p:sp>
+      <p:sp>
+        <p:nvSpPr>
+          <p:cNvPr id="9" name="Shape 7"/>
+          <p:cNvSpPr/>
+          <p:nvPr/>
+        </p:nvSpPr>
+        <p:spPr>
+          <a:xfrm>
+            <a:off x="3200400" y="3621756"/>
+            <a:ext cx="1371600" cy="1224564"/>
+          </a:xfrm>
+          <a:prstGeom prst="roundRect">
+            <a:avLst>
+              <a:gd name="adj" fmla="val 2240"/>
+            </a:avLst>
+          </a:prstGeom>
+          <a:solidFill>
+            <a:srgbClr val="B9BDC2"/>
+          </a:solidFill>
+          <a:ln/>
+        </p:spPr>
+      </p:sp>
+      <p:sp>
+        <p:nvSpPr>
+          <p:cNvPr id="10" name="Text 8"/>
+          <p:cNvSpPr/>
+          <p:nvPr/>
+        </p:nvSpPr>
+        <p:spPr>
+          <a:xfrm>
+            <a:off x="2880360" y="3274284"/>
+            <a:ext cx="2011680" cy="320040"/>
+          </a:xfrm>
+          <a:prstGeom prst="rect">
+            <a:avLst/>
+          </a:prstGeom>
+          <a:noFill/>
+          <a:ln/>
+        </p:spPr>
+        <p:txBody>
+          <a:bodyPr wrap="square" lIns="0" tIns="0" rIns="0" bIns="0" rtlCol="0" anchor="ctr"/>
+          <a:lstStyle/>
+          <a:p>
+            <a:pPr algn="ctr" indent="0" marL="0">
+              <a:buNone/>
+            </a:pPr>
+            <a:r>
+              <a:rPr lang="en-US" sz="1350" b="1" dirty="0">
+                <a:solidFill>
+                  <a:srgbClr val="2A2A2A"/>
+                </a:solidFill>
+                <a:latin typeface="Arial" pitchFamily="34" charset="0"/>
+                <a:ea typeface="Arial" pitchFamily="34" charset="-122"/>
+                <a:cs typeface="Arial" pitchFamily="34" charset="-120"/>
+              </a:rPr>
+              <a:t>$186,000</a:t>
+            </a:r>
+            <a:endParaRPr lang="en-US" sz="1350" dirty="0"/>
+          </a:p>
+        </p:txBody>
+      </p:sp>
+      <p:sp>
+        <p:nvSpPr>
+          <p:cNvPr id="11" name="Text 9"/>
+          <p:cNvSpPr/>
+          <p:nvPr/>
+        </p:nvSpPr>
+        <p:spPr>
+          <a:xfrm>
+            <a:off x="2880360" y="4919472"/>
+            <a:ext cx="2011680" cy="274320"/>
+          </a:xfrm>
+          <a:prstGeom prst="rect">
+            <a:avLst/>
+          </a:prstGeom>
+          <a:noFill/>
+          <a:ln/>
+        </p:spPr>
+        <p:txBody>
+          <a:bodyPr wrap="square" lIns="0" tIns="0" rIns="0" bIns="0" rtlCol="0" anchor="ctr"/>
+          <a:lstStyle/>
+          <a:p>
+            <a:pPr algn="ctr" indent="0" marL="0">
+              <a:buNone/>
+            </a:pPr>
+            <a:r>
+              <a:rPr lang="en-US" sz="1200" dirty="0">
+                <a:solidFill>
+                  <a:srgbClr val="2A2A2A"/>
+                </a:solidFill>
+                <a:latin typeface="Arial" pitchFamily="34" charset="0"/>
+                <a:ea typeface="Arial" pitchFamily="34" charset="-122"/>
+                <a:cs typeface="Arial" pitchFamily="34" charset="-120"/>
+              </a:rPr>
+              <a:t>40% close</a:t>
+            </a:r>
+            <a:endParaRPr lang="en-US" sz="1200" dirty="0"/>
+          </a:p>
+        </p:txBody>
+      </p:sp>
+      <p:sp>
+        <p:nvSpPr>
+          <p:cNvPr id="12" name="Shape 10"/>
+          <p:cNvSpPr/>
+          <p:nvPr/>
+        </p:nvSpPr>
+        <p:spPr>
+          <a:xfrm>
+            <a:off x="5394960" y="3127980"/>
+            <a:ext cx="1371600" cy="1718340"/>
+          </a:xfrm>
+          <a:prstGeom prst="roundRect">
+            <a:avLst>
+              <a:gd name="adj" fmla="val 2000"/>
+            </a:avLst>
+          </a:prstGeom>
+          <a:solidFill>
+            <a:srgbClr val="B9BDC2"/>
+          </a:solidFill>
+          <a:ln/>
+        </p:spPr>
+      </p:sp>
+      <p:sp>
+        <p:nvSpPr>
+          <p:cNvPr id="13" name="Text 11"/>
+          <p:cNvSpPr/>
+          <p:nvPr/>
+        </p:nvSpPr>
+        <p:spPr>
+          <a:xfrm>
+            <a:off x="5074920" y="2780508"/>
+            <a:ext cx="2011680" cy="320040"/>
+          </a:xfrm>
+          <a:prstGeom prst="rect">
+            <a:avLst/>
+          </a:prstGeom>
+          <a:noFill/>
+          <a:ln/>
+        </p:spPr>
+        <p:txBody>
+          <a:bodyPr wrap="square" lIns="0" tIns="0" rIns="0" bIns="0" rtlCol="0" anchor="ctr"/>
+          <a:lstStyle/>
+          <a:p>
+            <a:pPr algn="ctr" indent="0" marL="0">
+              <a:buNone/>
+            </a:pPr>
+            <a:r>
+              <a:rPr lang="en-US" sz="1350" b="1" dirty="0">
+                <a:solidFill>
+                  <a:srgbClr val="2A2A2A"/>
+                </a:solidFill>
+                <a:latin typeface="Arial" pitchFamily="34" charset="0"/>
+                <a:ea typeface="Arial" pitchFamily="34" charset="-122"/>
+                <a:cs typeface="Arial" pitchFamily="34" charset="-120"/>
+              </a:rPr>
+              <a:t>$261,000</a:t>
+            </a:r>
+            <a:endParaRPr lang="en-US" sz="1350" dirty="0"/>
+          </a:p>
+        </p:txBody>
+      </p:sp>
+      <p:sp>
+        <p:nvSpPr>
+          <p:cNvPr id="14" name="Text 12"/>
+          <p:cNvSpPr/>
+          <p:nvPr/>
+        </p:nvSpPr>
+        <p:spPr>
+          <a:xfrm>
+            <a:off x="5074920" y="4919472"/>
+            <a:ext cx="2011680" cy="274320"/>
+          </a:xfrm>
+          <a:prstGeom prst="rect">
+            <a:avLst/>
+          </a:prstGeom>
+          <a:noFill/>
+          <a:ln/>
+        </p:spPr>
+        <p:txBody>
+          <a:bodyPr wrap="square" lIns="0" tIns="0" rIns="0" bIns="0" rtlCol="0" anchor="ctr"/>
+          <a:lstStyle/>
+          <a:p>
+            <a:pPr algn="ctr" indent="0" marL="0">
+              <a:buNone/>
+            </a:pPr>
+            <a:r>
+              <a:rPr lang="en-US" sz="1200" dirty="0">
+                <a:solidFill>
+                  <a:srgbClr val="2A2A2A"/>
+                </a:solidFill>
+                <a:latin typeface="Arial" pitchFamily="34" charset="0"/>
+                <a:ea typeface="Arial" pitchFamily="34" charset="-122"/>
+                <a:cs typeface="Arial" pitchFamily="34" charset="-120"/>
+              </a:rPr>
+              <a:t>60% close</a:t>
+            </a:r>
+            <a:endParaRPr lang="en-US" sz="1200" dirty="0"/>
+          </a:p>
+        </p:txBody>
+      </p:sp>
+      <p:sp>
+        <p:nvSpPr>
+          <p:cNvPr id="15" name="Shape 13"/>
+          <p:cNvSpPr/>
+          <p:nvPr/>
+        </p:nvSpPr>
+        <p:spPr>
+          <a:xfrm>
+            <a:off x="7589520" y="2713208"/>
+            <a:ext cx="1371600" cy="2133112"/>
+          </a:xfrm>
+          <a:prstGeom prst="roundRect">
+            <a:avLst>
+              <a:gd name="adj" fmla="val 2000"/>
+            </a:avLst>
+          </a:prstGeom>
+          <a:solidFill>
+            <a:srgbClr val="B9BDC2"/>
+          </a:solidFill>
+          <a:ln/>
+        </p:spPr>
+      </p:sp>
+      <p:sp>
+        <p:nvSpPr>
+          <p:cNvPr id="16" name="Text 14"/>
+          <p:cNvSpPr/>
+          <p:nvPr/>
+        </p:nvSpPr>
+        <p:spPr>
+          <a:xfrm>
+            <a:off x="7269480" y="2365736"/>
+            <a:ext cx="2011680" cy="320040"/>
+          </a:xfrm>
+          <a:prstGeom prst="rect">
+            <a:avLst/>
+          </a:prstGeom>
+          <a:noFill/>
+          <a:ln/>
+        </p:spPr>
+        <p:txBody>
+          <a:bodyPr wrap="square" lIns="0" tIns="0" rIns="0" bIns="0" rtlCol="0" anchor="ctr"/>
+          <a:lstStyle/>
+          <a:p>
+            <a:pPr algn="ctr" indent="0" marL="0">
+              <a:buNone/>
+            </a:pPr>
+            <a:r>
+              <a:rPr lang="en-US" sz="1350" b="1" dirty="0">
+                <a:solidFill>
+                  <a:srgbClr val="2A2A2A"/>
+                </a:solidFill>
+                <a:latin typeface="Arial" pitchFamily="34" charset="0"/>
+                <a:ea typeface="Arial" pitchFamily="34" charset="-122"/>
+                <a:cs typeface="Arial" pitchFamily="34" charset="-120"/>
+              </a:rPr>
+              <a:t>$324,000</a:t>
+            </a:r>
+            <a:endParaRPr lang="en-US" sz="1350" dirty="0"/>
+          </a:p>
+        </p:txBody>
+      </p:sp>
+      <p:sp>
+        <p:nvSpPr>
+          <p:cNvPr id="17" name="Text 15"/>
+          <p:cNvSpPr/>
+          <p:nvPr/>
+        </p:nvSpPr>
+        <p:spPr>
+          <a:xfrm>
+            <a:off x="7269480" y="4919472"/>
+            <a:ext cx="2011680" cy="274320"/>
+          </a:xfrm>
+          <a:prstGeom prst="rect">
+            <a:avLst/>
+          </a:prstGeom>
+          <a:noFill/>
+          <a:ln/>
+        </p:spPr>
+        <p:txBody>
+          <a:bodyPr wrap="square" lIns="0" tIns="0" rIns="0" bIns="0" rtlCol="0" anchor="ctr"/>
+          <a:lstStyle/>
+          <a:p>
+            <a:pPr algn="ctr" indent="0" marL="0">
+              <a:buNone/>
+            </a:pPr>
+            <a:r>
+              <a:rPr lang="en-US" sz="1200" dirty="0">
+                <a:solidFill>
+                  <a:srgbClr val="2A2A2A"/>
+                </a:solidFill>
+                <a:latin typeface="Arial" pitchFamily="34" charset="0"/>
+                <a:ea typeface="Arial" pitchFamily="34" charset="-122"/>
+                <a:cs typeface="Arial" pitchFamily="34" charset="-120"/>
+              </a:rPr>
+              <a:t>80% close</a:t>
+            </a:r>
+            <a:endParaRPr lang="en-US" sz="1200" dirty="0"/>
+          </a:p>
+        </p:txBody>
+      </p:sp>
+      <p:sp>
+        <p:nvSpPr>
+          <p:cNvPr id="18" name="Shape 16"/>
+          <p:cNvSpPr/>
+          <p:nvPr/>
+        </p:nvSpPr>
+        <p:spPr>
+          <a:xfrm>
+            <a:off x="9784080" y="2377440"/>
+            <a:ext cx="1371600" cy="2468880"/>
+          </a:xfrm>
+          <a:prstGeom prst="roundRect">
+            <a:avLst>
+              <a:gd name="adj" fmla="val 2000"/>
+            </a:avLst>
+          </a:prstGeom>
+          <a:solidFill>
+            <a:srgbClr val="C8102E"/>
+          </a:solidFill>
+          <a:ln/>
+        </p:spPr>
+      </p:sp>
+      <p:sp>
+        <p:nvSpPr>
+          <p:cNvPr id="19" name="Text 17"/>
+          <p:cNvSpPr/>
+          <p:nvPr/>
+        </p:nvSpPr>
+        <p:spPr>
+          <a:xfrm>
+            <a:off x="9464040" y="2029968"/>
+            <a:ext cx="2011680" cy="320040"/>
+          </a:xfrm>
+          <a:prstGeom prst="rect">
+            <a:avLst/>
+          </a:prstGeom>
+          <a:noFill/>
+          <a:ln/>
+        </p:spPr>
+        <p:txBody>
+          <a:bodyPr wrap="square" lIns="0" tIns="0" rIns="0" bIns="0" rtlCol="0" anchor="ctr"/>
+          <a:lstStyle/>
+          <a:p>
+            <a:pPr algn="ctr" indent="0" marL="0">
+              <a:buNone/>
+            </a:pPr>
+            <a:r>
+              <a:rPr lang="en-US" sz="1600" b="1" dirty="0">
+                <a:solidFill>
+                  <a:srgbClr val="C8102E"/>
+                </a:solidFill>
+                <a:latin typeface="Arial" pitchFamily="34" charset="0"/>
+                <a:ea typeface="Arial" pitchFamily="34" charset="-122"/>
+                <a:cs typeface="Arial" pitchFamily="34" charset="-120"/>
+              </a:rPr>
+              <a:t>$375,000</a:t>
+            </a:r>
+            <a:endParaRPr lang="en-US" sz="1600" dirty="0"/>
+          </a:p>
+        </p:txBody>
+      </p:sp>
+      <p:sp>
+        <p:nvSpPr>
+          <p:cNvPr id="20" name="Text 18"/>
+          <p:cNvSpPr/>
+          <p:nvPr/>
+        </p:nvSpPr>
+        <p:spPr>
+          <a:xfrm>
+            <a:off x="9464040" y="4919472"/>
+            <a:ext cx="2011680" cy="274320"/>
+          </a:xfrm>
+          <a:prstGeom prst="rect">
+            <a:avLst/>
+          </a:prstGeom>
+          <a:noFill/>
+          <a:ln/>
+        </p:spPr>
+        <p:txBody>
+          <a:bodyPr wrap="square" lIns="0" tIns="0" rIns="0" bIns="0" rtlCol="0" anchor="ctr"/>
+          <a:lstStyle/>
+          <a:p>
+            <a:pPr algn="ctr" indent="0" marL="0">
+              <a:buNone/>
+            </a:pPr>
+            <a:r>
+              <a:rPr lang="en-US" sz="1200" b="1" dirty="0">
+                <a:solidFill>
+                  <a:srgbClr val="C8102E"/>
+                </a:solidFill>
+                <a:latin typeface="Arial" pitchFamily="34" charset="0"/>
+                <a:ea typeface="Arial" pitchFamily="34" charset="-122"/>
+                <a:cs typeface="Arial" pitchFamily="34" charset="-120"/>
+              </a:rPr>
+              <a:t>100% close</a:t>
+            </a:r>
+            <a:endParaRPr lang="en-US" sz="1200" dirty="0"/>
+          </a:p>
+        </p:txBody>
+      </p:sp>
+      <p:sp>
+        <p:nvSpPr>
+          <p:cNvPr id="21" name="Shape 19"/>
           <p:cNvSpPr/>
           <p:nvPr/>
         </p:nvSpPr>
@@ -6628,7 +6889,7 @@
       </p:sp>
       <p:sp>
         <p:nvSpPr>
-          <p:cNvPr id="6" name="Text 3"/>
+          <p:cNvPr id="22" name="Text 20"/>
           <p:cNvSpPr/>
           <p:nvPr/>
         </p:nvSpPr>
@@ -6681,7 +6942,7 @@
       </p:sp>
       <p:sp>
         <p:nvSpPr>
-          <p:cNvPr id="7" name="Text 4"/>
+          <p:cNvPr id="23" name="Text 21"/>
           <p:cNvSpPr/>
           <p:nvPr/>
         </p:nvSpPr>
@@ -6720,7 +6981,7 @@
       </p:sp>
       <p:sp>
         <p:nvSpPr>
-          <p:cNvPr id="8" name="Text 5"/>
+          <p:cNvPr id="24" name="Text 22"/>
           <p:cNvSpPr/>
           <p:nvPr/>
         </p:nvSpPr>

</xml_diff>

<commit_message>
Rebase commission plan on % of job profit; add per-lead volume row
Commission deck now runs on Dom's profit-based framing: $30,000 job at
50% margin = $15,000 profit, fee 2%-10% of profit booked as a job
expense before the 50/50 PM split (ceiling $1,500/job, T^Rock nets
$6,750). Slider table, anchor slide (ceiling = half the customary
referral fee), per-100-leads chart, and options slide all recomputed;
% of RCV kept as the alternative base.

Storm Scout deck: cost-per-lead slide adds a volume row showing the
subscription's per-lead cost falling as leads provided rise
($20/$10/$4/$2 at 100/200/500/1,000 leads per month).

Co-Authored-By: Claude Fable 5 <noreply@anthropic.com>
Claude-Session: https://claude.ai/code/session_01Qj1b2D7LVH4xves4mfA9FY
</commit_message>
<xml_diff>
--- a/pitch/Commission-Plan.pptx
+++ b/pitch/Commission-Plan.pptx
@@ -2569,7 +2569,7 @@
                 <a:ea typeface="Arial" pitchFamily="34" charset="-122"/>
                 <a:cs typeface="Arial" pitchFamily="34" charset="-120"/>
               </a:rPr>
-              <a:t>Fee = % of RCV on scoped jobs, paid only when closed AND collected. </a:t>
+              <a:t>Fee = % of job profit on scoped jobs, booked as a job expense, paid only when closed AND collected. </a:t>
             </a:r>
             <a:pPr indent="0" marL="0">
               <a:buNone/>
@@ -3061,7 +3061,7 @@
                           <a:ea typeface="Arial" pitchFamily="34" charset="-122"/>
                           <a:cs typeface="Arial" pitchFamily="34" charset="-120"/>
                         </a:rPr>
-                        <a:t>Fee (% of RCV)</a:t>
+                        <a:t>Fee (% of job profit)</a:t>
                       </a:r>
                       <a:endParaRPr lang="en-US" sz="1200" dirty="0">
                         <a:latin typeface="Arial" charset="0"/>
@@ -3845,9 +3845,74 @@
                           <a:ea typeface="Arial" pitchFamily="34" charset="-122"/>
                           <a:cs typeface="Arial" pitchFamily="34" charset="-120"/>
                         </a:rPr>
-                        <a:t>Fee per closed $30,000 job</a:t>
+                        <a:t>Fee per closed job ($15,000 profit)</a:t>
                       </a:r>
                       <a:endParaRPr lang="en-US" sz="1200" dirty="0">
+                        <a:latin typeface="Arial" charset="0"/>
+                        <a:ea typeface="Arial" charset="0"/>
+                        <a:cs typeface="Arial" charset="0"/>
+                      </a:endParaRPr>
+                    </a:p>
+                  </a:txBody>
+                  <a:tcPr marL="64008" marR="64008" marT="64008" marB="64008" anchor="ctr">
+                    <a:lnL w="9525" cap="flat" cmpd="sng" algn="ctr">
+                      <a:solidFill>
+                        <a:srgbClr val="DDDDDD"/>
+                      </a:solidFill>
+                      <a:prstDash val="solid"/>
+                      <a:round/>
+                      <a:headEnd type="none" w="med" len="med"/>
+                      <a:tailEnd type="none" w="med" len="med"/>
+                    </a:lnL>
+                    <a:lnR w="9525" cap="flat" cmpd="sng" algn="ctr">
+                      <a:solidFill>
+                        <a:srgbClr val="DDDDDD"/>
+                      </a:solidFill>
+                      <a:prstDash val="solid"/>
+                      <a:round/>
+                      <a:headEnd type="none" w="med" len="med"/>
+                      <a:tailEnd type="none" w="med" len="med"/>
+                    </a:lnR>
+                    <a:lnT w="9525" cap="flat" cmpd="sng" algn="ctr">
+                      <a:solidFill>
+                        <a:srgbClr val="DDDDDD"/>
+                      </a:solidFill>
+                      <a:prstDash val="solid"/>
+                      <a:round/>
+                      <a:headEnd type="none" w="med" len="med"/>
+                      <a:tailEnd type="none" w="med" len="med"/>
+                    </a:lnT>
+                    <a:lnB w="9525" cap="flat" cmpd="sng" algn="ctr">
+                      <a:solidFill>
+                        <a:srgbClr val="DDDDDD"/>
+                      </a:solidFill>
+                      <a:prstDash val="solid"/>
+                      <a:round/>
+                      <a:headEnd type="none" w="med" len="med"/>
+                      <a:tailEnd type="none" w="med" len="med"/>
+                    </a:lnB>
+                  </a:tcPr>
+                </a:tc>
+                <a:tc>
+                  <a:txBody>
+                    <a:bodyPr/>
+                    <a:lstStyle/>
+                    <a:p>
+                      <a:pPr algn="ctr" indent="0" marL="0">
+                        <a:buNone/>
+                      </a:pPr>
+                      <a:r>
+                        <a:rPr lang="en-US" sz="1250" dirty="0">
+                          <a:solidFill>
+                            <a:srgbClr val="2A2A2A"/>
+                          </a:solidFill>
+                          <a:latin typeface="Arial" pitchFamily="34" charset="0"/>
+                          <a:ea typeface="Arial" pitchFamily="34" charset="-122"/>
+                          <a:cs typeface="Arial" pitchFamily="34" charset="-120"/>
+                        </a:rPr>
+                        <a:t>$300</a:t>
+                      </a:r>
+                      <a:endParaRPr lang="en-US" sz="1250" dirty="0">
                         <a:latin typeface="Arial" charset="0"/>
                         <a:ea typeface="Arial" charset="0"/>
                         <a:cs typeface="Arial" charset="0"/>
@@ -3975,7 +4040,7 @@
                           <a:ea typeface="Arial" pitchFamily="34" charset="-122"/>
                           <a:cs typeface="Arial" pitchFamily="34" charset="-120"/>
                         </a:rPr>
-                        <a:t>$1,200</a:t>
+                        <a:t>$900</a:t>
                       </a:r>
                       <a:endParaRPr lang="en-US" sz="1250" dirty="0">
                         <a:latin typeface="Arial" charset="0"/>
@@ -4040,7 +4105,7 @@
                           <a:ea typeface="Arial" pitchFamily="34" charset="-122"/>
                           <a:cs typeface="Arial" pitchFamily="34" charset="-120"/>
                         </a:rPr>
-                        <a:t>$1,800</a:t>
+                        <a:t>$1,200</a:t>
                       </a:r>
                       <a:endParaRPr lang="en-US" sz="1250" dirty="0">
                         <a:latin typeface="Arial" charset="0"/>
@@ -4105,72 +4170,7 @@
                           <a:ea typeface="Arial" pitchFamily="34" charset="-122"/>
                           <a:cs typeface="Arial" pitchFamily="34" charset="-120"/>
                         </a:rPr>
-                        <a:t>$2,400</a:t>
-                      </a:r>
-                      <a:endParaRPr lang="en-US" sz="1250" dirty="0">
-                        <a:latin typeface="Arial" charset="0"/>
-                        <a:ea typeface="Arial" charset="0"/>
-                        <a:cs typeface="Arial" charset="0"/>
-                      </a:endParaRPr>
-                    </a:p>
-                  </a:txBody>
-                  <a:tcPr marL="64008" marR="64008" marT="64008" marB="64008" anchor="ctr">
-                    <a:lnL w="9525" cap="flat" cmpd="sng" algn="ctr">
-                      <a:solidFill>
-                        <a:srgbClr val="DDDDDD"/>
-                      </a:solidFill>
-                      <a:prstDash val="solid"/>
-                      <a:round/>
-                      <a:headEnd type="none" w="med" len="med"/>
-                      <a:tailEnd type="none" w="med" len="med"/>
-                    </a:lnL>
-                    <a:lnR w="9525" cap="flat" cmpd="sng" algn="ctr">
-                      <a:solidFill>
-                        <a:srgbClr val="DDDDDD"/>
-                      </a:solidFill>
-                      <a:prstDash val="solid"/>
-                      <a:round/>
-                      <a:headEnd type="none" w="med" len="med"/>
-                      <a:tailEnd type="none" w="med" len="med"/>
-                    </a:lnR>
-                    <a:lnT w="9525" cap="flat" cmpd="sng" algn="ctr">
-                      <a:solidFill>
-                        <a:srgbClr val="DDDDDD"/>
-                      </a:solidFill>
-                      <a:prstDash val="solid"/>
-                      <a:round/>
-                      <a:headEnd type="none" w="med" len="med"/>
-                      <a:tailEnd type="none" w="med" len="med"/>
-                    </a:lnT>
-                    <a:lnB w="9525" cap="flat" cmpd="sng" algn="ctr">
-                      <a:solidFill>
-                        <a:srgbClr val="DDDDDD"/>
-                      </a:solidFill>
-                      <a:prstDash val="solid"/>
-                      <a:round/>
-                      <a:headEnd type="none" w="med" len="med"/>
-                      <a:tailEnd type="none" w="med" len="med"/>
-                    </a:lnB>
-                  </a:tcPr>
-                </a:tc>
-                <a:tc>
-                  <a:txBody>
-                    <a:bodyPr/>
-                    <a:lstStyle/>
-                    <a:p>
-                      <a:pPr algn="ctr" indent="0" marL="0">
-                        <a:buNone/>
-                      </a:pPr>
-                      <a:r>
-                        <a:rPr lang="en-US" sz="1250" dirty="0">
-                          <a:solidFill>
-                            <a:srgbClr val="2A2A2A"/>
-                          </a:solidFill>
-                          <a:latin typeface="Arial" pitchFamily="34" charset="0"/>
-                          <a:ea typeface="Arial" pitchFamily="34" charset="-122"/>
-                          <a:cs typeface="Arial" pitchFamily="34" charset="-120"/>
-                        </a:rPr>
-                        <a:t>$3,000</a:t>
+                        <a:t>$1,500</a:t>
                       </a:r>
                       <a:endParaRPr lang="en-US" sz="1250" dirty="0">
                         <a:latin typeface="Arial" charset="0"/>
@@ -4629,7 +4629,7 @@
                           <a:ea typeface="Arial" pitchFamily="34" charset="-122"/>
                           <a:cs typeface="Arial" pitchFamily="34" charset="-120"/>
                         </a:rPr>
-                        <a:t>T^Rock net per closed job (after 50/50 PM split)</a:t>
+                        <a:t>T^Rock net per closed job (fee splits like any job cost)</a:t>
                       </a:r>
                       <a:endParaRPr lang="en-US" sz="1200" dirty="0">
                         <a:latin typeface="Arial" charset="0"/>
@@ -4694,7 +4694,7 @@
                           <a:ea typeface="Arial" pitchFamily="34" charset="-122"/>
                           <a:cs typeface="Arial" pitchFamily="34" charset="-120"/>
                         </a:rPr>
-                        <a:t>$4,950</a:t>
+                        <a:t>$7,350</a:t>
                       </a:r>
                       <a:endParaRPr lang="en-US" sz="1250" dirty="0">
                         <a:latin typeface="Arial" charset="0"/>
@@ -4759,7 +4759,7 @@
                           <a:ea typeface="Arial" pitchFamily="34" charset="-122"/>
                           <a:cs typeface="Arial" pitchFamily="34" charset="-120"/>
                         </a:rPr>
-                        <a:t>$4,650</a:t>
+                        <a:t>$7,200</a:t>
                       </a:r>
                       <a:endParaRPr lang="en-US" sz="1250" dirty="0">
                         <a:latin typeface="Arial" charset="0"/>
@@ -4824,7 +4824,7 @@
                           <a:ea typeface="Arial" pitchFamily="34" charset="-122"/>
                           <a:cs typeface="Arial" pitchFamily="34" charset="-120"/>
                         </a:rPr>
-                        <a:t>$4,350</a:t>
+                        <a:t>$7,050</a:t>
                       </a:r>
                       <a:endParaRPr lang="en-US" sz="1250" dirty="0">
                         <a:latin typeface="Arial" charset="0"/>
@@ -4889,7 +4889,7 @@
                           <a:ea typeface="Arial" pitchFamily="34" charset="-122"/>
                           <a:cs typeface="Arial" pitchFamily="34" charset="-120"/>
                         </a:rPr>
-                        <a:t>$4,050</a:t>
+                        <a:t>$6,900</a:t>
                       </a:r>
                       <a:endParaRPr lang="en-US" sz="1250" dirty="0">
                         <a:latin typeface="Arial" charset="0"/>
@@ -4954,7 +4954,7 @@
                           <a:ea typeface="Arial" pitchFamily="34" charset="-122"/>
                           <a:cs typeface="Arial" pitchFamily="34" charset="-120"/>
                         </a:rPr>
-                        <a:t>$3,750</a:t>
+                        <a:t>$6,750</a:t>
                       </a:r>
                       <a:endParaRPr lang="en-US" sz="1250" dirty="0">
                         <a:latin typeface="Arial" charset="0"/>
@@ -5086,7 +5086,7 @@
                           <a:ea typeface="Arial" pitchFamily="34" charset="-122"/>
                           <a:cs typeface="Arial" pitchFamily="34" charset="-120"/>
                         </a:rPr>
-                        <a:t>$9,900</a:t>
+                        <a:t>$14,700</a:t>
                       </a:r>
                       <a:endParaRPr lang="en-US" sz="1300" dirty="0">
                         <a:latin typeface="Arial" charset="0"/>
@@ -5154,7 +5154,7 @@
                           <a:ea typeface="Arial" pitchFamily="34" charset="-122"/>
                           <a:cs typeface="Arial" pitchFamily="34" charset="-120"/>
                         </a:rPr>
-                        <a:t>$18,600</a:t>
+                        <a:t>$28,800</a:t>
                       </a:r>
                       <a:endParaRPr lang="en-US" sz="1300" dirty="0">
                         <a:latin typeface="Arial" charset="0"/>
@@ -5222,7 +5222,7 @@
                           <a:ea typeface="Arial" pitchFamily="34" charset="-122"/>
                           <a:cs typeface="Arial" pitchFamily="34" charset="-120"/>
                         </a:rPr>
-                        <a:t>$26,100</a:t>
+                        <a:t>$42,300</a:t>
                       </a:r>
                       <a:endParaRPr lang="en-US" sz="1300" dirty="0">
                         <a:latin typeface="Arial" charset="0"/>
@@ -5290,7 +5290,7 @@
                           <a:ea typeface="Arial" pitchFamily="34" charset="-122"/>
                           <a:cs typeface="Arial" pitchFamily="34" charset="-120"/>
                         </a:rPr>
-                        <a:t>$32,400</a:t>
+                        <a:t>$55,200</a:t>
                       </a:r>
                       <a:endParaRPr lang="en-US" sz="1300" dirty="0">
                         <a:latin typeface="Arial" charset="0"/>
@@ -5358,7 +5358,7 @@
                           <a:ea typeface="Arial" pitchFamily="34" charset="-122"/>
                           <a:cs typeface="Arial" pitchFamily="34" charset="-120"/>
                         </a:rPr>
-                        <a:t>$37,500</a:t>
+                        <a:t>$67,500</a:t>
                       </a:r>
                       <a:endParaRPr lang="en-US" sz="1300" dirty="0">
                         <a:latin typeface="Arial" charset="0"/>
@@ -5469,7 +5469,7 @@
                 <a:ea typeface="Arial" pitchFamily="34" charset="-122"/>
                 <a:cs typeface="Arial" pitchFamily="34" charset="-120"/>
               </a:rPr>
-              <a:t>The “expensive” end of the slider is the one where T^Rock banks $37,500 on 10 leads instead of $9,900. </a:t>
+              <a:t>The “expensive” end of the slider is the one where T^Rock banks $67,500 on 10 leads instead of $14,700. </a:t>
             </a:r>
             <a:pPr indent="0" marL="0">
               <a:buNone/>
@@ -5522,7 +5522,7 @@
                 <a:ea typeface="Arial" pitchFamily="34" charset="-122"/>
                 <a:cs typeface="Arial" pitchFamily="34" charset="-120"/>
               </a:rPr>
-              <a:t>Total net = jobs closed (of 10) × net per closed job. Rates between tiers interpolate linearly. Close rate measured on a trailing quarter.</a:t>
+              <a:t>Typical job: $30,000 RCV at 50% margin = $15,000 profit. Fee is a job expense, so profit after fee splits 50/50 with the PM. Tiers interpolate linearly; close rate measured on a trailing quarter.</a:t>
             </a:r>
             <a:endParaRPr lang="en-US" sz="900" dirty="0"/>
           </a:p>
@@ -5854,7 +5854,7 @@
                 <a:ea typeface="Arial" pitchFamily="34" charset="-122"/>
                 <a:cs typeface="Arial" pitchFamily="34" charset="-120"/>
               </a:rPr>
-              <a:t>Scoped leads where most won't close. The fee collects on the few that do — priced like professional scope work, paid only on results. At a 20% close rate, 8 of every 10 scopes were written for free.</a:t>
+              <a:t>Of job profit — $300 on a typical roof. Scoped leads where most won't close; the fee collects on the few that do. At a 20% close rate, 8 of every 10 scopes were written for free.</a:t>
             </a:r>
             <a:endParaRPr lang="en-US" sz="1250" dirty="0"/>
           </a:p>
@@ -6037,7 +6037,7 @@
                 <a:ea typeface="Arial" pitchFamily="34" charset="-122"/>
                 <a:cs typeface="Arial" pitchFamily="34" charset="-120"/>
               </a:rPr>
-              <a:t>A lead that closes 100% of the time is a signed contract changing hands. That's a referral — and 10% of contract value is the standard referral fee. Nobody blinks at 10% for a job that's already sold.</a:t>
+              <a:t>A lead that closes 100% of the time is a signed contract changing hands — a referral. The customary referral fee is ~10% of contract value; 10% of profit is $1,500 on a $30,000 roof — just 5% of contract. Half the going rate for a done deal.</a:t>
             </a:r>
             <a:endParaRPr lang="en-US" sz="1250" dirty="0"/>
           </a:p>
@@ -6151,7 +6151,7 @@
                 <a:ea typeface="Arial" pitchFamily="34" charset="-122"/>
                 <a:cs typeface="Arial" pitchFamily="34" charset="-120"/>
               </a:rPr>
-              <a:t>Referral benchmark: ~10% of contract value is the customary fee for handed-off, ready-to-sign work in residential contracting.</a:t>
+              <a:t>Referral benchmark: ~10% of contract value is the customary fee for handed-off, ready-to-sign work — this plan's ceiling works out to half that.</a:t>
             </a:r>
             <a:endParaRPr lang="en-US" sz="900" dirty="0"/>
           </a:p>
@@ -6373,12 +6373,12 @@
         </p:nvSpPr>
         <p:spPr>
           <a:xfrm>
-            <a:off x="1005840" y="4194536"/>
-            <a:ext cx="1371600" cy="651784"/>
+            <a:off x="1005840" y="4308653"/>
+            <a:ext cx="1371600" cy="537667"/>
           </a:xfrm>
           <a:prstGeom prst="roundRect">
             <a:avLst>
-              <a:gd name="adj" fmla="val 4209"/>
+              <a:gd name="adj" fmla="val 5102"/>
             </a:avLst>
           </a:prstGeom>
           <a:solidFill>
@@ -6395,7 +6395,7 @@
         </p:nvSpPr>
         <p:spPr>
           <a:xfrm>
-            <a:off x="685800" y="3847064"/>
+            <a:off x="685800" y="3961181"/>
             <a:ext cx="2011680" cy="320040"/>
           </a:xfrm>
           <a:prstGeom prst="rect">
@@ -6420,7 +6420,7 @@
                 <a:ea typeface="Arial" pitchFamily="34" charset="-122"/>
                 <a:cs typeface="Arial" pitchFamily="34" charset="-120"/>
               </a:rPr>
-              <a:t>$99,000</a:t>
+              <a:t>$147,000</a:t>
             </a:r>
             <a:endParaRPr lang="en-US" sz="1350" dirty="0"/>
           </a:p>
@@ -6473,12 +6473,12 @@
         </p:nvSpPr>
         <p:spPr>
           <a:xfrm>
-            <a:off x="3200400" y="3621756"/>
-            <a:ext cx="1371600" cy="1224564"/>
+            <a:off x="3200400" y="3792931"/>
+            <a:ext cx="1371600" cy="1053389"/>
           </a:xfrm>
           <a:prstGeom prst="roundRect">
             <a:avLst>
-              <a:gd name="adj" fmla="val 2240"/>
+              <a:gd name="adj" fmla="val 2604"/>
             </a:avLst>
           </a:prstGeom>
           <a:solidFill>
@@ -6495,7 +6495,7 @@
         </p:nvSpPr>
         <p:spPr>
           <a:xfrm>
-            <a:off x="2880360" y="3274284"/>
+            <a:off x="2880360" y="3445459"/>
             <a:ext cx="2011680" cy="320040"/>
           </a:xfrm>
           <a:prstGeom prst="rect">
@@ -6520,7 +6520,7 @@
                 <a:ea typeface="Arial" pitchFamily="34" charset="-122"/>
                 <a:cs typeface="Arial" pitchFamily="34" charset="-120"/>
               </a:rPr>
-              <a:t>$186,000</a:t>
+              <a:t>$288,000</a:t>
             </a:r>
             <a:endParaRPr lang="en-US" sz="1350" dirty="0"/>
           </a:p>
@@ -6573,8 +6573,8 @@
         </p:nvSpPr>
         <p:spPr>
           <a:xfrm>
-            <a:off x="5394960" y="3127980"/>
-            <a:ext cx="1371600" cy="1718340"/>
+            <a:off x="5394960" y="3299155"/>
+            <a:ext cx="1371600" cy="1547165"/>
           </a:xfrm>
           <a:prstGeom prst="roundRect">
             <a:avLst>
@@ -6595,7 +6595,7 @@
         </p:nvSpPr>
         <p:spPr>
           <a:xfrm>
-            <a:off x="5074920" y="2780508"/>
+            <a:off x="5074920" y="2951683"/>
             <a:ext cx="2011680" cy="320040"/>
           </a:xfrm>
           <a:prstGeom prst="rect">
@@ -6620,7 +6620,7 @@
                 <a:ea typeface="Arial" pitchFamily="34" charset="-122"/>
                 <a:cs typeface="Arial" pitchFamily="34" charset="-120"/>
               </a:rPr>
-              <a:t>$261,000</a:t>
+              <a:t>$423,000</a:t>
             </a:r>
             <a:endParaRPr lang="en-US" sz="1350" dirty="0"/>
           </a:p>
@@ -6673,8 +6673,8 @@
         </p:nvSpPr>
         <p:spPr>
           <a:xfrm>
-            <a:off x="7589520" y="2713208"/>
-            <a:ext cx="1371600" cy="2133112"/>
+            <a:off x="7589520" y="2827325"/>
+            <a:ext cx="1371600" cy="2018995"/>
           </a:xfrm>
           <a:prstGeom prst="roundRect">
             <a:avLst>
@@ -6695,7 +6695,7 @@
         </p:nvSpPr>
         <p:spPr>
           <a:xfrm>
-            <a:off x="7269480" y="2365736"/>
+            <a:off x="7269480" y="2479853"/>
             <a:ext cx="2011680" cy="320040"/>
           </a:xfrm>
           <a:prstGeom prst="rect">
@@ -6720,7 +6720,7 @@
                 <a:ea typeface="Arial" pitchFamily="34" charset="-122"/>
                 <a:cs typeface="Arial" pitchFamily="34" charset="-120"/>
               </a:rPr>
-              <a:t>$324,000</a:t>
+              <a:t>$552,000</a:t>
             </a:r>
             <a:endParaRPr lang="en-US" sz="1350" dirty="0"/>
           </a:p>
@@ -6820,7 +6820,7 @@
                 <a:ea typeface="Arial" pitchFamily="34" charset="-122"/>
                 <a:cs typeface="Arial" pitchFamily="34" charset="-120"/>
               </a:rPr>
-              <a:t>$375,000</a:t>
+              <a:t>$675,000</a:t>
             </a:r>
             <a:endParaRPr lang="en-US" sz="1600" dirty="0"/>
           </a:p>
@@ -6920,7 +6920,7 @@
                 <a:ea typeface="Arial" pitchFamily="34" charset="-122"/>
                 <a:cs typeface="Arial" pitchFamily="34" charset="-120"/>
               </a:rPr>
-              <a:t>Top of the slider = T^Rock's take is up nearly 4×. </a:t>
+              <a:t>Top of the slider = T^Rock's take is up 4.6×. </a:t>
             </a:r>
             <a:pPr indent="0" marL="0">
               <a:buNone/>
@@ -6973,7 +6973,7 @@
                 <a:ea typeface="Arial" pitchFamily="34" charset="-122"/>
                 <a:cs typeface="Arial" pitchFamily="34" charset="-120"/>
               </a:rPr>
-              <a:t>Per closed job: $30,000 × 35% margin, less slider fee, split 50/50 with the PM. 100 scoped leads held constant across scenarios.</a:t>
+              <a:t>Per closed job: $30,000 × 50% margin = $15,000, less slider fee (a job expense), split 50/50 with the PM. 100 scoped leads held constant.</a:t>
             </a:r>
             <a:endParaRPr lang="en-US" sz="900" dirty="0"/>
           </a:p>
@@ -7188,7 +7188,7 @@
                 <a:ea typeface="Arial" pitchFamily="34" charset="-122"/>
                 <a:cs typeface="Arial" pitchFamily="34" charset="-120"/>
               </a:rPr>
-              <a:t>Option A — % of RCV</a:t>
+              <a:t>Option A — % of job profit</a:t>
             </a:r>
             <a:endParaRPr lang="en-US" sz="1700" dirty="0"/>
           </a:p>
@@ -7227,7 +7227,7 @@
                 <a:ea typeface="Arial" pitchFamily="34" charset="-122"/>
                 <a:cs typeface="Arial" pitchFamily="34" charset="-120"/>
               </a:rPr>
-              <a:t>the numbers shown so far</a:t>
+              <a:t>the plan as shown</a:t>
             </a:r>
             <a:endParaRPr lang="en-US" sz="1150" dirty="0"/>
           </a:p>
@@ -7270,7 +7270,7 @@
                 <a:ea typeface="Arial" pitchFamily="34" charset="-122"/>
                 <a:cs typeface="Arial" pitchFamily="34" charset="-120"/>
               </a:rPr>
-              <a:t>Verified straight off the carrier paperwork — no accounting disputes, ever</a:t>
+              <a:t>Booked as a job expense, so it splits with the PM like every other job cost — each side effectively carries half</a:t>
             </a:r>
             <a:endParaRPr lang="en-US" sz="1250" dirty="0"/>
           </a:p>
@@ -7291,7 +7291,7 @@
                 <a:ea typeface="Arial" pitchFamily="34" charset="-122"/>
                 <a:cs typeface="Arial" pitchFamily="34" charset="-120"/>
               </a:rPr>
-              <a:t>Insulated from cost overruns neither side controls</a:t>
+              <a:t>Worked example: $30,000 roof → $15,000 profit → 10% fee = $1,500 → $13,500 splits 50/50 → T^Rock nets $6,750</a:t>
             </a:r>
             <a:endParaRPr lang="en-US" sz="1250" dirty="0"/>
           </a:p>
@@ -7312,7 +7312,7 @@
                 <a:ea typeface="Arial" pitchFamily="34" charset="-122"/>
                 <a:cs typeface="Arial" pitchFamily="34" charset="-120"/>
               </a:rPr>
-              <a:t>Slider band: 2% → 10% of RCV</a:t>
+              <a:t>Fee shrinks automatically on thin-margin jobs — T^Rock is never overcharged on a bad one</a:t>
             </a:r>
             <a:endParaRPr lang="en-US" sz="1250" dirty="0"/>
           </a:p>
@@ -7330,7 +7330,7 @@
                 <a:ea typeface="Arial" pitchFamily="34" charset="-122"/>
                 <a:cs typeface="Arial" pitchFamily="34" charset="-120"/>
               </a:rPr>
-              <a:t>At 50% close: 5% × $30,000 = $1,500 per closed job</a:t>
+              <a:t>Needs job costing both sides can see</a:t>
             </a:r>
             <a:endParaRPr lang="en-US" sz="1250" dirty="0"/>
           </a:p>
@@ -7435,7 +7435,7 @@
                 <a:ea typeface="Arial" pitchFamily="34" charset="-122"/>
                 <a:cs typeface="Arial" pitchFamily="34" charset="-120"/>
               </a:rPr>
-              <a:t>Option B — % of job profit</a:t>
+              <a:t>Option B — % of RCV</a:t>
             </a:r>
             <a:endParaRPr lang="en-US" sz="1700" dirty="0"/>
           </a:p>
@@ -7474,7 +7474,7 @@
                 <a:ea typeface="Arial" pitchFamily="34" charset="-122"/>
                 <a:cs typeface="Arial" pitchFamily="34" charset="-120"/>
               </a:rPr>
-              <a:t>equivalent dollars, different base</a:t>
+              <a:t>same dollars, different base</a:t>
             </a:r>
             <a:endParaRPr lang="en-US" sz="1150" dirty="0"/>
           </a:p>
@@ -7517,7 +7517,7 @@
                 <a:ea typeface="Arial" pitchFamily="34" charset="-122"/>
                 <a:cs typeface="Arial" pitchFamily="34" charset="-120"/>
               </a:rPr>
-              <a:t>Scales with margin — the fee shrinks automatically on thin jobs</a:t>
+              <a:t>Equivalent band at today's margins: 1% → 5% of contract value</a:t>
             </a:r>
             <a:endParaRPr lang="en-US" sz="1250" dirty="0"/>
           </a:p>
@@ -7538,7 +7538,7 @@
                 <a:ea typeface="Arial" pitchFamily="34" charset="-122"/>
                 <a:cs typeface="Arial" pitchFamily="34" charset="-120"/>
               </a:rPr>
-              <a:t>Requires open-book job costing both sides trust</a:t>
+              <a:t>Verified straight off the carrier paperwork — no job-costing disputes, ever</a:t>
             </a:r>
             <a:endParaRPr lang="en-US" sz="1250" dirty="0"/>
           </a:p>
@@ -7559,7 +7559,7 @@
                 <a:ea typeface="Arial" pitchFamily="34" charset="-122"/>
                 <a:cs typeface="Arial" pitchFamily="34" charset="-120"/>
               </a:rPr>
-              <a:t>Equivalent slider band: ~6% → 28% of job gross profit</a:t>
+              <a:t>Insulated from cost overruns; the fee holds even if margins slip</a:t>
             </a:r>
             <a:endParaRPr lang="en-US" sz="1250" dirty="0"/>
           </a:p>
@@ -7577,7 +7577,7 @@
                 <a:ea typeface="Arial" pitchFamily="34" charset="-122"/>
                 <a:cs typeface="Arial" pitchFamily="34" charset="-120"/>
               </a:rPr>
-              <a:t>At 50% close: ~14% × $10,500 = ~$1,470 per closed job</a:t>
+              <a:t>Pick this if open-book job costing is a sticking point</a:t>
             </a:r>
             <a:endParaRPr lang="en-US" sz="1250" dirty="0"/>
           </a:p>
@@ -7652,7 +7652,7 @@
                 <a:ea typeface="Arial" pitchFamily="34" charset="-122"/>
                 <a:cs typeface="Arial" pitchFamily="34" charset="-120"/>
               </a:rPr>
-              <a:t>A is simpler to verify; B is tighter to margin. The only wrong answer is leaving the definition verbal.</a:t>
+              <a:t>A rides the profit pool and splits with the PM; B is simpler to audit. The only wrong answer is leaving the definition verbal.</a:t>
             </a:r>
             <a:endParaRPr lang="en-US" sz="1450" dirty="0"/>
           </a:p>
@@ -8893,7 +8893,7 @@
                 <a:ea typeface="Arial" pitchFamily="34" charset="-122"/>
                 <a:cs typeface="Arial" pitchFamily="34" charset="-120"/>
               </a:rPr>
-              <a:t>Option A (% of RCV) or Option B (% of job profit). One page, signed, with the slider table attached.</a:t>
+              <a:t>Option A (% of job profit, splits like a job cost) or Option B (% of RCV). One page, signed, with the slider table attached.</a:t>
             </a:r>
             <a:endParaRPr lang="en-US" sz="1250" dirty="0"/>
           </a:p>

</xml_diff>

<commit_message>
Remove icon backing circles; define cohort-based close rate
Some viewers ghost ellipse shapes across slides during scroll, showing
stray red discs over text. Both decks now render icons as flat glyphs
(red on light backgrounds, white on dark) with no ellipse shapes
anywhere in either file.

Commission plan defines close-rate measurement by cohort: a lead
belongs to the quarter it was scoped, late closers re-rate that cohort
within a 180-day maturity window, and quarter-end true-ups pay the
difference - the rate can only move up, so no clawbacks.

Co-Authored-By: Claude Fable 5 <noreply@anthropic.com>
Claude-Session: https://claude.ai/code/session_01Qj1b2D7LVH4xves4mfA9FY
</commit_message>
<xml_diff>
--- a/pitch/Commission-Plan.pptx
+++ b/pitch/Commission-Plan.pptx
@@ -1498,29 +1498,9 @@
           <a:chExt cx="0" cy="0"/>
         </a:xfrm>
       </p:grpSpPr>
-      <p:sp>
-        <p:nvSpPr>
-          <p:cNvPr id="2" name="Shape 0"/>
-          <p:cNvSpPr/>
-          <p:nvPr/>
-        </p:nvSpPr>
-        <p:spPr>
-          <a:xfrm>
-            <a:off x="685800" y="777240"/>
-            <a:ext cx="822960" cy="822960"/>
-          </a:xfrm>
-          <a:prstGeom prst="ellipse">
-            <a:avLst/>
-          </a:prstGeom>
-          <a:solidFill>
-            <a:srgbClr val="C8102E"/>
-          </a:solidFill>
-          <a:ln/>
-        </p:spPr>
-      </p:sp>
       <p:pic>
         <p:nvPicPr>
-          <p:cNvPr id="3" name="Image 0" descr="preencoded.png">    </p:cNvPr>
+          <p:cNvPr id="2" name="Image 0" descr="preencoded.png">    </p:cNvPr>
           <p:cNvPicPr>
             <a:picLocks noChangeAspect="1"/>
           </p:cNvPicPr>
@@ -1534,8 +1514,8 @@
         </p:blipFill>
         <p:spPr>
           <a:xfrm>
-            <a:off x="899770" y="991210"/>
-            <a:ext cx="395021" cy="395021"/>
+            <a:off x="685800" y="777240"/>
+            <a:ext cx="822960" cy="822960"/>
           </a:xfrm>
           <a:prstGeom prst="rect">
             <a:avLst/>
@@ -1544,7 +1524,7 @@
       </p:pic>
       <p:sp>
         <p:nvSpPr>
-          <p:cNvPr id="4" name="Text 1"/>
+          <p:cNvPr id="3" name="Text 0"/>
           <p:cNvSpPr/>
           <p:nvPr/>
         </p:nvSpPr>
@@ -1583,7 +1563,7 @@
       </p:sp>
       <p:sp>
         <p:nvSpPr>
-          <p:cNvPr id="5" name="Text 2"/>
+          <p:cNvPr id="4" name="Text 1"/>
           <p:cNvSpPr/>
           <p:nvPr/>
         </p:nvSpPr>
@@ -1622,7 +1602,7 @@
       </p:sp>
       <p:sp>
         <p:nvSpPr>
-          <p:cNvPr id="6" name="Text 3"/>
+          <p:cNvPr id="5" name="Text 2"/>
           <p:cNvSpPr/>
           <p:nvPr/>
         </p:nvSpPr>
@@ -1675,7 +1655,7 @@
       </p:sp>
       <p:sp>
         <p:nvSpPr>
-          <p:cNvPr id="7" name="Text 4"/>
+          <p:cNvPr id="6" name="Text 3"/>
           <p:cNvSpPr/>
           <p:nvPr/>
         </p:nvSpPr>
@@ -1844,29 +1824,9 @@
           <a:ln/>
         </p:spPr>
       </p:sp>
-      <p:sp>
-        <p:nvSpPr>
-          <p:cNvPr id="5" name="Shape 3"/>
-          <p:cNvSpPr/>
-          <p:nvPr/>
-        </p:nvSpPr>
-        <p:spPr>
-          <a:xfrm>
-            <a:off x="822960" y="2103120"/>
-            <a:ext cx="640080" cy="640080"/>
-          </a:xfrm>
-          <a:prstGeom prst="ellipse">
-            <a:avLst/>
-          </a:prstGeom>
-          <a:solidFill>
-            <a:srgbClr val="C8102E"/>
-          </a:solidFill>
-          <a:ln/>
-        </p:spPr>
-      </p:sp>
       <p:pic>
         <p:nvPicPr>
-          <p:cNvPr id="6" name="Image 0" descr="preencoded.png">    </p:cNvPr>
+          <p:cNvPr id="5" name="Image 0" descr="preencoded.png">    </p:cNvPr>
           <p:cNvPicPr>
             <a:picLocks noChangeAspect="1"/>
           </p:cNvPicPr>
@@ -1880,8 +1840,8 @@
         </p:blipFill>
         <p:spPr>
           <a:xfrm>
-            <a:off x="989381" y="2269541"/>
-            <a:ext cx="307238" cy="307238"/>
+            <a:off x="822960" y="2103120"/>
+            <a:ext cx="640080" cy="640080"/>
           </a:xfrm>
           <a:prstGeom prst="rect">
             <a:avLst/>
@@ -1890,7 +1850,7 @@
       </p:pic>
       <p:sp>
         <p:nvSpPr>
-          <p:cNvPr id="7" name="Text 4"/>
+          <p:cNvPr id="6" name="Text 3"/>
           <p:cNvSpPr/>
           <p:nvPr/>
         </p:nvSpPr>
@@ -1929,7 +1889,7 @@
       </p:sp>
       <p:sp>
         <p:nvSpPr>
-          <p:cNvPr id="8" name="Text 5"/>
+          <p:cNvPr id="7" name="Text 4"/>
           <p:cNvSpPr/>
           <p:nvPr/>
         </p:nvSpPr>
@@ -1968,7 +1928,7 @@
       </p:sp>
       <p:sp>
         <p:nvSpPr>
-          <p:cNvPr id="9" name="Shape 6"/>
+          <p:cNvPr id="8" name="Shape 5"/>
           <p:cNvSpPr/>
           <p:nvPr/>
         </p:nvSpPr>
@@ -1988,29 +1948,9 @@
           <a:ln/>
         </p:spPr>
       </p:sp>
-      <p:sp>
-        <p:nvSpPr>
-          <p:cNvPr id="10" name="Shape 7"/>
-          <p:cNvSpPr/>
-          <p:nvPr/>
-        </p:nvSpPr>
-        <p:spPr>
-          <a:xfrm>
-            <a:off x="6492240" y="2103120"/>
-            <a:ext cx="640080" cy="640080"/>
-          </a:xfrm>
-          <a:prstGeom prst="ellipse">
-            <a:avLst/>
-          </a:prstGeom>
-          <a:solidFill>
-            <a:srgbClr val="C8102E"/>
-          </a:solidFill>
-          <a:ln/>
-        </p:spPr>
-      </p:sp>
       <p:pic>
         <p:nvPicPr>
-          <p:cNvPr id="11" name="Image 1" descr="preencoded.png">    </p:cNvPr>
+          <p:cNvPr id="9" name="Image 1" descr="preencoded.png">    </p:cNvPr>
           <p:cNvPicPr>
             <a:picLocks noChangeAspect="1"/>
           </p:cNvPicPr>
@@ -2024,8 +1964,8 @@
         </p:blipFill>
         <p:spPr>
           <a:xfrm>
-            <a:off x="6658661" y="2269541"/>
-            <a:ext cx="307238" cy="307238"/>
+            <a:off x="6492240" y="2103120"/>
+            <a:ext cx="640080" cy="640080"/>
           </a:xfrm>
           <a:prstGeom prst="rect">
             <a:avLst/>
@@ -2034,7 +1974,7 @@
       </p:pic>
       <p:sp>
         <p:nvSpPr>
-          <p:cNvPr id="12" name="Text 8"/>
+          <p:cNvPr id="10" name="Text 6"/>
           <p:cNvSpPr/>
           <p:nvPr/>
         </p:nvSpPr>
@@ -2073,7 +2013,7 @@
       </p:sp>
       <p:sp>
         <p:nvSpPr>
-          <p:cNvPr id="13" name="Text 9"/>
+          <p:cNvPr id="11" name="Text 7"/>
           <p:cNvSpPr/>
           <p:nvPr/>
         </p:nvSpPr>
@@ -2112,7 +2052,7 @@
       </p:sp>
       <p:sp>
         <p:nvSpPr>
-          <p:cNvPr id="14" name="Shape 10"/>
+          <p:cNvPr id="12" name="Shape 8"/>
           <p:cNvSpPr/>
           <p:nvPr/>
         </p:nvSpPr>
@@ -2132,29 +2072,9 @@
           <a:ln/>
         </p:spPr>
       </p:sp>
-      <p:sp>
-        <p:nvSpPr>
-          <p:cNvPr id="15" name="Shape 11"/>
-          <p:cNvSpPr/>
-          <p:nvPr/>
-        </p:nvSpPr>
-        <p:spPr>
-          <a:xfrm>
-            <a:off x="822960" y="4297680"/>
-            <a:ext cx="640080" cy="640080"/>
-          </a:xfrm>
-          <a:prstGeom prst="ellipse">
-            <a:avLst/>
-          </a:prstGeom>
-          <a:solidFill>
-            <a:srgbClr val="C8102E"/>
-          </a:solidFill>
-          <a:ln/>
-        </p:spPr>
-      </p:sp>
       <p:pic>
         <p:nvPicPr>
-          <p:cNvPr id="16" name="Image 2" descr="preencoded.png">    </p:cNvPr>
+          <p:cNvPr id="13" name="Image 2" descr="preencoded.png">    </p:cNvPr>
           <p:cNvPicPr>
             <a:picLocks noChangeAspect="1"/>
           </p:cNvPicPr>
@@ -2168,8 +2088,8 @@
         </p:blipFill>
         <p:spPr>
           <a:xfrm>
-            <a:off x="989381" y="4464101"/>
-            <a:ext cx="307238" cy="307238"/>
+            <a:off x="822960" y="4297680"/>
+            <a:ext cx="640080" cy="640080"/>
           </a:xfrm>
           <a:prstGeom prst="rect">
             <a:avLst/>
@@ -2178,7 +2098,7 @@
       </p:pic>
       <p:sp>
         <p:nvSpPr>
-          <p:cNvPr id="17" name="Text 12"/>
+          <p:cNvPr id="14" name="Text 9"/>
           <p:cNvSpPr/>
           <p:nvPr/>
         </p:nvSpPr>
@@ -2217,7 +2137,7 @@
       </p:sp>
       <p:sp>
         <p:nvSpPr>
-          <p:cNvPr id="18" name="Text 13"/>
+          <p:cNvPr id="15" name="Text 10"/>
           <p:cNvSpPr/>
           <p:nvPr/>
         </p:nvSpPr>
@@ -2256,7 +2176,7 @@
       </p:sp>
       <p:sp>
         <p:nvSpPr>
-          <p:cNvPr id="19" name="Shape 14"/>
+          <p:cNvPr id="16" name="Shape 11"/>
           <p:cNvSpPr/>
           <p:nvPr/>
         </p:nvSpPr>
@@ -2276,29 +2196,9 @@
           <a:ln/>
         </p:spPr>
       </p:sp>
-      <p:sp>
-        <p:nvSpPr>
-          <p:cNvPr id="20" name="Shape 15"/>
-          <p:cNvSpPr/>
-          <p:nvPr/>
-        </p:nvSpPr>
-        <p:spPr>
-          <a:xfrm>
-            <a:off x="6492240" y="4297680"/>
-            <a:ext cx="640080" cy="640080"/>
-          </a:xfrm>
-          <a:prstGeom prst="ellipse">
-            <a:avLst/>
-          </a:prstGeom>
-          <a:solidFill>
-            <a:srgbClr val="C8102E"/>
-          </a:solidFill>
-          <a:ln/>
-        </p:spPr>
-      </p:sp>
       <p:pic>
         <p:nvPicPr>
-          <p:cNvPr id="21" name="Image 3" descr="preencoded.png">    </p:cNvPr>
+          <p:cNvPr id="17" name="Image 3" descr="preencoded.png">    </p:cNvPr>
           <p:cNvPicPr>
             <a:picLocks noChangeAspect="1"/>
           </p:cNvPicPr>
@@ -2312,8 +2212,8 @@
         </p:blipFill>
         <p:spPr>
           <a:xfrm>
-            <a:off x="6658661" y="4464101"/>
-            <a:ext cx="307238" cy="307238"/>
+            <a:off x="6492240" y="4297680"/>
+            <a:ext cx="640080" cy="640080"/>
           </a:xfrm>
           <a:prstGeom prst="rect">
             <a:avLst/>
@@ -2322,7 +2222,7 @@
       </p:pic>
       <p:sp>
         <p:nvSpPr>
-          <p:cNvPr id="22" name="Text 16"/>
+          <p:cNvPr id="18" name="Text 12"/>
           <p:cNvSpPr/>
           <p:nvPr/>
         </p:nvSpPr>
@@ -2361,7 +2261,7 @@
       </p:sp>
       <p:sp>
         <p:nvSpPr>
-          <p:cNvPr id="23" name="Text 17"/>
+          <p:cNvPr id="19" name="Text 13"/>
           <p:cNvSpPr/>
           <p:nvPr/>
         </p:nvSpPr>
@@ -2400,7 +2300,7 @@
       </p:sp>
       <p:sp>
         <p:nvSpPr>
-          <p:cNvPr id="24" name="Text 18"/>
+          <p:cNvPr id="20" name="Text 14"/>
           <p:cNvSpPr/>
           <p:nvPr/>
         </p:nvSpPr>
@@ -2428,7 +2328,7 @@
       </p:sp>
       <p:sp>
         <p:nvSpPr>
-          <p:cNvPr id="25" name="Text 19"/>
+          <p:cNvPr id="21" name="Text 15"/>
           <p:cNvSpPr/>
           <p:nvPr/>
         </p:nvSpPr>
@@ -5522,7 +5422,7 @@
                 <a:ea typeface="Arial" pitchFamily="34" charset="-122"/>
                 <a:cs typeface="Arial" pitchFamily="34" charset="-120"/>
               </a:rPr>
-              <a:t>Typical job: $30,000 RCV at 50% margin = $15,000 profit. Fee is a job expense, so profit after fee splits 50/50 with the PM. Tiers interpolate linearly; close rate measured on a trailing quarter.</a:t>
+              <a:t>Typical job: $30,000 RCV at 50% margin = $15,000 profit; fee is a job expense, so profit after fee splits 50/50. Close rate is cohort-based — a lead belongs to the quarter it was scoped; late closers re-rate that cohort (180-day window), so the rate only moves up.</a:t>
             </a:r>
             <a:endParaRPr lang="en-US" sz="900" dirty="0"/>
           </a:p>
@@ -5699,29 +5599,9 @@
           <a:ln/>
         </p:spPr>
       </p:sp>
-      <p:sp>
-        <p:nvSpPr>
-          <p:cNvPr id="5" name="Shape 3"/>
-          <p:cNvSpPr/>
-          <p:nvPr/>
-        </p:nvSpPr>
-        <p:spPr>
-          <a:xfrm>
-            <a:off x="822960" y="1920240"/>
-            <a:ext cx="640080" cy="640080"/>
-          </a:xfrm>
-          <a:prstGeom prst="ellipse">
-            <a:avLst/>
-          </a:prstGeom>
-          <a:solidFill>
-            <a:srgbClr val="C8102E"/>
-          </a:solidFill>
-          <a:ln/>
-        </p:spPr>
-      </p:sp>
       <p:pic>
         <p:nvPicPr>
-          <p:cNvPr id="6" name="Image 0" descr="preencoded.png">    </p:cNvPr>
+          <p:cNvPr id="5" name="Image 0" descr="preencoded.png">    </p:cNvPr>
           <p:cNvPicPr>
             <a:picLocks noChangeAspect="1"/>
           </p:cNvPicPr>
@@ -5735,8 +5615,8 @@
         </p:blipFill>
         <p:spPr>
           <a:xfrm>
-            <a:off x="989381" y="2086661"/>
-            <a:ext cx="307238" cy="307238"/>
+            <a:off x="822960" y="1920240"/>
+            <a:ext cx="640080" cy="640080"/>
           </a:xfrm>
           <a:prstGeom prst="rect">
             <a:avLst/>
@@ -5745,7 +5625,7 @@
       </p:pic>
       <p:sp>
         <p:nvSpPr>
-          <p:cNvPr id="7" name="Text 4"/>
+          <p:cNvPr id="6" name="Text 3"/>
           <p:cNvSpPr/>
           <p:nvPr/>
         </p:nvSpPr>
@@ -5784,7 +5664,7 @@
       </p:sp>
       <p:sp>
         <p:nvSpPr>
-          <p:cNvPr id="8" name="Text 5"/>
+          <p:cNvPr id="7" name="Text 4"/>
           <p:cNvSpPr/>
           <p:nvPr/>
         </p:nvSpPr>
@@ -5823,7 +5703,7 @@
       </p:sp>
       <p:sp>
         <p:nvSpPr>
-          <p:cNvPr id="9" name="Text 6"/>
+          <p:cNvPr id="8" name="Text 5"/>
           <p:cNvSpPr/>
           <p:nvPr/>
         </p:nvSpPr>
@@ -5862,7 +5742,7 @@
       </p:sp>
       <p:sp>
         <p:nvSpPr>
-          <p:cNvPr id="10" name="Shape 7"/>
+          <p:cNvPr id="9" name="Shape 6"/>
           <p:cNvSpPr/>
           <p:nvPr/>
         </p:nvSpPr>
@@ -5882,29 +5762,9 @@
           <a:ln/>
         </p:spPr>
       </p:sp>
-      <p:sp>
-        <p:nvSpPr>
-          <p:cNvPr id="11" name="Shape 8"/>
-          <p:cNvSpPr/>
-          <p:nvPr/>
-        </p:nvSpPr>
-        <p:spPr>
-          <a:xfrm>
-            <a:off x="6492240" y="1920240"/>
-            <a:ext cx="640080" cy="640080"/>
-          </a:xfrm>
-          <a:prstGeom prst="ellipse">
-            <a:avLst/>
-          </a:prstGeom>
-          <a:solidFill>
-            <a:srgbClr val="C8102E"/>
-          </a:solidFill>
-          <a:ln/>
-        </p:spPr>
-      </p:sp>
       <p:pic>
         <p:nvPicPr>
-          <p:cNvPr id="12" name="Image 1" descr="preencoded.png">    </p:cNvPr>
+          <p:cNvPr id="10" name="Image 1" descr="preencoded.png">    </p:cNvPr>
           <p:cNvPicPr>
             <a:picLocks noChangeAspect="1"/>
           </p:cNvPicPr>
@@ -5918,8 +5778,8 @@
         </p:blipFill>
         <p:spPr>
           <a:xfrm>
-            <a:off x="6658661" y="2086661"/>
-            <a:ext cx="307238" cy="307238"/>
+            <a:off x="6492240" y="1920240"/>
+            <a:ext cx="640080" cy="640080"/>
           </a:xfrm>
           <a:prstGeom prst="rect">
             <a:avLst/>
@@ -5928,7 +5788,7 @@
       </p:pic>
       <p:sp>
         <p:nvSpPr>
-          <p:cNvPr id="13" name="Text 9"/>
+          <p:cNvPr id="11" name="Text 7"/>
           <p:cNvSpPr/>
           <p:nvPr/>
         </p:nvSpPr>
@@ -5967,7 +5827,7 @@
       </p:sp>
       <p:sp>
         <p:nvSpPr>
-          <p:cNvPr id="14" name="Text 10"/>
+          <p:cNvPr id="12" name="Text 8"/>
           <p:cNvSpPr/>
           <p:nvPr/>
         </p:nvSpPr>
@@ -6006,7 +5866,7 @@
       </p:sp>
       <p:sp>
         <p:nvSpPr>
-          <p:cNvPr id="15" name="Text 11"/>
+          <p:cNvPr id="13" name="Text 9"/>
           <p:cNvSpPr/>
           <p:nvPr/>
         </p:nvSpPr>
@@ -6045,7 +5905,7 @@
       </p:sp>
       <p:sp>
         <p:nvSpPr>
-          <p:cNvPr id="16" name="Shape 12"/>
+          <p:cNvPr id="14" name="Shape 10"/>
           <p:cNvSpPr/>
           <p:nvPr/>
         </p:nvSpPr>
@@ -6067,7 +5927,7 @@
       </p:sp>
       <p:sp>
         <p:nvSpPr>
-          <p:cNvPr id="17" name="Text 13"/>
+          <p:cNvPr id="15" name="Text 11"/>
           <p:cNvSpPr/>
           <p:nvPr/>
         </p:nvSpPr>
@@ -6120,7 +5980,7 @@
       </p:sp>
       <p:sp>
         <p:nvSpPr>
-          <p:cNvPr id="18" name="Text 14"/>
+          <p:cNvPr id="16" name="Text 12"/>
           <p:cNvSpPr/>
           <p:nvPr/>
         </p:nvSpPr>
@@ -6159,7 +6019,7 @@
       </p:sp>
       <p:sp>
         <p:nvSpPr>
-          <p:cNvPr id="19" name="Text 15"/>
+          <p:cNvPr id="17" name="Text 13"/>
           <p:cNvSpPr/>
           <p:nvPr/>
         </p:nvSpPr>
@@ -7111,29 +6971,9 @@
           <a:ln/>
         </p:spPr>
       </p:sp>
-      <p:sp>
-        <p:nvSpPr>
-          <p:cNvPr id="4" name="Shape 2"/>
-          <p:cNvSpPr/>
-          <p:nvPr/>
-        </p:nvSpPr>
-        <p:spPr>
-          <a:xfrm>
-            <a:off x="822960" y="1645920"/>
-            <a:ext cx="640080" cy="640080"/>
-          </a:xfrm>
-          <a:prstGeom prst="ellipse">
-            <a:avLst/>
-          </a:prstGeom>
-          <a:solidFill>
-            <a:srgbClr val="C8102E"/>
-          </a:solidFill>
-          <a:ln/>
-        </p:spPr>
-      </p:sp>
       <p:pic>
         <p:nvPicPr>
-          <p:cNvPr id="5" name="Image 0" descr="preencoded.png">    </p:cNvPr>
+          <p:cNvPr id="4" name="Image 0" descr="preencoded.png">    </p:cNvPr>
           <p:cNvPicPr>
             <a:picLocks noChangeAspect="1"/>
           </p:cNvPicPr>
@@ -7147,8 +6987,8 @@
         </p:blipFill>
         <p:spPr>
           <a:xfrm>
-            <a:off x="989381" y="1812341"/>
-            <a:ext cx="307238" cy="307238"/>
+            <a:off x="822960" y="1645920"/>
+            <a:ext cx="640080" cy="640080"/>
           </a:xfrm>
           <a:prstGeom prst="rect">
             <a:avLst/>
@@ -7157,7 +6997,7 @@
       </p:pic>
       <p:sp>
         <p:nvSpPr>
-          <p:cNvPr id="6" name="Text 3"/>
+          <p:cNvPr id="5" name="Text 2"/>
           <p:cNvSpPr/>
           <p:nvPr/>
         </p:nvSpPr>
@@ -7196,7 +7036,7 @@
       </p:sp>
       <p:sp>
         <p:nvSpPr>
-          <p:cNvPr id="7" name="Text 4"/>
+          <p:cNvPr id="6" name="Text 3"/>
           <p:cNvSpPr/>
           <p:nvPr/>
         </p:nvSpPr>
@@ -7235,7 +7075,7 @@
       </p:sp>
       <p:sp>
         <p:nvSpPr>
-          <p:cNvPr id="8" name="Text 5"/>
+          <p:cNvPr id="7" name="Text 4"/>
           <p:cNvSpPr/>
           <p:nvPr/>
         </p:nvSpPr>
@@ -7338,7 +7178,7 @@
       </p:sp>
       <p:sp>
         <p:nvSpPr>
-          <p:cNvPr id="9" name="Shape 6"/>
+          <p:cNvPr id="8" name="Shape 5"/>
           <p:cNvSpPr/>
           <p:nvPr/>
         </p:nvSpPr>
@@ -7358,29 +7198,9 @@
           <a:ln/>
         </p:spPr>
       </p:sp>
-      <p:sp>
-        <p:nvSpPr>
-          <p:cNvPr id="10" name="Shape 7"/>
-          <p:cNvSpPr/>
-          <p:nvPr/>
-        </p:nvSpPr>
-        <p:spPr>
-          <a:xfrm>
-            <a:off x="6492240" y="1645920"/>
-            <a:ext cx="640080" cy="640080"/>
-          </a:xfrm>
-          <a:prstGeom prst="ellipse">
-            <a:avLst/>
-          </a:prstGeom>
-          <a:solidFill>
-            <a:srgbClr val="C8102E"/>
-          </a:solidFill>
-          <a:ln/>
-        </p:spPr>
-      </p:sp>
       <p:pic>
         <p:nvPicPr>
-          <p:cNvPr id="11" name="Image 1" descr="preencoded.png">    </p:cNvPr>
+          <p:cNvPr id="9" name="Image 1" descr="preencoded.png">    </p:cNvPr>
           <p:cNvPicPr>
             <a:picLocks noChangeAspect="1"/>
           </p:cNvPicPr>
@@ -7394,8 +7214,8 @@
         </p:blipFill>
         <p:spPr>
           <a:xfrm>
-            <a:off x="6658661" y="1812341"/>
-            <a:ext cx="307238" cy="307238"/>
+            <a:off x="6492240" y="1645920"/>
+            <a:ext cx="640080" cy="640080"/>
           </a:xfrm>
           <a:prstGeom prst="rect">
             <a:avLst/>
@@ -7404,7 +7224,7 @@
       </p:pic>
       <p:sp>
         <p:nvSpPr>
-          <p:cNvPr id="12" name="Text 8"/>
+          <p:cNvPr id="10" name="Text 6"/>
           <p:cNvSpPr/>
           <p:nvPr/>
         </p:nvSpPr>
@@ -7443,7 +7263,7 @@
       </p:sp>
       <p:sp>
         <p:nvSpPr>
-          <p:cNvPr id="13" name="Text 9"/>
+          <p:cNvPr id="11" name="Text 7"/>
           <p:cNvSpPr/>
           <p:nvPr/>
         </p:nvSpPr>
@@ -7482,7 +7302,7 @@
       </p:sp>
       <p:sp>
         <p:nvSpPr>
-          <p:cNvPr id="14" name="Text 10"/>
+          <p:cNvPr id="12" name="Text 8"/>
           <p:cNvSpPr/>
           <p:nvPr/>
         </p:nvSpPr>
@@ -7585,7 +7405,7 @@
       </p:sp>
       <p:sp>
         <p:nvSpPr>
-          <p:cNvPr id="15" name="Shape 11"/>
+          <p:cNvPr id="13" name="Shape 9"/>
           <p:cNvSpPr/>
           <p:nvPr/>
         </p:nvSpPr>
@@ -7607,7 +7427,7 @@
       </p:sp>
       <p:sp>
         <p:nvSpPr>
-          <p:cNvPr id="16" name="Text 12"/>
+          <p:cNvPr id="14" name="Text 10"/>
           <p:cNvSpPr/>
           <p:nvPr/>
         </p:nvSpPr>
@@ -7660,7 +7480,7 @@
       </p:sp>
       <p:sp>
         <p:nvSpPr>
-          <p:cNvPr id="17" name="Text 13"/>
+          <p:cNvPr id="15" name="Text 11"/>
           <p:cNvSpPr/>
           <p:nvPr/>
         </p:nvSpPr>
@@ -7688,7 +7508,7 @@
       </p:sp>
       <p:sp>
         <p:nvSpPr>
-          <p:cNvPr id="18" name="Text 14"/>
+          <p:cNvPr id="16" name="Text 12"/>
           <p:cNvSpPr/>
           <p:nvPr/>
         </p:nvSpPr>
@@ -7857,29 +7677,9 @@
           <a:ln/>
         </p:spPr>
       </p:sp>
-      <p:sp>
-        <p:nvSpPr>
-          <p:cNvPr id="5" name="Shape 3"/>
-          <p:cNvSpPr/>
-          <p:nvPr/>
-        </p:nvSpPr>
-        <p:spPr>
-          <a:xfrm>
-            <a:off x="868680" y="2011680"/>
-            <a:ext cx="685800" cy="685800"/>
-          </a:xfrm>
-          <a:prstGeom prst="ellipse">
-            <a:avLst/>
-          </a:prstGeom>
-          <a:solidFill>
-            <a:srgbClr val="C8102E"/>
-          </a:solidFill>
-          <a:ln/>
-        </p:spPr>
-      </p:sp>
       <p:pic>
         <p:nvPicPr>
-          <p:cNvPr id="6" name="Image 0" descr="preencoded.png">    </p:cNvPr>
+          <p:cNvPr id="5" name="Image 0" descr="preencoded.png">    </p:cNvPr>
           <p:cNvPicPr>
             <a:picLocks noChangeAspect="1"/>
           </p:cNvPicPr>
@@ -7893,8 +7693,8 @@
         </p:blipFill>
         <p:spPr>
           <a:xfrm>
-            <a:off x="1046988" y="2189988"/>
-            <a:ext cx="329184" cy="329184"/>
+            <a:off x="868680" y="2011680"/>
+            <a:ext cx="685800" cy="685800"/>
           </a:xfrm>
           <a:prstGeom prst="rect">
             <a:avLst/>
@@ -7903,7 +7703,7 @@
       </p:pic>
       <p:sp>
         <p:nvSpPr>
-          <p:cNvPr id="7" name="Text 4"/>
+          <p:cNvPr id="6" name="Text 3"/>
           <p:cNvSpPr/>
           <p:nvPr/>
         </p:nvSpPr>
@@ -7942,7 +7742,7 @@
       </p:sp>
       <p:sp>
         <p:nvSpPr>
-          <p:cNvPr id="8" name="Text 5"/>
+          <p:cNvPr id="7" name="Text 4"/>
           <p:cNvSpPr/>
           <p:nvPr/>
         </p:nvSpPr>
@@ -7981,7 +7781,7 @@
       </p:sp>
       <p:sp>
         <p:nvSpPr>
-          <p:cNvPr id="9" name="Text 6"/>
+          <p:cNvPr id="8" name="Text 5"/>
           <p:cNvSpPr/>
           <p:nvPr/>
         </p:nvSpPr>
@@ -8020,7 +7820,7 @@
       </p:sp>
       <p:sp>
         <p:nvSpPr>
-          <p:cNvPr id="10" name="Shape 7"/>
+          <p:cNvPr id="9" name="Shape 6"/>
           <p:cNvSpPr/>
           <p:nvPr/>
         </p:nvSpPr>
@@ -8040,29 +7840,9 @@
           <a:ln/>
         </p:spPr>
       </p:sp>
-      <p:sp>
-        <p:nvSpPr>
-          <p:cNvPr id="11" name="Shape 8"/>
-          <p:cNvSpPr/>
-          <p:nvPr/>
-        </p:nvSpPr>
-        <p:spPr>
-          <a:xfrm>
-            <a:off x="4663440" y="2011680"/>
-            <a:ext cx="685800" cy="685800"/>
-          </a:xfrm>
-          <a:prstGeom prst="ellipse">
-            <a:avLst/>
-          </a:prstGeom>
-          <a:solidFill>
-            <a:srgbClr val="C8102E"/>
-          </a:solidFill>
-          <a:ln/>
-        </p:spPr>
-      </p:sp>
       <p:pic>
         <p:nvPicPr>
-          <p:cNvPr id="12" name="Image 1" descr="preencoded.png">    </p:cNvPr>
+          <p:cNvPr id="10" name="Image 1" descr="preencoded.png">    </p:cNvPr>
           <p:cNvPicPr>
             <a:picLocks noChangeAspect="1"/>
           </p:cNvPicPr>
@@ -8076,8 +7856,8 @@
         </p:blipFill>
         <p:spPr>
           <a:xfrm>
-            <a:off x="4841748" y="2189988"/>
-            <a:ext cx="329184" cy="329184"/>
+            <a:off x="4663440" y="2011680"/>
+            <a:ext cx="685800" cy="685800"/>
           </a:xfrm>
           <a:prstGeom prst="rect">
             <a:avLst/>
@@ -8086,7 +7866,7 @@
       </p:pic>
       <p:sp>
         <p:nvSpPr>
-          <p:cNvPr id="13" name="Text 9"/>
+          <p:cNvPr id="11" name="Text 7"/>
           <p:cNvSpPr/>
           <p:nvPr/>
         </p:nvSpPr>
@@ -8125,7 +7905,7 @@
       </p:sp>
       <p:sp>
         <p:nvSpPr>
-          <p:cNvPr id="14" name="Text 10"/>
+          <p:cNvPr id="12" name="Text 8"/>
           <p:cNvSpPr/>
           <p:nvPr/>
         </p:nvSpPr>
@@ -8164,7 +7944,7 @@
       </p:sp>
       <p:sp>
         <p:nvSpPr>
-          <p:cNvPr id="15" name="Text 11"/>
+          <p:cNvPr id="13" name="Text 9"/>
           <p:cNvSpPr/>
           <p:nvPr/>
         </p:nvSpPr>
@@ -8203,7 +7983,7 @@
       </p:sp>
       <p:sp>
         <p:nvSpPr>
-          <p:cNvPr id="16" name="Shape 12"/>
+          <p:cNvPr id="14" name="Shape 10"/>
           <p:cNvSpPr/>
           <p:nvPr/>
         </p:nvSpPr>
@@ -8223,29 +8003,9 @@
           <a:ln/>
         </p:spPr>
       </p:sp>
-      <p:sp>
-        <p:nvSpPr>
-          <p:cNvPr id="17" name="Shape 13"/>
-          <p:cNvSpPr/>
-          <p:nvPr/>
-        </p:nvSpPr>
-        <p:spPr>
-          <a:xfrm>
-            <a:off x="8458200" y="2011680"/>
-            <a:ext cx="685800" cy="685800"/>
-          </a:xfrm>
-          <a:prstGeom prst="ellipse">
-            <a:avLst/>
-          </a:prstGeom>
-          <a:solidFill>
-            <a:srgbClr val="C8102E"/>
-          </a:solidFill>
-          <a:ln/>
-        </p:spPr>
-      </p:sp>
       <p:pic>
         <p:nvPicPr>
-          <p:cNvPr id="18" name="Image 2" descr="preencoded.png">    </p:cNvPr>
+          <p:cNvPr id="15" name="Image 2" descr="preencoded.png">    </p:cNvPr>
           <p:cNvPicPr>
             <a:picLocks noChangeAspect="1"/>
           </p:cNvPicPr>
@@ -8259,8 +8019,8 @@
         </p:blipFill>
         <p:spPr>
           <a:xfrm>
-            <a:off x="8636508" y="2189988"/>
-            <a:ext cx="329184" cy="329184"/>
+            <a:off x="8458200" y="2011680"/>
+            <a:ext cx="685800" cy="685800"/>
           </a:xfrm>
           <a:prstGeom prst="rect">
             <a:avLst/>
@@ -8269,7 +8029,7 @@
       </p:pic>
       <p:sp>
         <p:nvSpPr>
-          <p:cNvPr id="19" name="Text 14"/>
+          <p:cNvPr id="16" name="Text 11"/>
           <p:cNvSpPr/>
           <p:nvPr/>
         </p:nvSpPr>
@@ -8308,7 +8068,7 @@
       </p:sp>
       <p:sp>
         <p:nvSpPr>
-          <p:cNvPr id="20" name="Text 15"/>
+          <p:cNvPr id="17" name="Text 12"/>
           <p:cNvSpPr/>
           <p:nvPr/>
         </p:nvSpPr>
@@ -8347,7 +8107,7 @@
       </p:sp>
       <p:sp>
         <p:nvSpPr>
-          <p:cNvPr id="21" name="Text 16"/>
+          <p:cNvPr id="18" name="Text 13"/>
           <p:cNvSpPr/>
           <p:nvPr/>
         </p:nvSpPr>
@@ -8386,7 +8146,7 @@
       </p:sp>
       <p:sp>
         <p:nvSpPr>
-          <p:cNvPr id="22" name="Text 17"/>
+          <p:cNvPr id="19" name="Text 14"/>
           <p:cNvSpPr/>
           <p:nvPr/>
         </p:nvSpPr>
@@ -8425,7 +8185,7 @@
       </p:sp>
       <p:sp>
         <p:nvSpPr>
-          <p:cNvPr id="23" name="Text 18"/>
+          <p:cNvPr id="20" name="Text 15"/>
           <p:cNvSpPr/>
           <p:nvPr/>
         </p:nvSpPr>
@@ -8555,29 +8315,9 @@
           <a:ln/>
         </p:spPr>
       </p:sp>
-      <p:sp>
-        <p:nvSpPr>
-          <p:cNvPr id="4" name="Shape 2"/>
-          <p:cNvSpPr/>
-          <p:nvPr/>
-        </p:nvSpPr>
-        <p:spPr>
-          <a:xfrm>
-            <a:off x="978408" y="1874520"/>
-            <a:ext cx="640080" cy="640080"/>
-          </a:xfrm>
-          <a:prstGeom prst="ellipse">
-            <a:avLst/>
-          </a:prstGeom>
-          <a:solidFill>
-            <a:srgbClr val="C8102E"/>
-          </a:solidFill>
-          <a:ln/>
-        </p:spPr>
-      </p:sp>
       <p:pic>
         <p:nvPicPr>
-          <p:cNvPr id="5" name="Image 0" descr="preencoded.png">    </p:cNvPr>
+          <p:cNvPr id="4" name="Image 0" descr="preencoded.png">    </p:cNvPr>
           <p:cNvPicPr>
             <a:picLocks noChangeAspect="1"/>
           </p:cNvPicPr>
@@ -8591,8 +8331,8 @@
         </p:blipFill>
         <p:spPr>
           <a:xfrm>
-            <a:off x="1144829" y="2040941"/>
-            <a:ext cx="307238" cy="307238"/>
+            <a:off x="978408" y="1874520"/>
+            <a:ext cx="640080" cy="640080"/>
           </a:xfrm>
           <a:prstGeom prst="rect">
             <a:avLst/>
@@ -8601,7 +8341,7 @@
       </p:pic>
       <p:sp>
         <p:nvSpPr>
-          <p:cNvPr id="6" name="Text 3"/>
+          <p:cNvPr id="5" name="Text 2"/>
           <p:cNvSpPr/>
           <p:nvPr/>
         </p:nvSpPr>
@@ -8640,7 +8380,7 @@
       </p:sp>
       <p:sp>
         <p:nvSpPr>
-          <p:cNvPr id="7" name="Text 4"/>
+          <p:cNvPr id="6" name="Text 3"/>
           <p:cNvSpPr/>
           <p:nvPr/>
         </p:nvSpPr>
@@ -8679,7 +8419,7 @@
       </p:sp>
       <p:sp>
         <p:nvSpPr>
-          <p:cNvPr id="8" name="Text 5"/>
+          <p:cNvPr id="7" name="Text 4"/>
           <p:cNvSpPr/>
           <p:nvPr/>
         </p:nvSpPr>
@@ -8710,7 +8450,7 @@
                 <a:ea typeface="Arial" pitchFamily="34" charset="-122"/>
                 <a:cs typeface="Arial" pitchFamily="34" charset="-120"/>
               </a:rPr>
-              <a:t>Close-rate window (trailing quarter), what counts as a scoped lead, attribution rules, and “collected” = funds received.</a:t>
+              <a:t>Cohorts: a lead belongs to the quarter it was scoped; its close counts whenever it funds, inside a 180-day window. Define scoped lead, attribution, and collected = funds received.</a:t>
             </a:r>
             <a:endParaRPr lang="en-US" sz="1250" dirty="0"/>
           </a:p>
@@ -8718,7 +8458,7 @@
       </p:sp>
       <p:sp>
         <p:nvSpPr>
-          <p:cNvPr id="9" name="Shape 6"/>
+          <p:cNvPr id="8" name="Shape 5"/>
           <p:cNvSpPr/>
           <p:nvPr/>
         </p:nvSpPr>
@@ -8738,29 +8478,9 @@
           <a:ln/>
         </p:spPr>
       </p:sp>
-      <p:sp>
-        <p:nvSpPr>
-          <p:cNvPr id="10" name="Shape 7"/>
-          <p:cNvSpPr/>
-          <p:nvPr/>
-        </p:nvSpPr>
-        <p:spPr>
-          <a:xfrm>
-            <a:off x="4727448" y="1874520"/>
-            <a:ext cx="640080" cy="640080"/>
-          </a:xfrm>
-          <a:prstGeom prst="ellipse">
-            <a:avLst/>
-          </a:prstGeom>
-          <a:solidFill>
-            <a:srgbClr val="C8102E"/>
-          </a:solidFill>
-          <a:ln/>
-        </p:spPr>
-      </p:sp>
       <p:pic>
         <p:nvPicPr>
-          <p:cNvPr id="11" name="Image 1" descr="preencoded.png">    </p:cNvPr>
+          <p:cNvPr id="9" name="Image 1" descr="preencoded.png">    </p:cNvPr>
           <p:cNvPicPr>
             <a:picLocks noChangeAspect="1"/>
           </p:cNvPicPr>
@@ -8774,8 +8494,8 @@
         </p:blipFill>
         <p:spPr>
           <a:xfrm>
-            <a:off x="4893869" y="2040941"/>
-            <a:ext cx="307238" cy="307238"/>
+            <a:off x="4727448" y="1874520"/>
+            <a:ext cx="640080" cy="640080"/>
           </a:xfrm>
           <a:prstGeom prst="rect">
             <a:avLst/>
@@ -8784,7 +8504,7 @@
       </p:pic>
       <p:sp>
         <p:nvSpPr>
-          <p:cNvPr id="12" name="Text 8"/>
+          <p:cNvPr id="10" name="Text 6"/>
           <p:cNvSpPr/>
           <p:nvPr/>
         </p:nvSpPr>
@@ -8823,7 +8543,7 @@
       </p:sp>
       <p:sp>
         <p:nvSpPr>
-          <p:cNvPr id="13" name="Text 9"/>
+          <p:cNvPr id="11" name="Text 7"/>
           <p:cNvSpPr/>
           <p:nvPr/>
         </p:nvSpPr>
@@ -8862,7 +8582,7 @@
       </p:sp>
       <p:sp>
         <p:nvSpPr>
-          <p:cNvPr id="14" name="Text 10"/>
+          <p:cNvPr id="12" name="Text 8"/>
           <p:cNvSpPr/>
           <p:nvPr/>
         </p:nvSpPr>
@@ -8901,7 +8621,7 @@
       </p:sp>
       <p:sp>
         <p:nvSpPr>
-          <p:cNvPr id="15" name="Shape 11"/>
+          <p:cNvPr id="13" name="Shape 9"/>
           <p:cNvSpPr/>
           <p:nvPr/>
         </p:nvSpPr>
@@ -8921,29 +8641,9 @@
           <a:ln/>
         </p:spPr>
       </p:sp>
-      <p:sp>
-        <p:nvSpPr>
-          <p:cNvPr id="16" name="Shape 12"/>
-          <p:cNvSpPr/>
-          <p:nvPr/>
-        </p:nvSpPr>
-        <p:spPr>
-          <a:xfrm>
-            <a:off x="8476488" y="1874520"/>
-            <a:ext cx="640080" cy="640080"/>
-          </a:xfrm>
-          <a:prstGeom prst="ellipse">
-            <a:avLst/>
-          </a:prstGeom>
-          <a:solidFill>
-            <a:srgbClr val="C8102E"/>
-          </a:solidFill>
-          <a:ln/>
-        </p:spPr>
-      </p:sp>
       <p:pic>
         <p:nvPicPr>
-          <p:cNvPr id="17" name="Image 2" descr="preencoded.png">    </p:cNvPr>
+          <p:cNvPr id="14" name="Image 2" descr="preencoded.png">    </p:cNvPr>
           <p:cNvPicPr>
             <a:picLocks noChangeAspect="1"/>
           </p:cNvPicPr>
@@ -8957,8 +8657,8 @@
         </p:blipFill>
         <p:spPr>
           <a:xfrm>
-            <a:off x="8642909" y="2040941"/>
-            <a:ext cx="307238" cy="307238"/>
+            <a:off x="8476488" y="1874520"/>
+            <a:ext cx="640080" cy="640080"/>
           </a:xfrm>
           <a:prstGeom prst="rect">
             <a:avLst/>
@@ -8967,7 +8667,7 @@
       </p:pic>
       <p:sp>
         <p:nvSpPr>
-          <p:cNvPr id="18" name="Text 13"/>
+          <p:cNvPr id="15" name="Text 10"/>
           <p:cNvSpPr/>
           <p:nvPr/>
         </p:nvSpPr>
@@ -9006,7 +8706,7 @@
       </p:sp>
       <p:sp>
         <p:nvSpPr>
-          <p:cNvPr id="19" name="Text 14"/>
+          <p:cNvPr id="16" name="Text 11"/>
           <p:cNvSpPr/>
           <p:nvPr/>
         </p:nvSpPr>
@@ -9045,7 +8745,7 @@
       </p:sp>
       <p:sp>
         <p:nvSpPr>
-          <p:cNvPr id="20" name="Text 15"/>
+          <p:cNvPr id="17" name="Text 12"/>
           <p:cNvSpPr/>
           <p:nvPr/>
         </p:nvSpPr>
@@ -9076,7 +8776,7 @@
                 <a:ea typeface="Arial" pitchFamily="34" charset="-122"/>
                 <a:cs typeface="Arial" pitchFamily="34" charset="-120"/>
               </a:rPr>
-              <a:t>2% floor paid as jobs fund; quarter-end true-up to the earned average rate. Six-month check: if the numbers say adjust the curve, adjust the curve.</a:t>
+              <a:t>2% floor paid as jobs fund; each quarter-end re-rates every open cohort and pays the difference. Six-month check: if the numbers say adjust the curve, adjust it.</a:t>
             </a:r>
             <a:endParaRPr lang="en-US" sz="1250" dirty="0"/>
           </a:p>
@@ -9084,7 +8784,7 @@
       </p:sp>
       <p:sp>
         <p:nvSpPr>
-          <p:cNvPr id="21" name="Text 16"/>
+          <p:cNvPr id="18" name="Text 13"/>
           <p:cNvSpPr/>
           <p:nvPr/>
         </p:nvSpPr>
@@ -9123,7 +8823,7 @@
       </p:sp>
       <p:sp>
         <p:nvSpPr>
-          <p:cNvPr id="22" name="Text 17"/>
+          <p:cNvPr id="19" name="Text 14"/>
           <p:cNvSpPr/>
           <p:nvPr/>
         </p:nvSpPr>

</xml_diff>

<commit_message>
Reframe pay plan as lead provision only; sync storm deck fee
The seat provides leads, not scopes: all RSOW/scope-writing language
replaced with damage-verified lead delivery and territory ops, the
comparison slide now benchmarks against lead sellers and paid ads, and
close rate = funded jobs / delivered leads (a lead a rep accepts onto
a route; raw map records excluded), cohort-assigned with a 180-day
window.

Storm Scout deck synced: the per-job waterfall now carries a
2%-of-profit lead fee ($210) instead of a 2% RCV scope fee, lifting
T^Rock's share to $5,145/job and Founding's break-even to 4.7 jobs/yr;
upside table recomputed.

Co-Authored-By: Claude Fable 5 <noreply@anthropic.com>
Claude-Session: https://claude.ai/code/session_01Qj1b2D7LVH4xves4mfA9FY
</commit_message>
<xml_diff>
--- a/pitch/Commission-Plan.pptx
+++ b/pitch/Commission-Plan.pptx
@@ -1594,7 +1594,7 @@
                 <a:ea typeface="Arial" pitchFamily="34" charset="-122"/>
                 <a:cs typeface="Arial" pitchFamily="34" charset="-120"/>
               </a:rPr>
-              <a:t>Scope writing &amp; lead operations — paid only on jobs that close and collect</a:t>
+              <a:t>Storm-targeted lead generation — paid only on jobs that close and collect</a:t>
             </a:r>
             <a:endParaRPr lang="en-US" sz="2200" dirty="0"/>
           </a:p>
@@ -1881,7 +1881,7 @@
                 <a:ea typeface="Arial" pitchFamily="34" charset="-122"/>
                 <a:cs typeface="Arial" pitchFamily="34" charset="-120"/>
               </a:rPr>
-              <a:t>Insurance-grade scope writing (RSOW)</a:t>
+              <a:t>Damage-verified lead lists</a:t>
             </a:r>
             <a:endParaRPr lang="en-US" sz="1600" dirty="0"/>
           </a:p>
@@ -1920,7 +1920,7 @@
                 <a:ea typeface="Arial" pitchFamily="34" charset="-122"/>
                 <a:cs typeface="Arial" pitchFamily="34" charset="-120"/>
               </a:rPr>
-              <a:t>Full restoration scopes of work per job — line items, quantities, code items — built to survive adjuster review and maximize approved RCV.</a:t>
+              <a:t>Storm-mapped, filter-qualified homeowners — owner-occupied, right roof age, right income band — handed to reps as ready-to-knock lists.</a:t>
             </a:r>
             <a:endParaRPr lang="en-US" sz="1200" dirty="0"/>
           </a:p>
@@ -2005,7 +2005,7 @@
                 <a:ea typeface="Arial" pitchFamily="34" charset="-122"/>
                 <a:cs typeface="Arial" pitchFamily="34" charset="-120"/>
               </a:rPr>
-              <a:t>Storm targeting &amp; lead operations</a:t>
+              <a:t>Storm response &amp; territory ops</a:t>
             </a:r>
             <a:endParaRPr lang="en-US" sz="1600" dirty="0"/>
           </a:p>
@@ -2044,7 +2044,7 @@
                 <a:ea typeface="Arial" pitchFamily="34" charset="-122"/>
                 <a:cs typeface="Arial" pitchFamily="34" charset="-120"/>
               </a:rPr>
-              <a:t>Runs the damage-map platform: territories, filtered knock lists, alert response. Reps knock verified-damage doors instead of guessing.</a:t>
+              <a:t>Runs the damage-map platform: alerts, territories, routed lists, outreach timing. Reps are on verified-damage doors while competitors are reading the weather.</a:t>
             </a:r>
             <a:endParaRPr lang="en-US" sz="1200" dirty="0"/>
           </a:p>
@@ -2292,7 +2292,7 @@
                 <a:ea typeface="Arial" pitchFamily="34" charset="-122"/>
                 <a:cs typeface="Arial" pitchFamily="34" charset="-120"/>
               </a:rPr>
-              <a:t>No base, no draw, no per-scope charge. If a job doesn't close and fund, the work was free. All of the risk sits on this side of the table.</a:t>
+              <a:t>No base, no draw, no per-lead charge. If a job doesn't close and fund, the lead was free. All of the risk sits on this side of the table.</a:t>
             </a:r>
             <a:endParaRPr lang="en-US" sz="1200" dirty="0"/>
           </a:p>
@@ -2469,7 +2469,7 @@
                 <a:ea typeface="Arial" pitchFamily="34" charset="-122"/>
                 <a:cs typeface="Arial" pitchFamily="34" charset="-120"/>
               </a:rPr>
-              <a:t>Fee = % of job profit on scoped jobs, booked as a job expense, paid only when closed AND collected. </a:t>
+              <a:t>Fee = % of job profit on jobs from provided leads, booked as a job expense, paid only when closed AND collected. </a:t>
             </a:r>
             <a:pPr indent="0" marL="0">
               <a:buNone/>
@@ -2483,7 +2483,7 @@
                 <a:ea typeface="Arial" pitchFamily="34" charset="-122"/>
                 <a:cs typeface="Arial" pitchFamily="34" charset="-120"/>
               </a:rPr>
-              <a:t>The % is set by the close rate on scoped leads, measured quarterly. </a:t>
+              <a:t>The % is set by the close rate on those leads, measured quarterly. </a:t>
             </a:r>
             <a:pPr indent="0" marL="0">
               <a:buNone/>
@@ -2551,7 +2551,7 @@
                           <a:ea typeface="Arial" pitchFamily="34" charset="-122"/>
                           <a:cs typeface="Arial" pitchFamily="34" charset="-120"/>
                         </a:rPr>
-                        <a:t>Per 10 scoped leads</a:t>
+                        <a:t>Per 10 delivered leads</a:t>
                       </a:r>
                       <a:endParaRPr lang="en-US" sz="1300" dirty="0">
                         <a:latin typeface="Arial" charset="0"/>
@@ -5422,7 +5422,7 @@
                 <a:ea typeface="Arial" pitchFamily="34" charset="-122"/>
                 <a:cs typeface="Arial" pitchFamily="34" charset="-120"/>
               </a:rPr>
-              <a:t>Typical job: $30,000 RCV at 50% margin = $15,000 profit; fee is a job expense, so profit after fee splits 50/50. Close rate is cohort-based — a lead belongs to the quarter it was scoped; late closers re-rate that cohort (180-day window), so the rate only moves up.</a:t>
+              <a:t>Typical job: $30,000 RCV at 50% margin = $15,000 profit; fee is a job expense, so profit after fee splits 50/50. Close rate is cohort-based — a lead belongs to the quarter it was delivered; late closers re-rate that cohort (180-day window), so the rate only moves up.</a:t>
             </a:r>
             <a:endParaRPr lang="en-US" sz="900" dirty="0"/>
           </a:p>
@@ -5734,7 +5734,7 @@
                 <a:ea typeface="Arial" pitchFamily="34" charset="-122"/>
                 <a:cs typeface="Arial" pitchFamily="34" charset="-120"/>
               </a:rPr>
-              <a:t>Of job profit — $300 on a typical roof. Scoped leads where most won't close; the fee collects on the few that do. At a 20% close rate, 8 of every 10 scopes were written for free.</a:t>
+              <a:t>Of job profit — $300 on a typical roof. Raw lead lists where most won't close; the fee collects on the few that do. At a 20% close rate, 8 of every 10 leads were handed over for free.</a:t>
             </a:r>
             <a:endParaRPr lang="en-US" sz="1250" dirty="0"/>
           </a:p>
@@ -6160,7 +6160,7 @@
                 <a:ea typeface="Arial" pitchFamily="34" charset="-122"/>
                 <a:cs typeface="Arial" pitchFamily="34" charset="-120"/>
               </a:rPr>
-              <a:t>Same 100 scoped leads, five close rates. The fee % rises — the pie rises much faster.</a:t>
+              <a:t>Same 100 delivered leads, five close rates. The fee % rises — the pie rises much faster.</a:t>
             </a:r>
             <a:endParaRPr lang="en-US" sz="1500" dirty="0"/>
           </a:p>
@@ -6199,7 +6199,7 @@
                 <a:ea typeface="Arial" pitchFamily="34" charset="-122"/>
                 <a:cs typeface="Arial" pitchFamily="34" charset="-120"/>
               </a:rPr>
-              <a:t>T^Rock net profit per 100 scoped leads  (after fee &amp; PM split)</a:t>
+              <a:t>T^Rock net profit per 100 delivered leads  (after fee &amp; PM split)</a:t>
             </a:r>
             <a:endParaRPr lang="en-US" sz="1400" dirty="0"/>
           </a:p>
@@ -6833,7 +6833,7 @@
                 <a:ea typeface="Arial" pitchFamily="34" charset="-122"/>
                 <a:cs typeface="Arial" pitchFamily="34" charset="-120"/>
               </a:rPr>
-              <a:t>Per closed job: $30,000 × 50% margin = $15,000, less slider fee (a job expense), split 50/50 with the PM. 100 scoped leads held constant.</a:t>
+              <a:t>Per closed job: $30,000 × 50% margin = $15,000, less slider fee (a job expense), split 50/50 with the PM. 100 delivered leads held constant.</a:t>
             </a:r>
             <a:endParaRPr lang="en-US" sz="900" dirty="0"/>
           </a:p>
@@ -7649,7 +7649,7 @@
                 <a:ea typeface="Arial" pitchFamily="34" charset="-122"/>
                 <a:cs typeface="Arial" pitchFamily="34" charset="-120"/>
               </a:rPr>
-              <a:t>Every other way to buy scope writing carries fixed cost or scales with paperwork. This one scales only with collected revenue.</a:t>
+              <a:t>Every other way to buy leads charges up front, win or lose. This one bills only against collected revenue.</a:t>
             </a:r>
             <a:endParaRPr lang="en-US" sz="1500" dirty="0"/>
           </a:p>
@@ -7734,7 +7734,7 @@
                 <a:ea typeface="Arial" pitchFamily="34" charset="-122"/>
                 <a:cs typeface="Arial" pitchFamily="34" charset="-120"/>
               </a:rPr>
-              <a:t>Staff estimator</a:t>
+              <a:t>Lead sellers</a:t>
             </a:r>
             <a:endParaRPr lang="en-US" sz="1500" dirty="0"/>
           </a:p>
@@ -7773,7 +7773,7 @@
                 <a:ea typeface="Arial" pitchFamily="34" charset="-122"/>
                 <a:cs typeface="Arial" pitchFamily="34" charset="-120"/>
               </a:rPr>
-              <a:t>$70–90k/yr</a:t>
+              <a:t>$150–300</a:t>
             </a:r>
             <a:endParaRPr lang="en-US" sz="4000" dirty="0"/>
           </a:p>
@@ -7812,7 +7812,7 @@
                 <a:ea typeface="Arial" pitchFamily="34" charset="-122"/>
                 <a:cs typeface="Arial" pitchFamily="34" charset="-120"/>
               </a:rPr>
-              <a:t>Salary paid whether jobs close or not. Pure fixed overhead, plus payroll burden — and someone still has to run lead targeting.</a:t>
+              <a:t>per shared Angi-style lead, paid up front whether it closes or not — and the same homeowner is resold to 3–4 competitors.</a:t>
             </a:r>
             <a:endParaRPr lang="en-US" sz="1200" dirty="0"/>
           </a:p>
@@ -7897,7 +7897,7 @@
                 <a:ea typeface="Arial" pitchFamily="34" charset="-122"/>
                 <a:cs typeface="Arial" pitchFamily="34" charset="-120"/>
               </a:rPr>
-              <a:t>Supplement service</a:t>
+              <a:t>Paid ads (Google / LSA)</a:t>
             </a:r>
             <a:endParaRPr lang="en-US" sz="1500" dirty="0"/>
           </a:p>
@@ -7936,7 +7936,7 @@
                 <a:ea typeface="Arial" pitchFamily="34" charset="-122"/>
                 <a:cs typeface="Arial" pitchFamily="34" charset="-120"/>
               </a:rPr>
-              <a:t>25–33%</a:t>
+              <a:t>$75–250</a:t>
             </a:r>
             <a:endParaRPr lang="en-US" sz="4000" dirty="0"/>
           </a:p>
@@ -7975,7 +7975,7 @@
                 <a:ea typeface="Arial" pitchFamily="34" charset="-122"/>
                 <a:cs typeface="Arial" pitchFamily="34" charset="-120"/>
               </a:rPr>
-              <a:t>of every supplement dollar they add — cost scales with paperwork volume, not with closed jobs, and they touch nothing else.</a:t>
+              <a:t>per inbound lead — spend is committed before anyone knocks, and quality swings wildly from click to click.</a:t>
             </a:r>
             <a:endParaRPr lang="en-US" sz="1200" dirty="0"/>
           </a:p>
@@ -8138,7 +8138,7 @@
                 <a:ea typeface="Arial" pitchFamily="34" charset="-122"/>
                 <a:cs typeface="Arial" pitchFamily="34" charset="-120"/>
               </a:rPr>
-              <a:t>until a job closes AND the check clears. Scope writing and lead operations in one seat, booked as a job cost on collected revenue.</a:t>
+              <a:t>until a job closes AND the check clears. Damage-verified, exclusive leads, billed as a job cost on collected revenue.</a:t>
             </a:r>
             <a:endParaRPr lang="en-US" sz="1200" dirty="0"/>
           </a:p>
@@ -8177,7 +8177,7 @@
                 <a:ea typeface="Arial" pitchFamily="34" charset="-122"/>
                 <a:cs typeface="Arial" pitchFamily="34" charset="-120"/>
               </a:rPr>
-              <a:t>Estimator salary and supplement-fee ranges are industry-typical figures for the region, not quotes.</a:t>
+              <a:t>Per-lead price ranges are typical published figures for roofing, not quotes.</a:t>
             </a:r>
             <a:endParaRPr lang="en-US" sz="900" dirty="0"/>
           </a:p>
@@ -8450,7 +8450,7 @@
                 <a:ea typeface="Arial" pitchFamily="34" charset="-122"/>
                 <a:cs typeface="Arial" pitchFamily="34" charset="-120"/>
               </a:rPr>
-              <a:t>Close rate = funded jobs ÷ scoped leads. A scoped lead = homeowner + written RSOW handed to a rep; raw map records don't count. A lead belongs to the quarter it was scoped (180-day window).</a:t>
+              <a:t>Close rate = funded jobs ÷ delivered leads. A delivered lead = homeowner + property accepted by a rep onto a route; raw map records don't count. A lead belongs to the quarter delivered (180-day window).</a:t>
             </a:r>
             <a:endParaRPr lang="en-US" sz="1250" dirty="0"/>
           </a:p>

</xml_diff>

<commit_message>
Sync commission plan to 35% margin
Both decks now run on the same job economics: $30,000 RCV at 35% =
$10,500 profit. Slider fees $210-$1,050 per closed job, T^Rock net
$5,145-$4,725/job, totals $10,290-$47,250 per 10 leads, per-100-leads
chart $102,900-$472,500, ceiling equals ~3.5% of contract (about a
third of the customary referral fee).

Co-Authored-By: Claude Fable 5 <noreply@anthropic.com>
Claude-Session: https://claude.ai/code/session_01Qj1b2D7LVH4xves4mfA9FY
</commit_message>
<xml_diff>
--- a/pitch/Commission-Plan.pptx
+++ b/pitch/Commission-Plan.pptx
@@ -3745,7 +3745,7 @@
                           <a:ea typeface="Arial" pitchFamily="34" charset="-122"/>
                           <a:cs typeface="Arial" pitchFamily="34" charset="-120"/>
                         </a:rPr>
-                        <a:t>Fee per closed job ($15,000 profit)</a:t>
+                        <a:t>Fee per closed job ($10,500 profit)</a:t>
                       </a:r>
                       <a:endParaRPr lang="en-US" sz="1200" dirty="0">
                         <a:latin typeface="Arial" charset="0"/>
@@ -3810,7 +3810,7 @@
                           <a:ea typeface="Arial" pitchFamily="34" charset="-122"/>
                           <a:cs typeface="Arial" pitchFamily="34" charset="-120"/>
                         </a:rPr>
-                        <a:t>$300</a:t>
+                        <a:t>$210</a:t>
                       </a:r>
                       <a:endParaRPr lang="en-US" sz="1250" dirty="0">
                         <a:latin typeface="Arial" charset="0"/>
@@ -3875,7 +3875,7 @@
                           <a:ea typeface="Arial" pitchFamily="34" charset="-122"/>
                           <a:cs typeface="Arial" pitchFamily="34" charset="-120"/>
                         </a:rPr>
-                        <a:t>$600</a:t>
+                        <a:t>$420</a:t>
                       </a:r>
                       <a:endParaRPr lang="en-US" sz="1250" dirty="0">
                         <a:latin typeface="Arial" charset="0"/>
@@ -3940,7 +3940,7 @@
                           <a:ea typeface="Arial" pitchFamily="34" charset="-122"/>
                           <a:cs typeface="Arial" pitchFamily="34" charset="-120"/>
                         </a:rPr>
-                        <a:t>$900</a:t>
+                        <a:t>$630</a:t>
                       </a:r>
                       <a:endParaRPr lang="en-US" sz="1250" dirty="0">
                         <a:latin typeface="Arial" charset="0"/>
@@ -4005,7 +4005,7 @@
                           <a:ea typeface="Arial" pitchFamily="34" charset="-122"/>
                           <a:cs typeface="Arial" pitchFamily="34" charset="-120"/>
                         </a:rPr>
-                        <a:t>$1,200</a:t>
+                        <a:t>$840</a:t>
                       </a:r>
                       <a:endParaRPr lang="en-US" sz="1250" dirty="0">
                         <a:latin typeface="Arial" charset="0"/>
@@ -4070,7 +4070,7 @@
                           <a:ea typeface="Arial" pitchFamily="34" charset="-122"/>
                           <a:cs typeface="Arial" pitchFamily="34" charset="-120"/>
                         </a:rPr>
-                        <a:t>$1,500</a:t>
+                        <a:t>$1,050</a:t>
                       </a:r>
                       <a:endParaRPr lang="en-US" sz="1250" dirty="0">
                         <a:latin typeface="Arial" charset="0"/>
@@ -4594,7 +4594,7 @@
                           <a:ea typeface="Arial" pitchFamily="34" charset="-122"/>
                           <a:cs typeface="Arial" pitchFamily="34" charset="-120"/>
                         </a:rPr>
-                        <a:t>$7,350</a:t>
+                        <a:t>$5,145</a:t>
                       </a:r>
                       <a:endParaRPr lang="en-US" sz="1250" dirty="0">
                         <a:latin typeface="Arial" charset="0"/>
@@ -4659,7 +4659,7 @@
                           <a:ea typeface="Arial" pitchFamily="34" charset="-122"/>
                           <a:cs typeface="Arial" pitchFamily="34" charset="-120"/>
                         </a:rPr>
-                        <a:t>$7,200</a:t>
+                        <a:t>$5,040</a:t>
                       </a:r>
                       <a:endParaRPr lang="en-US" sz="1250" dirty="0">
                         <a:latin typeface="Arial" charset="0"/>
@@ -4724,7 +4724,7 @@
                           <a:ea typeface="Arial" pitchFamily="34" charset="-122"/>
                           <a:cs typeface="Arial" pitchFamily="34" charset="-120"/>
                         </a:rPr>
-                        <a:t>$7,050</a:t>
+                        <a:t>$4,935</a:t>
                       </a:r>
                       <a:endParaRPr lang="en-US" sz="1250" dirty="0">
                         <a:latin typeface="Arial" charset="0"/>
@@ -4789,7 +4789,7 @@
                           <a:ea typeface="Arial" pitchFamily="34" charset="-122"/>
                           <a:cs typeface="Arial" pitchFamily="34" charset="-120"/>
                         </a:rPr>
-                        <a:t>$6,900</a:t>
+                        <a:t>$4,830</a:t>
                       </a:r>
                       <a:endParaRPr lang="en-US" sz="1250" dirty="0">
                         <a:latin typeface="Arial" charset="0"/>
@@ -4854,7 +4854,7 @@
                           <a:ea typeface="Arial" pitchFamily="34" charset="-122"/>
                           <a:cs typeface="Arial" pitchFamily="34" charset="-120"/>
                         </a:rPr>
-                        <a:t>$6,750</a:t>
+                        <a:t>$4,725</a:t>
                       </a:r>
                       <a:endParaRPr lang="en-US" sz="1250" dirty="0">
                         <a:latin typeface="Arial" charset="0"/>
@@ -4986,7 +4986,7 @@
                           <a:ea typeface="Arial" pitchFamily="34" charset="-122"/>
                           <a:cs typeface="Arial" pitchFamily="34" charset="-120"/>
                         </a:rPr>
-                        <a:t>$14,700</a:t>
+                        <a:t>$10,290</a:t>
                       </a:r>
                       <a:endParaRPr lang="en-US" sz="1300" dirty="0">
                         <a:latin typeface="Arial" charset="0"/>
@@ -5054,7 +5054,7 @@
                           <a:ea typeface="Arial" pitchFamily="34" charset="-122"/>
                           <a:cs typeface="Arial" pitchFamily="34" charset="-120"/>
                         </a:rPr>
-                        <a:t>$28,800</a:t>
+                        <a:t>$20,160</a:t>
                       </a:r>
                       <a:endParaRPr lang="en-US" sz="1300" dirty="0">
                         <a:latin typeface="Arial" charset="0"/>
@@ -5122,7 +5122,7 @@
                           <a:ea typeface="Arial" pitchFamily="34" charset="-122"/>
                           <a:cs typeface="Arial" pitchFamily="34" charset="-120"/>
                         </a:rPr>
-                        <a:t>$42,300</a:t>
+                        <a:t>$29,610</a:t>
                       </a:r>
                       <a:endParaRPr lang="en-US" sz="1300" dirty="0">
                         <a:latin typeface="Arial" charset="0"/>
@@ -5190,7 +5190,7 @@
                           <a:ea typeface="Arial" pitchFamily="34" charset="-122"/>
                           <a:cs typeface="Arial" pitchFamily="34" charset="-120"/>
                         </a:rPr>
-                        <a:t>$55,200</a:t>
+                        <a:t>$38,640</a:t>
                       </a:r>
                       <a:endParaRPr lang="en-US" sz="1300" dirty="0">
                         <a:latin typeface="Arial" charset="0"/>
@@ -5258,7 +5258,7 @@
                           <a:ea typeface="Arial" pitchFamily="34" charset="-122"/>
                           <a:cs typeface="Arial" pitchFamily="34" charset="-120"/>
                         </a:rPr>
-                        <a:t>$67,500</a:t>
+                        <a:t>$47,250</a:t>
                       </a:r>
                       <a:endParaRPr lang="en-US" sz="1300" dirty="0">
                         <a:latin typeface="Arial" charset="0"/>
@@ -5369,7 +5369,7 @@
                 <a:ea typeface="Arial" pitchFamily="34" charset="-122"/>
                 <a:cs typeface="Arial" pitchFamily="34" charset="-120"/>
               </a:rPr>
-              <a:t>The “expensive” end of the slider is the one where T^Rock banks $67,500 on 10 leads instead of $14,700. </a:t>
+              <a:t>The “expensive” end of the slider is the one where T^Rock banks $47,250 on 10 leads instead of $10,290. </a:t>
             </a:r>
             <a:pPr indent="0" marL="0">
               <a:buNone/>
@@ -5422,7 +5422,7 @@
                 <a:ea typeface="Arial" pitchFamily="34" charset="-122"/>
                 <a:cs typeface="Arial" pitchFamily="34" charset="-120"/>
               </a:rPr>
-              <a:t>Typical job: $30,000 RCV at 50% margin = $15,000 profit; fee is a job expense, so profit after fee splits 50/50. Close rate is cohort-based — a lead belongs to the quarter it was delivered; late closers re-rate that cohort (180-day window), so the rate only moves up.</a:t>
+              <a:t>Typical job: $30,000 RCV at 35% margin = $10,500 profit; fee is a job expense, so profit after fee splits 50/50. Close rate is cohort-based — a lead belongs to the quarter it was delivered; late closers re-rate that cohort (180-day window), so the rate only moves up.</a:t>
             </a:r>
             <a:endParaRPr lang="en-US" sz="900" dirty="0"/>
           </a:p>
@@ -5734,7 +5734,7 @@
                 <a:ea typeface="Arial" pitchFamily="34" charset="-122"/>
                 <a:cs typeface="Arial" pitchFamily="34" charset="-120"/>
               </a:rPr>
-              <a:t>Of job profit — $300 on a typical roof. Raw lead lists where most won't close; the fee collects on the few that do. At a 20% close rate, 8 of every 10 leads were handed over for free.</a:t>
+              <a:t>Of job profit — $210 on a typical roof. Raw lead lists where most won't close; the fee collects on the few that do. At a 20% close rate, 8 of every 10 leads were handed over for free.</a:t>
             </a:r>
             <a:endParaRPr lang="en-US" sz="1250" dirty="0"/>
           </a:p>
@@ -5897,7 +5897,7 @@
                 <a:ea typeface="Arial" pitchFamily="34" charset="-122"/>
                 <a:cs typeface="Arial" pitchFamily="34" charset="-120"/>
               </a:rPr>
-              <a:t>A lead that closes 100% of the time is a signed contract changing hands — a referral. The customary referral fee is ~10% of contract value; 10% of profit is $1,500 on a $30,000 roof — just 5% of contract. Half the going rate for a done deal.</a:t>
+              <a:t>A lead that closes 100% of the time is a signed contract changing hands — a referral. The customary referral fee is ~10% of contract value; 10% of profit is $1,050 on a $30,000 roof — just 3.5% of contract. A third of the going rate for a done deal.</a:t>
             </a:r>
             <a:endParaRPr lang="en-US" sz="1250" dirty="0"/>
           </a:p>
@@ -6011,7 +6011,7 @@
                 <a:ea typeface="Arial" pitchFamily="34" charset="-122"/>
                 <a:cs typeface="Arial" pitchFamily="34" charset="-120"/>
               </a:rPr>
-              <a:t>Referral benchmark: ~10% of contract value is the customary fee for handed-off, ready-to-sign work — this plan's ceiling works out to half that.</a:t>
+              <a:t>Referral benchmark: ~10% of contract value is the customary fee for handed-off, ready-to-sign work — this plan's ceiling works out to about a third of that.</a:t>
             </a:r>
             <a:endParaRPr lang="en-US" sz="900" dirty="0"/>
           </a:p>
@@ -6280,7 +6280,7 @@
                 <a:ea typeface="Arial" pitchFamily="34" charset="-122"/>
                 <a:cs typeface="Arial" pitchFamily="34" charset="-120"/>
               </a:rPr>
-              <a:t>$147,000</a:t>
+              <a:t>$102,900</a:t>
             </a:r>
             <a:endParaRPr lang="en-US" sz="1350" dirty="0"/>
           </a:p>
@@ -6380,7 +6380,7 @@
                 <a:ea typeface="Arial" pitchFamily="34" charset="-122"/>
                 <a:cs typeface="Arial" pitchFamily="34" charset="-120"/>
               </a:rPr>
-              <a:t>$288,000</a:t>
+              <a:t>$201,600</a:t>
             </a:r>
             <a:endParaRPr lang="en-US" sz="1350" dirty="0"/>
           </a:p>
@@ -6480,7 +6480,7 @@
                 <a:ea typeface="Arial" pitchFamily="34" charset="-122"/>
                 <a:cs typeface="Arial" pitchFamily="34" charset="-120"/>
               </a:rPr>
-              <a:t>$423,000</a:t>
+              <a:t>$296,100</a:t>
             </a:r>
             <a:endParaRPr lang="en-US" sz="1350" dirty="0"/>
           </a:p>
@@ -6580,7 +6580,7 @@
                 <a:ea typeface="Arial" pitchFamily="34" charset="-122"/>
                 <a:cs typeface="Arial" pitchFamily="34" charset="-120"/>
               </a:rPr>
-              <a:t>$552,000</a:t>
+              <a:t>$386,400</a:t>
             </a:r>
             <a:endParaRPr lang="en-US" sz="1350" dirty="0"/>
           </a:p>
@@ -6680,7 +6680,7 @@
                 <a:ea typeface="Arial" pitchFamily="34" charset="-122"/>
                 <a:cs typeface="Arial" pitchFamily="34" charset="-120"/>
               </a:rPr>
-              <a:t>$675,000</a:t>
+              <a:t>$472,500</a:t>
             </a:r>
             <a:endParaRPr lang="en-US" sz="1600" dirty="0"/>
           </a:p>
@@ -6833,7 +6833,7 @@
                 <a:ea typeface="Arial" pitchFamily="34" charset="-122"/>
                 <a:cs typeface="Arial" pitchFamily="34" charset="-120"/>
               </a:rPr>
-              <a:t>Per closed job: $30,000 × 50% margin = $15,000, less slider fee (a job expense), split 50/50 with the PM. 100 delivered leads held constant.</a:t>
+              <a:t>Per closed job: $30,000 × 35% margin = $10,500, less slider fee (a job expense), split 50/50 with the PM. 100 delivered leads held constant.</a:t>
             </a:r>
             <a:endParaRPr lang="en-US" sz="900" dirty="0"/>
           </a:p>
@@ -7131,7 +7131,7 @@
                 <a:ea typeface="Arial" pitchFamily="34" charset="-122"/>
                 <a:cs typeface="Arial" pitchFamily="34" charset="-120"/>
               </a:rPr>
-              <a:t>Worked example: $30,000 roof → $15,000 profit → 10% fee = $1,500 → $13,500 splits 50/50 → T^Rock nets $6,750</a:t>
+              <a:t>Worked example: $30,000 roof → $10,500 profit → 10% fee = $1,050 → $9,450 splits 50/50 → T^Rock nets $4,725</a:t>
             </a:r>
             <a:endParaRPr lang="en-US" sz="1250" dirty="0"/>
           </a:p>
@@ -7337,7 +7337,7 @@
                 <a:ea typeface="Arial" pitchFamily="34" charset="-122"/>
                 <a:cs typeface="Arial" pitchFamily="34" charset="-120"/>
               </a:rPr>
-              <a:t>Equivalent band at today's margins: 1% → 5% of contract value</a:t>
+              <a:t>Equivalent band at today's margins: 0.7% → 3.5% of contract value</a:t>
             </a:r>
             <a:endParaRPr lang="en-US" sz="1250" dirty="0"/>
           </a:p>

</xml_diff>

<commit_message>
Formatting hardening pass on both decks
No wording changes. Fixes text-clipping risk on tighter renderers:
taller heading and subtitle boxes, larger table header rows with
smaller header type, wider per-lead volume chips, slightly smaller
callout type with taller boxes, reduced hero-title sizes, and more
room for step-card bodies. Verified with a stress checker simulating
20% narrower text rendering plus a table-cell overflow checker.

Co-Authored-By: Claude Fable 5 <noreply@anthropic.com>
Claude-Session: https://claude.ai/code/session_01Qj1b2D7LVH4xves4mfA9FY
</commit_message>
<xml_diff>
--- a/pitch/Commission-Plan.pptx
+++ b/pitch/Commission-Plan.pptx
@@ -1547,7 +1547,7 @@
               <a:buNone/>
             </a:pPr>
             <a:r>
-              <a:rPr lang="en-US" sz="4400" b="1" dirty="0">
+              <a:rPr lang="en-US" sz="3600" b="1" dirty="0">
                 <a:solidFill>
                   <a:srgbClr val="FFFFFF"/>
                 </a:solidFill>
@@ -1557,7 +1557,7 @@
               </a:rPr>
               <a:t>T^ROCK PERFORMANCE PAY PLAN</a:t>
             </a:r>
-            <a:endParaRPr lang="en-US" sz="4400" dirty="0"/>
+            <a:endParaRPr lang="en-US" sz="3600" dirty="0"/>
           </a:p>
         </p:txBody>
       </p:sp>
@@ -1570,7 +1570,7 @@
         <p:spPr>
           <a:xfrm>
             <a:off x="713232" y="3200400"/>
-            <a:ext cx="10515600" cy="548640"/>
+            <a:ext cx="10515600" cy="914400"/>
           </a:xfrm>
           <a:prstGeom prst="rect">
             <a:avLst/>
@@ -1586,7 +1586,7 @@
               <a:buNone/>
             </a:pPr>
             <a:r>
-              <a:rPr lang="en-US" sz="2200" dirty="0">
+              <a:rPr lang="en-US" sz="2100" dirty="0">
                 <a:solidFill>
                   <a:srgbClr val="D9D9D9"/>
                 </a:solidFill>
@@ -1596,7 +1596,7 @@
               </a:rPr>
               <a:t>Storm-targeted lead generation — paid only on jobs that close and collect</a:t>
             </a:r>
-            <a:endParaRPr lang="en-US" sz="2200" dirty="0"/>
+            <a:endParaRPr lang="en-US" sz="2100" dirty="0"/>
           </a:p>
         </p:txBody>
       </p:sp>
@@ -1856,8 +1856,8 @@
         </p:nvSpPr>
         <p:spPr>
           <a:xfrm>
-            <a:off x="1645920" y="2084832"/>
-            <a:ext cx="4114800" cy="365760"/>
+            <a:off x="1645920" y="2048256"/>
+            <a:ext cx="4114800" cy="530352"/>
           </a:xfrm>
           <a:prstGeom prst="rect">
             <a:avLst/>
@@ -1873,7 +1873,7 @@
               <a:buNone/>
             </a:pPr>
             <a:r>
-              <a:rPr lang="en-US" sz="1600" b="1" dirty="0">
+              <a:rPr lang="en-US" sz="1500" b="1" dirty="0">
                 <a:solidFill>
                   <a:srgbClr val="111111"/>
                 </a:solidFill>
@@ -1883,7 +1883,7 @@
               </a:rPr>
               <a:t>Damage-verified lead lists</a:t>
             </a:r>
-            <a:endParaRPr lang="en-US" sz="1600" dirty="0"/>
+            <a:endParaRPr lang="en-US" sz="1500" dirty="0"/>
           </a:p>
         </p:txBody>
       </p:sp>
@@ -1895,8 +1895,8 @@
         </p:nvSpPr>
         <p:spPr>
           <a:xfrm>
-            <a:off x="1645920" y="2514600"/>
-            <a:ext cx="4114800" cy="1188720"/>
+            <a:off x="1645920" y="2633472"/>
+            <a:ext cx="4114800" cy="1115568"/>
           </a:xfrm>
           <a:prstGeom prst="rect">
             <a:avLst/>
@@ -1980,8 +1980,8 @@
         </p:nvSpPr>
         <p:spPr>
           <a:xfrm>
-            <a:off x="7315200" y="2084832"/>
-            <a:ext cx="4114800" cy="365760"/>
+            <a:off x="7315200" y="2048256"/>
+            <a:ext cx="4114800" cy="530352"/>
           </a:xfrm>
           <a:prstGeom prst="rect">
             <a:avLst/>
@@ -1997,7 +1997,7 @@
               <a:buNone/>
             </a:pPr>
             <a:r>
-              <a:rPr lang="en-US" sz="1600" b="1" dirty="0">
+              <a:rPr lang="en-US" sz="1500" b="1" dirty="0">
                 <a:solidFill>
                   <a:srgbClr val="111111"/>
                 </a:solidFill>
@@ -2007,7 +2007,7 @@
               </a:rPr>
               <a:t>Storm response &amp; territory ops</a:t>
             </a:r>
-            <a:endParaRPr lang="en-US" sz="1600" dirty="0"/>
+            <a:endParaRPr lang="en-US" sz="1500" dirty="0"/>
           </a:p>
         </p:txBody>
       </p:sp>
@@ -2019,8 +2019,8 @@
         </p:nvSpPr>
         <p:spPr>
           <a:xfrm>
-            <a:off x="7315200" y="2514600"/>
-            <a:ext cx="4114800" cy="1188720"/>
+            <a:off x="7315200" y="2633472"/>
+            <a:ext cx="4114800" cy="1115568"/>
           </a:xfrm>
           <a:prstGeom prst="rect">
             <a:avLst/>
@@ -2104,8 +2104,8 @@
         </p:nvSpPr>
         <p:spPr>
           <a:xfrm>
-            <a:off x="1645920" y="4279392"/>
-            <a:ext cx="4114800" cy="365760"/>
+            <a:off x="1645920" y="4242816"/>
+            <a:ext cx="4114800" cy="530352"/>
           </a:xfrm>
           <a:prstGeom prst="rect">
             <a:avLst/>
@@ -2121,7 +2121,7 @@
               <a:buNone/>
             </a:pPr>
             <a:r>
-              <a:rPr lang="en-US" sz="1600" b="1" dirty="0">
+              <a:rPr lang="en-US" sz="1500" b="1" dirty="0">
                 <a:solidFill>
                   <a:srgbClr val="111111"/>
                 </a:solidFill>
@@ -2131,7 +2131,7 @@
               </a:rPr>
               <a:t>Fee booked as a job cost</a:t>
             </a:r>
-            <a:endParaRPr lang="en-US" sz="1600" dirty="0"/>
+            <a:endParaRPr lang="en-US" sz="1500" dirty="0"/>
           </a:p>
         </p:txBody>
       </p:sp>
@@ -2143,8 +2143,8 @@
         </p:nvSpPr>
         <p:spPr>
           <a:xfrm>
-            <a:off x="1645920" y="4709160"/>
-            <a:ext cx="4114800" cy="1188720"/>
+            <a:off x="1645920" y="4828032"/>
+            <a:ext cx="4114800" cy="1115568"/>
           </a:xfrm>
           <a:prstGeom prst="rect">
             <a:avLst/>
@@ -2228,8 +2228,8 @@
         </p:nvSpPr>
         <p:spPr>
           <a:xfrm>
-            <a:off x="7315200" y="4279392"/>
-            <a:ext cx="4114800" cy="365760"/>
+            <a:off x="7315200" y="4242816"/>
+            <a:ext cx="4114800" cy="530352"/>
           </a:xfrm>
           <a:prstGeom prst="rect">
             <a:avLst/>
@@ -2245,7 +2245,7 @@
               <a:buNone/>
             </a:pPr>
             <a:r>
-              <a:rPr lang="en-US" sz="1600" b="1" dirty="0">
+              <a:rPr lang="en-US" sz="1500" b="1" dirty="0">
                 <a:solidFill>
                   <a:srgbClr val="111111"/>
                 </a:solidFill>
@@ -2255,7 +2255,7 @@
               </a:rPr>
               <a:t>Paid on collected, not promised</a:t>
             </a:r>
-            <a:endParaRPr lang="en-US" sz="1600" dirty="0"/>
+            <a:endParaRPr lang="en-US" sz="1500" dirty="0"/>
           </a:p>
         </p:txBody>
       </p:sp>
@@ -2267,8 +2267,8 @@
         </p:nvSpPr>
         <p:spPr>
           <a:xfrm>
-            <a:off x="7315200" y="4709160"/>
-            <a:ext cx="4114800" cy="1188720"/>
+            <a:off x="7315200" y="4828032"/>
+            <a:ext cx="4114800" cy="1115568"/>
           </a:xfrm>
           <a:prstGeom prst="rect">
             <a:avLst/>
@@ -2444,8 +2444,8 @@
         </p:nvSpPr>
         <p:spPr>
           <a:xfrm>
-            <a:off x="548640" y="1051560"/>
-            <a:ext cx="10881360" cy="685800"/>
+            <a:off x="548640" y="1024128"/>
+            <a:ext cx="10881360" cy="868680"/>
           </a:xfrm>
           <a:prstGeom prst="rect">
             <a:avLst/>
@@ -2461,7 +2461,7 @@
               <a:buNone/>
             </a:pPr>
             <a:r>
-              <a:rPr lang="en-US" sz="1400" b="1" dirty="0">
+              <a:rPr lang="en-US" sz="1300" b="1" dirty="0">
                 <a:solidFill>
                   <a:srgbClr val="2A2A2A"/>
                 </a:solidFill>
@@ -2475,7 +2475,7 @@
               <a:buNone/>
             </a:pPr>
             <a:r>
-              <a:rPr lang="en-US" sz="1400" dirty="0">
+              <a:rPr lang="en-US" sz="1300" dirty="0">
                 <a:solidFill>
                   <a:srgbClr val="6E6E6E"/>
                 </a:solidFill>
@@ -2489,7 +2489,7 @@
               <a:buNone/>
             </a:pPr>
             <a:r>
-              <a:rPr lang="en-US" sz="1400" b="1" dirty="0">
+              <a:rPr lang="en-US" sz="1300" b="1" dirty="0">
                 <a:solidFill>
                   <a:srgbClr val="C8102E"/>
                 </a:solidFill>
@@ -2499,7 +2499,7 @@
               </a:rPr>
               <a:t>Cash flow: the 2% floor is paid as each job funds; quarter-end reconciliation trues up to the earned average rate — T^Rock never prepays a rate, and nothing is ever clawed back.</a:t>
             </a:r>
-            <a:endParaRPr lang="en-US" sz="1400" dirty="0"/>
+            <a:endParaRPr lang="en-US" sz="1300" dirty="0"/>
           </a:p>
         </p:txBody>
       </p:sp>
@@ -2518,7 +2518,7 @@
           </p:nvPr>
         </p:nvGraphicFramePr>
         <p:xfrm>
-          <a:off x="548640" y="1874520"/>
+          <a:off x="548640" y="1920240"/>
           <a:ext cx="11064240" cy="914400"/>
         </p:xfrm>
         <a:graphic>
@@ -2533,7 +2533,7 @@
                 <a:gridCol w="1463040"/>
                 <a:gridCol w="1737360"/>
               </a:tblGrid>
-              <a:tr h="365760">
+              <a:tr h="457200">
                 <a:tc>
                   <a:txBody>
                     <a:bodyPr/>
@@ -2543,7 +2543,7 @@
                         <a:buNone/>
                       </a:pPr>
                       <a:r>
-                        <a:rPr lang="en-US" sz="1300" b="1" dirty="0">
+                        <a:rPr lang="en-US" sz="1200" b="1" dirty="0">
                           <a:solidFill>
                             <a:srgbClr val="FFFFFF"/>
                           </a:solidFill>
@@ -2553,7 +2553,7 @@
                         </a:rPr>
                         <a:t>Per 10 delivered leads</a:t>
                       </a:r>
-                      <a:endParaRPr lang="en-US" sz="1300" dirty="0">
+                      <a:endParaRPr lang="en-US" sz="1200" dirty="0">
                         <a:latin typeface="Arial" charset="0"/>
                         <a:ea typeface="Arial" charset="0"/>
                         <a:cs typeface="Arial" charset="0"/>
@@ -2611,7 +2611,7 @@
                         <a:buNone/>
                       </a:pPr>
                       <a:r>
-                        <a:rPr lang="en-US" sz="1300" b="1" dirty="0">
+                        <a:rPr lang="en-US" sz="1200" b="1" dirty="0">
                           <a:solidFill>
                             <a:srgbClr val="FFFFFF"/>
                           </a:solidFill>
@@ -2621,7 +2621,7 @@
                         </a:rPr>
                         <a:t>20% close (floor)</a:t>
                       </a:r>
-                      <a:endParaRPr lang="en-US" sz="1300" dirty="0">
+                      <a:endParaRPr lang="en-US" sz="1200" dirty="0">
                         <a:latin typeface="Arial" charset="0"/>
                         <a:ea typeface="Arial" charset="0"/>
                         <a:cs typeface="Arial" charset="0"/>
@@ -2679,7 +2679,7 @@
                         <a:buNone/>
                       </a:pPr>
                       <a:r>
-                        <a:rPr lang="en-US" sz="1300" b="1" dirty="0">
+                        <a:rPr lang="en-US" sz="1200" b="1" dirty="0">
                           <a:solidFill>
                             <a:srgbClr val="FFFFFF"/>
                           </a:solidFill>
@@ -2689,7 +2689,7 @@
                         </a:rPr>
                         <a:t>40%</a:t>
                       </a:r>
-                      <a:endParaRPr lang="en-US" sz="1300" dirty="0">
+                      <a:endParaRPr lang="en-US" sz="1200" dirty="0">
                         <a:latin typeface="Arial" charset="0"/>
                         <a:ea typeface="Arial" charset="0"/>
                         <a:cs typeface="Arial" charset="0"/>
@@ -2747,7 +2747,7 @@
                         <a:buNone/>
                       </a:pPr>
                       <a:r>
-                        <a:rPr lang="en-US" sz="1300" b="1" dirty="0">
+                        <a:rPr lang="en-US" sz="1200" b="1" dirty="0">
                           <a:solidFill>
                             <a:srgbClr val="FFFFFF"/>
                           </a:solidFill>
@@ -2757,7 +2757,7 @@
                         </a:rPr>
                         <a:t>60%</a:t>
                       </a:r>
-                      <a:endParaRPr lang="en-US" sz="1300" dirty="0">
+                      <a:endParaRPr lang="en-US" sz="1200" dirty="0">
                         <a:latin typeface="Arial" charset="0"/>
                         <a:ea typeface="Arial" charset="0"/>
                         <a:cs typeface="Arial" charset="0"/>
@@ -2815,7 +2815,7 @@
                         <a:buNone/>
                       </a:pPr>
                       <a:r>
-                        <a:rPr lang="en-US" sz="1300" b="1" dirty="0">
+                        <a:rPr lang="en-US" sz="1200" b="1" dirty="0">
                           <a:solidFill>
                             <a:srgbClr val="FFFFFF"/>
                           </a:solidFill>
@@ -2825,7 +2825,7 @@
                         </a:rPr>
                         <a:t>80%</a:t>
                       </a:r>
-                      <a:endParaRPr lang="en-US" sz="1300" dirty="0">
+                      <a:endParaRPr lang="en-US" sz="1200" dirty="0">
                         <a:latin typeface="Arial" charset="0"/>
                         <a:ea typeface="Arial" charset="0"/>
                         <a:cs typeface="Arial" charset="0"/>
@@ -2883,7 +2883,7 @@
                         <a:buNone/>
                       </a:pPr>
                       <a:r>
-                        <a:rPr lang="en-US" sz="1300" b="1" dirty="0">
+                        <a:rPr lang="en-US" sz="1200" b="1" dirty="0">
                           <a:solidFill>
                             <a:srgbClr val="FFFFFF"/>
                           </a:solidFill>
@@ -2893,7 +2893,7 @@
                         </a:rPr>
                         <a:t>100% (ceiling)</a:t>
                       </a:r>
-                      <a:endParaRPr lang="en-US" sz="1300" dirty="0">
+                      <a:endParaRPr lang="en-US" sz="1200" dirty="0">
                         <a:latin typeface="Arial" charset="0"/>
                         <a:ea typeface="Arial" charset="0"/>
                         <a:cs typeface="Arial" charset="0"/>
@@ -7625,7 +7625,7 @@
         <p:spPr>
           <a:xfrm>
             <a:off x="548640" y="1097280"/>
-            <a:ext cx="10881360" cy="365760"/>
+            <a:ext cx="10881360" cy="502920"/>
           </a:xfrm>
           <a:prstGeom prst="rect">
             <a:avLst/>
@@ -7709,8 +7709,8 @@
         </p:nvSpPr>
         <p:spPr>
           <a:xfrm>
-            <a:off x="1691640" y="2194560"/>
-            <a:ext cx="2286000" cy="365760"/>
+            <a:off x="1691640" y="2121408"/>
+            <a:ext cx="2286000" cy="566928"/>
           </a:xfrm>
           <a:prstGeom prst="rect">
             <a:avLst/>
@@ -7726,7 +7726,7 @@
               <a:buNone/>
             </a:pPr>
             <a:r>
-              <a:rPr lang="en-US" sz="1500" b="1" dirty="0">
+              <a:rPr lang="en-US" sz="1400" b="1" dirty="0">
                 <a:solidFill>
                   <a:srgbClr val="111111"/>
                 </a:solidFill>
@@ -7736,7 +7736,7 @@
               </a:rPr>
               <a:t>Lead sellers</a:t>
             </a:r>
-            <a:endParaRPr lang="en-US" sz="1500" dirty="0"/>
+            <a:endParaRPr lang="en-US" sz="1400" dirty="0"/>
           </a:p>
         </p:txBody>
       </p:sp>
@@ -7872,8 +7872,8 @@
         </p:nvSpPr>
         <p:spPr>
           <a:xfrm>
-            <a:off x="5486400" y="2194560"/>
-            <a:ext cx="2286000" cy="365760"/>
+            <a:off x="5486400" y="2121408"/>
+            <a:ext cx="2286000" cy="566928"/>
           </a:xfrm>
           <a:prstGeom prst="rect">
             <a:avLst/>
@@ -7889,7 +7889,7 @@
               <a:buNone/>
             </a:pPr>
             <a:r>
-              <a:rPr lang="en-US" sz="1500" b="1" dirty="0">
+              <a:rPr lang="en-US" sz="1400" b="1" dirty="0">
                 <a:solidFill>
                   <a:srgbClr val="111111"/>
                 </a:solidFill>
@@ -7899,7 +7899,7 @@
               </a:rPr>
               <a:t>Paid ads (Google / LSA)</a:t>
             </a:r>
-            <a:endParaRPr lang="en-US" sz="1500" dirty="0"/>
+            <a:endParaRPr lang="en-US" sz="1400" dirty="0"/>
           </a:p>
         </p:txBody>
       </p:sp>
@@ -8035,8 +8035,8 @@
         </p:nvSpPr>
         <p:spPr>
           <a:xfrm>
-            <a:off x="9281160" y="2194560"/>
-            <a:ext cx="2286000" cy="365760"/>
+            <a:off x="9281160" y="2121408"/>
+            <a:ext cx="2286000" cy="566928"/>
           </a:xfrm>
           <a:prstGeom prst="rect">
             <a:avLst/>
@@ -8052,7 +8052,7 @@
               <a:buNone/>
             </a:pPr>
             <a:r>
-              <a:rPr lang="en-US" sz="1500" b="1" dirty="0">
+              <a:rPr lang="en-US" sz="1400" b="1" dirty="0">
                 <a:solidFill>
                   <a:srgbClr val="FFFFFF"/>
                 </a:solidFill>
@@ -8062,7 +8062,7 @@
               </a:rPr>
               <a:t>This plan</a:t>
             </a:r>
-            <a:endParaRPr lang="en-US" sz="1500" dirty="0"/>
+            <a:endParaRPr lang="en-US" sz="1400" dirty="0"/>
           </a:p>
         </p:txBody>
       </p:sp>
@@ -8426,7 +8426,7 @@
         <p:spPr>
           <a:xfrm>
             <a:off x="978408" y="3383280"/>
-            <a:ext cx="2926080" cy="1280160"/>
+            <a:ext cx="2926080" cy="1298448"/>
           </a:xfrm>
           <a:prstGeom prst="rect">
             <a:avLst/>
@@ -8442,7 +8442,7 @@
               <a:buNone/>
             </a:pPr>
             <a:r>
-              <a:rPr lang="en-US" sz="1250" dirty="0">
+              <a:rPr lang="en-US" sz="1150" dirty="0">
                 <a:solidFill>
                   <a:srgbClr val="CFCFCF"/>
                 </a:solidFill>
@@ -8452,7 +8452,7 @@
               </a:rPr>
               <a:t>Close rate = funded jobs ÷ delivered leads. A delivered lead = homeowner + property accepted by a rep onto a route; raw map records don't count. A lead belongs to the quarter delivered (180-day window).</a:t>
             </a:r>
-            <a:endParaRPr lang="en-US" sz="1250" dirty="0"/>
+            <a:endParaRPr lang="en-US" sz="1150" dirty="0"/>
           </a:p>
         </p:txBody>
       </p:sp>
@@ -8589,7 +8589,7 @@
         <p:spPr>
           <a:xfrm>
             <a:off x="4727448" y="3383280"/>
-            <a:ext cx="2926080" cy="1280160"/>
+            <a:ext cx="2926080" cy="1298448"/>
           </a:xfrm>
           <a:prstGeom prst="rect">
             <a:avLst/>
@@ -8605,7 +8605,7 @@
               <a:buNone/>
             </a:pPr>
             <a:r>
-              <a:rPr lang="en-US" sz="1250" dirty="0">
+              <a:rPr lang="en-US" sz="1150" dirty="0">
                 <a:solidFill>
                   <a:srgbClr val="CFCFCF"/>
                 </a:solidFill>
@@ -8615,7 +8615,7 @@
               </a:rPr>
               <a:t>Option A (% of job profit, splits like a job cost) or Option B (% of RCV). One page, signed, with the slider table attached.</a:t>
             </a:r>
-            <a:endParaRPr lang="en-US" sz="1250" dirty="0"/>
+            <a:endParaRPr lang="en-US" sz="1150" dirty="0"/>
           </a:p>
         </p:txBody>
       </p:sp>
@@ -8752,7 +8752,7 @@
         <p:spPr>
           <a:xfrm>
             <a:off x="8476488" y="3383280"/>
-            <a:ext cx="2926080" cy="1280160"/>
+            <a:ext cx="2926080" cy="1298448"/>
           </a:xfrm>
           <a:prstGeom prst="rect">
             <a:avLst/>
@@ -8768,7 +8768,7 @@
               <a:buNone/>
             </a:pPr>
             <a:r>
-              <a:rPr lang="en-US" sz="1250" dirty="0">
+              <a:rPr lang="en-US" sz="1150" dirty="0">
                 <a:solidFill>
                   <a:srgbClr val="CFCFCF"/>
                 </a:solidFill>
@@ -8778,7 +8778,7 @@
               </a:rPr>
               <a:t>2% floor paid as jobs fund; each quarter-end re-rates every open cohort and pays the difference. Six-month check: if the numbers say adjust the curve, adjust it.</a:t>
             </a:r>
-            <a:endParaRPr lang="en-US" sz="1250" dirty="0"/>
+            <a:endParaRPr lang="en-US" sz="1150" dirty="0"/>
           </a:p>
         </p:txBody>
       </p:sp>

</xml_diff>